<commit_message>
Slides: full speaking scripts in speaker notes (timing cues, supplementary numbers, anticipated Q&A)
Co-Authored-By: Claude Opus 5.5 (1M context) <noreply@anthropic.com>
</commit_message>
<xml_diff>
--- a/results/progress_slides_2026-09.pptx
+++ b/results/progress_slides_2026-09.pptx
@@ -509,7 +509,12 @@
           <a:p>
             <a:r>
               <a:rPr lang="en-US" dirty="0"/>
-              <a:t>今日は卒論の進捗を5分ほどで報告します。結論から言うと、実験はほぼ揃っていて、今は評価の数値を正しく計算し直している段階です。</a:t>
+              <a:t>【台本】
+よろしくお願いします。卒論の進捗を報告します。
+タイトルは「ASR損失で学習した喉マイク音声強調の効果と汎化範囲」です。
+今日の話は3つです。1つ目は、今やっている実験で何がわかったか。2つ目は、それを踏まえて、今のやり方を提案手法として押すのは正直行き詰まっている、という現状の評価。3つ目は、その先の方向について相談したいことです。
+先に結論を言うと、卒論に必要な実験はほぼ揃っていて、論文も4ページの形になっています。ただ、途中で評価の方法に問題を見つけたので、数字を全部計算し直しました。その話も正直にします。
+（目安：30秒）</a:t>
             </a:r>
             <a:endParaRPr lang="en-US" dirty="0"/>
           </a:p>
@@ -597,7 +602,13 @@
           <a:p>
             <a:r>
               <a:rPr lang="en-US" dirty="0"/>
-              <a:t>予備実験でWhisperのFTが強いことはわかっていますが、SEはどのASRにもつなげられるのが利点なので、SE側を改善する方針です。今回はSEをWhisperの損失で直接学習させました。問題は、その改善が学習に使っていないASRにも通用するかどうかです。</a:t>
+              <a:t>【台本】
+まず問いと手法です。
+（左側を指して）喉マイクは、喉の振動を直接拾うので騒音に強いのが利点です。ただ、今使っているTAPSという韓国語のデータセットでは、喉マイクの音は4kHz以上がもともと入っていません。そのため、普通の音声認識にかけると精度がかなり落ちます。
+これを改善する方法は大きく2つあります。音声認識モデルそのものを喉マイクに合わせて学習し直すファインチューニングと、音声認識の前に音をきれいにする音声強調、SEです。精度だけならファインチューニングの方が強いことは予備実験でわかっています。それでもSEに注目しているのは、SEは前処理なので、どの音声認識にもつなげられるという利点があるからです。
+（右側を指して）そこで今回は、TAPSの論文で公開されているSE-Conformerというモデルを、凍結したWhisper-smallの損失で追加学習しました。つまり「Whisperが正しく書き起こせる音」を出すようにSEを学習させています。
+（問いを指して）問いは、こうやってASRの損失で学習したSEの改善が、学習に使っていない別のASRにも通用するのか、です。SEの利点が「どのASRにもつなげられること」なので、ここが本質的な問いだと考えています。
+（目安：1分15秒）</a:t>
             </a:r>
             <a:endParaRPr lang="en-US" dirty="0"/>
           </a:p>
@@ -685,7 +696,15 @@
           <a:p>
             <a:r>
               <a:rPr lang="en-US" dirty="0"/>
-              <a:t>ASR損失の中身です。SEの出力を凍結したWhisper-smallに入れ、正解テキストを1トークンずつ当てさせます。Whisperが正しく書き起こしやすい音ほど損失が小さくなります。Whisperの重みは固定で、勾配はWhisperを通り抜けてSEだけを更新します。音が崩れすぎないよう、気導音声との差を測る再構成損失も足しています。この仕組みだと、SEはWhisper専用に最適化されます。</a:t>
+              <a:t>【台本】
+ASR損失の仕組みをもう少し詳しく説明します。
+（上の図を左から指して）喉マイクの音をSEに入れて、出てきた強調音声をメルスペクトログラムに変換し、Whisper-smallに入れます。Whisperは、各トークンの予測確率を出します。
+（真ん中のカードを指して）ここでCE損失、交差エントロピー損失を計算します。正解テキストをWhisperのトークン列にして、1つ前までの正解を与えたうえで、次のトークンを当てさせます。正解のトークンに高い確率を出せるほど損失は小さくなります。つまり、Whisperが正しく書き起こしやすい音ほど損失が小さい、という損失です。
+（右のカードを指して）大事なのは、Whisperの重みは固定していて、更新するのはSEだけという点です。勾配はWhisperを通り抜けてSEまで戻ります。
+（左のカードを指して）ASRの損失だけだと音が崩れてしまうので、同時に録った気導マイクの音との差、再構成損失も足しています。元のTAPSのSEはこの再構成損失だけで学習されています。
+（下の式を指して）この2つを、重みλで足し合わせたものが全体の損失です。λは開発用データで選びました。
+この仕組みだと、SEはWhisperという特定のモデルに合わせて最適化されます。これが次のスライドの結果につながります。
+（目安：1分15秒）</a:t>
             </a:r>
             <a:endParaRPr lang="en-US" dirty="0"/>
           </a:p>
@@ -773,7 +792,14 @@
           <a:p>
             <a:r>
               <a:rPr lang="en-US" dirty="0"/>
-              <a:t>細かい数字は省いて傾向だけ話します。学習に使ったWhisperでは改善し、10人の話者全員で改善しました。Whisper-mediumにも効きますが、baseでは差がはっきりしません。ところがwav2vec2系のASRでは改善しません。XLS-Rでははっきり悪化し、MMSではほぼ変わりませんでした。改善の一部は、正解テキストに句読点がないせいでWhisperが句読点を出さなくなっただけで、評価の句読点をそろえると改善は小さくなりますが、残ります。音としての品質指標は下がっていて、気導音声に近づけるのではなく、Whisperが読みやすい音を作っていることがわかりました。</a:t>
+              <a:t>【台本】
+わかったことです。細かい数字は省いて、傾向だけお話しします。
+（1行目）まず、学習に使ったWhisper-smallでは、CERは確かに改善しました。テスト用の10話者全員で改善しています。同じWhisper系列のmediumにも改善は持ち越されましたが、小さいbaseでははっきりした差が出ませんでした。
+（2行目）一方で、Whisperとは作りが違うwav2vec2系の音声認識では改善しませんでした。XLS-Rでははっきり悪化し、MMSではほぼ変わりませんでした。
+（3行目）それから、評価の途中で問題を見つけました。TAPSの正解テキストには句読点がないのですが、Whisperは普通、文末に句点を付けます。ASR損失で学習すると、SEはWhisperが句読点を出さなくなるような音を作るようになっていました。評価で句読点をそろえていなかったので、その分が改善として数えられていました。句読点をそろえて計算し直すと改善は小さくなりますが、それでも残ります。
+（4行目）最後に、STOIやPESQといった音の品質の指標は、むしろ下がっていました。つまり、気導マイクらしい自然な音に近づけているのではなく、Whisperが読みやすい別の音を作っている、ということです。
+（補足：聞かれたら）句読点をそろえたCERで、Whisper-smallはTAPSのSEの0.230から0.196、15%の改善です。改善幅のうち約3分の1が句読点によるものでした。XLS-Rは約26%悪化しています。
+（目安：1分30秒）</a:t>
             </a:r>
             <a:endParaRPr lang="en-US" dirty="0"/>
           </a:p>
@@ -861,7 +887,17 @@
           <a:p>
             <a:r>
               <a:rPr lang="en-US" dirty="0"/>
-              <a:t>正直な評価として、この手法を提案手法として押す方向は行き詰まっていると考えています。理由は3つです。まず、凍結したWhisperの損失で前処理を学習する手法には先行研究があります。次に、Whisperに特化するなら、Whisper自体をファインチューニングするほうが精度が上です。そして、SEの唯一の長所である「どのASRにも使える」ことを、ASR損失で学習すると失ってしまいます。λや損失を工夫しても、この構造は変わらないと思います。</a:t>
+              <a:t>【台本】
+ここからが、正直な現状の評価です。
+この手法を「提案手法」として押す方向は、行き詰まっていると考えています。理由は3つあります。
+（左のカード）1つ目は、新しさが小さいことです。凍結したWhisperの損失で前処理を学習する手法は、2024年のInterspeechで、Dissenらがすでに発表しています。
+（真ん中のカード）2つ目は、精度でファインチューニングに届かないことです。Whisperに特化するのであれば、Whisper自体を喉マイクに合わせてファインチューニングする方が、明らかに精度が高いです。
+（右のカード）3つ目が一番大きくて、SEの長所を失うことです。SEの売りは、どのASRにもつなげられることでした。ところがASR損失で学習すると、さっきの結果のとおり、他の系列のASRでは効かなくなります。
+（下の文）まとめると、「Whisper用ならファインチューニング、汎用ならもともとのTAPSのSE」で済んでしまって、この手法の居場所がありません。損失の重みを変えたり損失を工夫したりしても、この構造自体は変わらないと思っています。
+（目安：1分）
+【想定質問】
+Q. 学習をやり直せば改善するのでは？
+A. λを大きくするほど、句読点の抑制や、出力に現れる人工的な成分が強くなりました。ASR損失の比重を上げるほどWhisperへの合わせ込みが進む、という構造的な問題だと考えています。</a:t>
             </a:r>
             <a:endParaRPr lang="en-US" dirty="0"/>
           </a:p>
@@ -949,7 +985,14 @@
           <a:p>
             <a:r>
               <a:rPr lang="en-US" dirty="0"/>
-              <a:t>一方で、研究そのものが行き詰まったわけではありません。ASR損失で学習すると汎用性を失うこと、評価にはテキストの正規化と別系列のASRが必要なことは、分析の成果として卒論や学会発表には十分だと考えています。そして一番大きいのは、次に何を目指すべきかがはっきりしたことです。汎用性を保ったまま、ASRに効くSEをどう作るかです。</a:t>
+              <a:t>【台本】
+ただ、研究そのものが行き詰まったわけではないと考えています。
+（左のカード）1つ目に、分析の成果としての価値があります。ASR損失で学習するとSEの汎用性が失われること、そしてこういうSEを評価するには、テキストの正規化と、学習に使っていない系列のASRでの評価が必要だということです。なお、ASR損失で学習したSEが別のASRで悪化するという傾向は、NTTのSatoらの2025年の論文や、D4AMという2023年の研究でも報告されていて、今回は喉マイクという帯域が欠けた条件でも同じことが起きることを、句読点の影響も含めて確かめた、という位置づけです。卒論や学会発表としては、この分析でまとめられると考えています。
+（右のカード）2つ目、こちらの方が大きいのですが、次に何を目指すべきかがはっきりしました。SEの長所である汎用性を保ったまま、ASRに効くSEをどう作るか、です。
+（目安：1分）
+【想定質問】
+Q. 先行研究と同じ結論なら、卒論の新規性は？
+A. 喉マイクへの適用と、句読点による見かけの改善の定量化、それに出力に現れる250Hz間隔の人工的な成分の分析が新しい部分です。</a:t>
             </a:r>
             <a:endParaRPr lang="en-US" dirty="0"/>
           </a:p>
@@ -1037,7 +1080,12 @@
           <a:p>
             <a:r>
               <a:rPr lang="en-US" dirty="0"/>
-              <a:t>次の方向の本命は、特定のASRに依存しない喉マイク用のSEです。動機として、実際の現場ではクラウドのAPIや共用のASRのように、重みを変えられないASRが多いです。その場合はFTもASR損失での学習もできないので、ASRを選ばないSEしか選択肢がありません。ここがFTに対するSEの本当の存在意義だと考えています。手がかりもあって、気導音声の表現に近づける損失で学習したSEは、Whisper以外のASRでも悪化しませんでした。評価の枠組みは卒論で作ったものがそのまま使えます。</a:t>
+              <a:t>【台本】
+次の方向の本命として考えているのは、特定のASRに依存しない、喉マイク用のSEです。
+（動機）実際の現場では、クラウドのAPIや、他のサービスと共用しているASRのように、重みを変えられないASRが多いです。その場合は、ファインチューニングも、今回のようなASR損失での学習もできません。つまり、ASRを選ばないSEしか選択肢がない。ここが、ファインチューニングに対するSEの本当の存在意義だと考えています。
+（手がかり）手がかりもあります。今回、比較手法として、気導マイクの音の表現に近づける損失でも学習しました。こちらは改善は小さかったのですが、Whisper以外のASRでも悪化しませんでした。汎用性を保てるのは、特定のASRの出力に合わせる方向ではなく、音声の表現そのものに近づける方向だと考えています。実際、WavLMのような自己教師あり学習モデルの表現を損失に使うと、学習に使っていないASRでも改善したという報告があります。
+（評価の枠組み）評価については、学習に使っていない系列のASRで評価する、句読点をそろえる、といった枠組みを卒論で作ったので、それがそのまま使えます。
+（目安：1分15秒）</a:t>
             </a:r>
             <a:endParaRPr lang="en-US" dirty="0"/>
           </a:p>
@@ -1125,7 +1173,13 @@
           <a:p>
             <a:r>
               <a:rPr lang="en-US" dirty="0"/>
-              <a:t>ほかの選択肢も3つ考えました。複数のASRの損失を混ぜる方法は自然な発展ですが、平均的になるだけで、学習に使っていない系列には効かない可能性があります。実際の雑音環境での評価は喉マイクの本来の強みを活かせますが、データの収録が必要で、競合研究もあります。入力側の適応とFTの比較は分析としては面白いものの、手法の提案にはなりません。これらについてもご意見をいただきたいです。</a:t>
+              <a:t>【台本】
+本命以外にも、考えられる選択肢を3つ挙げます。
+（1行目）1つ目は、複数のASRの損失を混ぜて学習する方法です。自然な発展ですが、平均的な結果になるだけで、学習に使っていない系列には効かない可能性があります。
+（2行目）2つ目は、実際の騒音環境で評価することです。喉マイクの本来の強みは騒音に強いことなので、それを活かせます。ただ、データを自分で収録する必要がありますし、競合する研究もあります。
+（3行目）3つ目は、入力側での適応とファインチューニングを比べて、なぜ効くのかを分析する方向です。分析としては面白いのですが、手法の提案にはなりません。
+以上です。卒論は分析としてまとめ、この先は本命の方向に切り替えたいと考えています。この方向でよいか、また他に考えるべき選択肢があるか、ご意見をいただけるとありがたいです。ありがとうございました。
+（目安：1分）</a:t>
             </a:r>
             <a:endParaRPr lang="en-US" dirty="0"/>
           </a:p>

</xml_diff>

<commit_message>
Slides 5-6: state overlap with prior work (Dissen 2024, Sato 2025, D4AM 2023) and what is new
Co-Authored-By: Claude Opus 5.5 (1M context) <noreply@anthropic.com>
</commit_message>
<xml_diff>
--- a/results/progress_slides_2026-09.pptx
+++ b/results/progress_slides_2026-09.pptx
@@ -890,7 +890,7 @@
               <a:t>【台本】
 ここからが、正直な現状の評価です。
 この手法を「提案手法」として押す方向は、行き詰まっていると考えています。理由は3つあります。
-（左のカード）1つ目は、新しさが小さいことです。凍結したWhisperの損失で前処理を学習する手法は、2024年のInterspeechで、Dissenらがすでに発表しています。
+（左のカード）1つ目は、新しさが小さいことです。凍結したWhisperの損失で前処理を学習する手法は、2024年のInterspeechで、Dissenらがすでに発表しています。さらに、ASR損失で学習したSEが学習に使っていないASRで悪化するという今回の発見についても、NTTのSatoらの2025年の論文と、ICLR 2023のD4AMという研究が、すでに同じ傾向を報告していました。これは今回の文献調査でわかったことです。
 （真ん中のカード）2つ目は、精度でファインチューニングに届かないことです。Whisperに特化するのであれば、Whisper自体を喉マイクに合わせてファインチューニングする方が、明らかに精度が高いです。
 （右のカード）3つ目が一番大きくて、SEの長所を失うことです。SEの売りは、どのASRにもつなげられることでした。ところがASR損失で学習すると、さっきの結果のとおり、他の系列のASRでは効かなくなります。
 （下の文）まとめると、「Whisper用ならファインチューニング、汎用ならもともとのTAPSのSE」で済んでしまって、この手法の居場所がありません。損失の重みを変えたり損失を工夫したりしても、この構造自体は変わらないと思っています。
@@ -987,7 +987,7 @@
               <a:rPr lang="en-US" dirty="0"/>
               <a:t>【台本】
 ただ、研究そのものが行き詰まったわけではないと考えています。
-（左のカード）1つ目に、分析の成果としての価値があります。ASR損失で学習するとSEの汎用性が失われること、そしてこういうSEを評価するには、テキストの正規化と、学習に使っていない系列のASRでの評価が必要だということです。なお、ASR損失で学習したSEが別のASRで悪化するという傾向は、NTTのSatoらの2025年の論文や、D4AMという2023年の研究でも報告されていて、今回は喉マイクという帯域が欠けた条件でも同じことが起きることを、句読点の影響も含めて確かめた、という位置づけです。卒論や学会発表としては、この分析でまとめられると考えています。
+（左のカード）1つ目に、分析の成果としての価値があります。ASR損失で学習するとSEの汎用性が失われること、そしてこういうSEを評価するには、テキストの正規化と、学習に使っていない系列のASRでの評価が必要だということです。さっきお話ししたとおり、「汎用性を失う」こと自体は先行研究と同じ傾向です。新しいと言えるのは、4kHz以上が欠けた喉マイクという条件で確かめたこと、句読点による見かけの改善を定量化したこと、そして出力に現れる250Hz間隔の人工的な成分を分析したことです。卒論や学会発表としては、この分析でまとめられると考えています。
 （右のカード）2つ目、こちらの方が大きいのですが、次に何を目指すべきかがはっきりしました。SEの長所である汎用性を保ったまま、ASRに効くSEをどう作るか、です。
 （目安：1分）
 【想定質問】
@@ -4205,7 +4205,7 @@
                 <a:ea typeface="Yu Gothic" pitchFamily="34" charset="-122"/>
                 <a:cs typeface="Yu Gothic" pitchFamily="34" charset="-120"/>
               </a:rPr>
-              <a:t>凍結したWhisperの損失で前処理を学習する手法は、先行研究（Dissen 2024）がある</a:t>
+              <a:t>凍結Whisperの損失で前処理を学習する手法はDissen 2024が既出。ASR損失で学習したSEが他のASRで悪化することも、Sato 2025・D4AM 2023が報告済み</a:t>
             </a:r>
             <a:endParaRPr lang="en-US" sz="1400" dirty="0"/>
           </a:p>
@@ -4704,7 +4704,41 @@
                 <a:ea typeface="Yu Gothic" pitchFamily="34" charset="-122"/>
                 <a:cs typeface="Yu Gothic" pitchFamily="34" charset="-120"/>
               </a:rPr>
-              <a:t>「ASR損失で学習すると汎用性を失う」「評価にはテキスト正規化と別系列のASRが必要」</a:t>
+              <a:t>「汎用性を失う」は先行研究と同じ傾向。</a:t>
+            </a:r>
+            <a:pPr indent="0" marL="0">
+              <a:lnSpc>
+                <a:spcPct val="140000"/>
+              </a:lnSpc>
+              <a:buNone/>
+            </a:pPr>
+            <a:r>
+              <a:rPr lang="en-US" sz="1500" b="1" dirty="0">
+                <a:solidFill>
+                  <a:srgbClr val="1F2A37"/>
+                </a:solidFill>
+                <a:latin typeface="Yu Gothic" pitchFamily="34" charset="0"/>
+                <a:ea typeface="Yu Gothic" pitchFamily="34" charset="-122"/>
+                <a:cs typeface="Yu Gothic" pitchFamily="34" charset="-120"/>
+              </a:rPr>
+              <a:t>新しいのは</a:t>
+            </a:r>
+            <a:pPr indent="0" marL="0">
+              <a:lnSpc>
+                <a:spcPct val="140000"/>
+              </a:lnSpc>
+              <a:buNone/>
+            </a:pPr>
+            <a:r>
+              <a:rPr lang="en-US" sz="1500" dirty="0">
+                <a:solidFill>
+                  <a:srgbClr val="1F2A37"/>
+                </a:solidFill>
+                <a:latin typeface="Yu Gothic" pitchFamily="34" charset="0"/>
+                <a:ea typeface="Yu Gothic" pitchFamily="34" charset="-122"/>
+                <a:cs typeface="Yu Gothic" pitchFamily="34" charset="-120"/>
+              </a:rPr>
+              <a:t>、帯域が欠けた喉マイクでの確認、句読点による見かけの改善の定量化、250 Hz間隔の人工成分の分析</a:t>
             </a:r>
             <a:endParaRPr lang="en-US" sz="1500" dirty="0"/>
           </a:p>

</xml_diff>

<commit_message>
Slide 7: ground the 'clue' in prior work (Sato 2025, Ravenscroft 2024); Enc L1 stated as no-effect
Co-Authored-By: Claude Opus 5.5 (1M context) <noreply@anthropic.com>
</commit_message>
<xml_diff>
--- a/results/progress_slides_2026-09.pptx
+++ b/results/progress_slides_2026-09.pptx
@@ -1083,7 +1083,8 @@
               <a:t>【台本】
 次の方向の本命として考えているのは、特定のASRに依存しない、喉マイク用のSEです。
 （動機）実際の現場では、クラウドのAPIや、他のサービスと共用しているASRのように、重みを変えられないASRが多いです。その場合は、ファインチューニングも、今回のようなASR損失での学習もできません。つまり、ASRを選ばないSEしか選択肢がない。ここが、ファインチューニングに対するSEの本当の存在意義だと考えています。
-（手がかり）手がかりもあります。今回、比較手法として、気導マイクの音の表現に近づける損失でも学習しました。こちらは改善は小さかったのですが、Whisper以外のASRでも悪化しませんでした。汎用性を保てるのは、特定のASRの出力に合わせる方向ではなく、音声の表現そのものに近づける方向だと考えています。実際、WavLMのような自己教師あり学習モデルの表現を損失に使うと、学習に使っていないASRでも改善したという報告があります。
+（手がかり）手がかりは先行研究にあります。WavLMのような自己教師あり学習モデルの表現を損失に使ってSEを学習すると、学習に使っていないASRでも改善した、という報告があります。NTTのSatoらの2025年の論文や、Ravenscroftらの2024年の研究です。特定のASRの出力に合わせるのではなく、音声の表現そのものに近づける方向なので、汎用性を保てる可能性があります。
+一方で、今回の実験でも比較手法として、気導マイクの音をWhisperに入れたときの表現に近づける損失、Enc L1を試しています。こちらはWhisper以外のASRで悪化はしませんでしたが、どのASRでも改善もしませんでした。元のTAPSのSEからほとんど変わらなかった、というのが正直なところです。なので、自分の結果だけではまだ手がかりとは言えず、Whisperの表現ではなく自己教師あり学習モデルの表現を使うところから試したいと考えています。
 （評価の枠組み）評価については、学習に使っていない系列のASRで評価する、句読点をそろえる、といった枠組みを卒論で作ったので、それがそのまま使えます。
 （目安：1分15秒）</a:t>
             </a:r>
@@ -5421,7 +5422,7 @@
                 <a:ea typeface="Yu Gothic" pitchFamily="34" charset="-122"/>
                 <a:cs typeface="Yu Gothic" pitchFamily="34" charset="-120"/>
               </a:rPr>
-              <a:t>気導音声の表現に近づける損失（Enc L1）は、Whisper以外でも悪化しなかった。汎用性を保てるのは「特定のASRの出力」ではなく</a:t>
+              <a:t>自己教師あり表現（WavLMなど）を損失に使うと、</a:t>
             </a:r>
             <a:pPr indent="0" marL="0">
               <a:lnSpc>
@@ -5438,7 +5439,7 @@
                 <a:ea typeface="Yu Gothic" pitchFamily="34" charset="-122"/>
                 <a:cs typeface="Yu Gothic" pitchFamily="34" charset="-120"/>
               </a:rPr>
-              <a:t>「音声の表現」に近づける</a:t>
+              <a:t>学習に使っていないASRでも改善した</a:t>
             </a:r>
             <a:pPr indent="0" marL="0">
               <a:lnSpc>
@@ -5455,7 +5456,7 @@
                 <a:ea typeface="Yu Gothic" pitchFamily="34" charset="-122"/>
                 <a:cs typeface="Yu Gothic" pitchFamily="34" charset="-120"/>
               </a:rPr>
-              <a:t>方向（自己教師あり表現を損失に使う研究もある）</a:t>
+              <a:t>という報告がある（Sato 2025、Ravenscroft 2024）。今回のEnc L1（Whisperの表現に近づける損失）は特化は起きなかったが、改善もしなかった</a:t>
             </a:r>
             <a:endParaRPr lang="en-US" sz="1400" dirty="0"/>
           </a:p>

</xml_diff>

<commit_message>
Slides: review pass — introduce FT/baseline/eval conditions, baseline note, introduce comb artifact, move Enc L1 to Q&A, clarify options, add closing ask
Co-Authored-By: Claude Opus 5.5 (1M context) <noreply@anthropic.com>
</commit_message>
<xml_diff>
--- a/results/progress_slides_2026-09.pptx
+++ b/results/progress_slides_2026-09.pptx
@@ -793,11 +793,11 @@
             <a:r>
               <a:rPr lang="en-US" dirty="0"/>
               <a:t>【台本】
-わかったことです。細かい数字は省いて、傾向だけお話しします。
+わかったことです。細かい数字は省いて、傾向だけお話しします。比べている相手は、すべて元のTAPSのSEです。
 （1行目）まず、学習に使ったWhisper-smallでは、CERは確かに改善しました。テスト用の10話者全員で改善しています。同じWhisper系列のmediumにも改善は持ち越されましたが、小さいbaseでははっきりした差が出ませんでした。
 （2行目）一方で、Whisperとは作りが違うwav2vec2系の音声認識では改善しませんでした。XLS-Rでははっきり悪化し、MMSではほぼ変わりませんでした。
 （3行目）それから、評価の途中で問題を見つけました。TAPSの正解テキストには句読点がないのですが、Whisperは普通、文末に句点を付けます。ASR損失で学習すると、SEはWhisperが句読点を出さなくなるような音を作るようになっていました。評価で句読点をそろえていなかったので、その分が改善として数えられていました。句読点をそろえて計算し直すと改善は小さくなりますが、それでも残ります。
-（4行目）最後に、STOIやPESQといった音の品質の指標は、むしろ下がっていました。つまり、気導マイクらしい自然な音に近づけているのではなく、Whisperが読みやすい別の音を作っている、ということです。
+（4行目）最後に出力の音です。STOIやPESQといった音の品質の指標は、むしろ下がっていました。さらに出力には、250Hz間隔で鋭いピークが並ぶ人工的な成分が現れていました。気導マイクの音にはない成分です。つまり、気導マイクらしい自然な音に近づけているのではなく、Whisperが読みやすい別の音を作っている、ということです。
 （補足：聞かれたら）句読点をそろえたCERで、Whisper-smallはTAPSのSEの0.230から0.196、15%の改善です。改善幅のうち約3分の1が句読点によるものでした。XLS-Rは約26%悪化しています。
 （目安：1分30秒）</a:t>
             </a:r>
@@ -1084,9 +1084,11 @@
 次の方向の本命として考えているのは、特定のASRに依存しない、喉マイク用のSEです。
 （動機）実際の現場では、クラウドのAPIや、他のサービスと共用しているASRのように、重みを変えられないASRが多いです。その場合は、ファインチューニングも、今回のようなASR損失での学習もできません。つまり、ASRを選ばないSEしか選択肢がない。ここが、ファインチューニングに対するSEの本当の存在意義だと考えています。
 （手がかり）手がかりは先行研究にあります。WavLMのような自己教師あり学習モデルの表現を損失に使ってSEを学習すると、学習に使っていないASRでも改善した、という報告があります。NTTのSatoらの2025年の論文や、Ravenscroftらの2024年の研究です。特定のASRの出力に合わせるのではなく、音声の表現そのものに近づける方向なので、汎用性を保てる可能性があります。
-一方で、今回の実験でも比較手法として、気導マイクの音をWhisperに入れたときの表現に近づける損失、Enc L1を試しています。こちらはWhisper以外のASRで悪化はしませんでしたが、どのASRでも改善もしませんでした。元のTAPSのSEからほとんど変わらなかった、というのが正直なところです。なので、自分の結果だけではまだ手がかりとは言えず、Whisperの表現ではなく自己教師あり学習モデルの表現を使うところから試したいと考えています。
 （評価の枠組み）評価については、学習に使っていない系列のASRで評価する、句読点をそろえる、といった枠組みを卒論で作ったので、それがそのまま使えます。
-（目安：1分15秒）</a:t>
+（目安：1分15秒）
+【想定質問】
+Q. 自分の実験で、表現に近づける損失は試していないのか？
+A. 比較手法として、気導マイクの音をWhisperに入れたときの表現に近づける損失（Enc L1）を試しました。Whisper以外のASRで悪化はしませんでしたが、どのASRでも改善もせず、元のTAPS SEからほとんど変わりませんでした。なので、Whisperの表現ではなく、自己教師あり学習モデルの表現を使うところから試したいと考えています。</a:t>
             </a:r>
             <a:endParaRPr lang="en-US" dirty="0"/>
           </a:p>
@@ -1177,9 +1179,9 @@
               <a:t>【台本】
 本命以外にも、考えられる選択肢を3つ挙げます。
 （1行目）1つ目は、複数のASRの損失を混ぜて学習する方法です。自然な発展ですが、平均的な結果になるだけで、学習に使っていない系列には効かない可能性があります。
-（2行目）2つ目は、実際の騒音環境で評価することです。喉マイクの本来の強みは騒音に強いことなので、それを活かせます。ただ、データを自分で収録する必要がありますし、競合する研究もあります。
-（3行目）3つ目は、入力側での適応とファインチューニングを比べて、なぜ効くのかを分析する方向です。分析としては面白いのですが、手法の提案にはなりません。
-以上です。卒論は分析としてまとめ、この先は本命の方向に切り替えたいと考えています。この方向でよいか、また他に考えるべき選択肢があるか、ご意見をいただけるとありがたいです。ありがとうございました。
+（2行目）2つ目は、雑音のある環境で評価することです。今回の実験は雑音のない収録音声だけでした。喉マイクの本来の強みは騒音に強いことなので、それを活かせます。ただ、データを自分で収録する必要がありますし、競合する研究もあります。
+（3行目）3つ目は、SEとファインチューニングが、それぞれ音声のどこを直しているのかを分析する方向です。分析としては面白いのですが、手法の提案にはなりません。
+以上です。卒論は分析としてまとめ、この先は本命の方向に切り替えたいと考えています。（下の帯を指して）この本命の方向でよいか、また他に考えるべき選択肢があるか、ご意見をいただけるとありがたいです。ありがとうございました。
 （目安：1分）</a:t>
             </a:r>
             <a:endParaRPr lang="en-US" dirty="0"/>
@@ -1837,7 +1839,7 @@
         <p:spPr>
           <a:xfrm>
             <a:off x="813816" y="1965960"/>
-            <a:ext cx="5760720" cy="1188720"/>
+            <a:ext cx="5760720" cy="1280160"/>
           </a:xfrm>
           <a:prstGeom prst="rect">
             <a:avLst/>
@@ -1864,7 +1866,7 @@
                 <a:ea typeface="Yu Gothic" pitchFamily="34" charset="-122"/>
                 <a:cs typeface="Yu Gothic" pitchFamily="34" charset="-120"/>
               </a:rPr>
-              <a:t>喉マイクは騒音に強いが、4 kHz以上がなくASR精度が低い。SEは</a:t>
+              <a:t>喉マイクは騒音に強いが、4 kHz以上がなくASR精度が低い。対策は、ASR自体を学習し直す</a:t>
             </a:r>
             <a:pPr indent="0" marL="0">
               <a:lnSpc>
@@ -1881,7 +1883,7 @@
                 <a:ea typeface="Yu Gothic" pitchFamily="34" charset="-122"/>
                 <a:cs typeface="Yu Gothic" pitchFamily="34" charset="-120"/>
               </a:rPr>
-              <a:t>どのASRにも前処理としてつなげる</a:t>
+              <a:t>FT</a:t>
             </a:r>
             <a:pPr indent="0" marL="0">
               <a:lnSpc>
@@ -1898,6 +1900,74 @@
                 <a:ea typeface="Yu Gothic" pitchFamily="34" charset="-122"/>
                 <a:cs typeface="Yu Gothic" pitchFamily="34" charset="-120"/>
               </a:rPr>
+              <a:t>か、前処理で音を直す</a:t>
+            </a:r>
+            <a:pPr indent="0" marL="0">
+              <a:lnSpc>
+                <a:spcPct val="140000"/>
+              </a:lnSpc>
+              <a:buNone/>
+            </a:pPr>
+            <a:r>
+              <a:rPr lang="en-US" sz="1600" b="1" dirty="0">
+                <a:solidFill>
+                  <a:srgbClr val="1F2A37"/>
+                </a:solidFill>
+                <a:latin typeface="Yu Gothic" pitchFamily="34" charset="0"/>
+                <a:ea typeface="Yu Gothic" pitchFamily="34" charset="-122"/>
+                <a:cs typeface="Yu Gothic" pitchFamily="34" charset="-120"/>
+              </a:rPr>
+              <a:t>SE</a:t>
+            </a:r>
+            <a:pPr indent="0" marL="0">
+              <a:lnSpc>
+                <a:spcPct val="140000"/>
+              </a:lnSpc>
+              <a:buNone/>
+            </a:pPr>
+            <a:r>
+              <a:rPr lang="en-US" sz="1600" dirty="0">
+                <a:solidFill>
+                  <a:srgbClr val="1F2A37"/>
+                </a:solidFill>
+                <a:latin typeface="Yu Gothic" pitchFamily="34" charset="0"/>
+                <a:ea typeface="Yu Gothic" pitchFamily="34" charset="-122"/>
+                <a:cs typeface="Yu Gothic" pitchFamily="34" charset="-120"/>
+              </a:rPr>
+              <a:t>。精度はFTが上だが、SEは</a:t>
+            </a:r>
+            <a:pPr indent="0" marL="0">
+              <a:lnSpc>
+                <a:spcPct val="140000"/>
+              </a:lnSpc>
+              <a:buNone/>
+            </a:pPr>
+            <a:r>
+              <a:rPr lang="en-US" sz="1600" b="1" dirty="0">
+                <a:solidFill>
+                  <a:srgbClr val="1F2A37"/>
+                </a:solidFill>
+                <a:latin typeface="Yu Gothic" pitchFamily="34" charset="0"/>
+                <a:ea typeface="Yu Gothic" pitchFamily="34" charset="-122"/>
+                <a:cs typeface="Yu Gothic" pitchFamily="34" charset="-120"/>
+              </a:rPr>
+              <a:t>どのASRにもつなげられる</a:t>
+            </a:r>
+            <a:pPr indent="0" marL="0">
+              <a:lnSpc>
+                <a:spcPct val="140000"/>
+              </a:lnSpc>
+              <a:buNone/>
+            </a:pPr>
+            <a:r>
+              <a:rPr lang="en-US" sz="1600" dirty="0">
+                <a:solidFill>
+                  <a:srgbClr val="1F2A37"/>
+                </a:solidFill>
+                <a:latin typeface="Yu Gothic" pitchFamily="34" charset="0"/>
+                <a:ea typeface="Yu Gothic" pitchFamily="34" charset="-122"/>
+                <a:cs typeface="Yu Gothic" pitchFamily="34" charset="-120"/>
+              </a:rPr>
               <a:t>のが利点。</a:t>
             </a:r>
             <a:endParaRPr lang="en-US" sz="1600" dirty="0"/>
@@ -1912,7 +1982,7 @@
         </p:nvSpPr>
         <p:spPr>
           <a:xfrm>
-            <a:off x="813816" y="3337560"/>
+            <a:off x="813816" y="3657600"/>
             <a:ext cx="5760720" cy="320040"/>
           </a:xfrm>
           <a:prstGeom prst="rect">
@@ -1951,7 +2021,7 @@
         </p:nvSpPr>
         <p:spPr>
           <a:xfrm>
-            <a:off x="813816" y="3703320"/>
+            <a:off x="813816" y="4023360"/>
             <a:ext cx="5760720" cy="1188720"/>
           </a:xfrm>
           <a:prstGeom prst="rect">
@@ -2149,41 +2219,14 @@
       </p:sp>
       <p:sp>
         <p:nvSpPr>
-          <p:cNvPr id="10" name="Shape 8"/>
-          <p:cNvSpPr/>
-          <p:nvPr/>
-        </p:nvSpPr>
-        <p:spPr>
-          <a:xfrm>
-            <a:off x="7196328" y="3429000"/>
-            <a:ext cx="3879799" cy="1005840"/>
-          </a:xfrm>
-          <a:prstGeom prst="roundRect">
-            <a:avLst>
-              <a:gd name="adj" fmla="val 7273"/>
-            </a:avLst>
-          </a:prstGeom>
-          <a:solidFill>
-            <a:srgbClr val="EEF1F4"/>
-          </a:solidFill>
-          <a:ln w="12700">
-            <a:solidFill>
-              <a:srgbClr val="EEF1F4"/>
-            </a:solidFill>
-            <a:prstDash val="solid"/>
-          </a:ln>
-        </p:spPr>
-      </p:sp>
-      <p:sp>
-        <p:nvSpPr>
-          <p:cNvPr id="11" name="Text 9"/>
-          <p:cNvSpPr/>
-          <p:nvPr/>
-        </p:nvSpPr>
-        <p:spPr>
-          <a:xfrm>
-            <a:off x="7351776" y="3520440"/>
-            <a:ext cx="3568903" cy="822960"/>
+          <p:cNvPr id="10" name="Text 8"/>
+          <p:cNvSpPr/>
+          <p:nvPr/>
+        </p:nvSpPr>
+        <p:spPr>
+          <a:xfrm>
+            <a:off x="7196328" y="3520440"/>
+            <a:ext cx="3879799" cy="2011680"/>
           </a:xfrm>
           <a:prstGeom prst="rect">
             <a:avLst/>
@@ -2192,49 +2235,30 @@
           <a:ln/>
         </p:spPr>
         <p:txBody>
-          <a:bodyPr wrap="square" lIns="0" tIns="0" rIns="0" bIns="0" rtlCol="0" anchor="ctr"/>
-          <a:lstStyle/>
-          <a:p>
-            <a:pPr indent="0" marL="0">
-              <a:buNone/>
-            </a:pPr>
-            <a:r>
-              <a:rPr lang="en-US" sz="1500" dirty="0">
-                <a:solidFill>
-                  <a:srgbClr val="1F2A37"/>
-                </a:solidFill>
-                <a:latin typeface="Yu Gothic" pitchFamily="34" charset="0"/>
-                <a:ea typeface="Yu Gothic" pitchFamily="34" charset="-122"/>
-                <a:cs typeface="Yu Gothic" pitchFamily="34" charset="-120"/>
-              </a:rPr>
-              <a:t>L = 再構成損失 + λ × CE(Whisper(SE出力), 正解)</a:t>
-            </a:r>
-            <a:endParaRPr lang="en-US" sz="1500" dirty="0"/>
-          </a:p>
-        </p:txBody>
-      </p:sp>
-      <p:sp>
-        <p:nvSpPr>
-          <p:cNvPr id="12" name="Text 10"/>
-          <p:cNvSpPr/>
-          <p:nvPr/>
-        </p:nvSpPr>
-        <p:spPr>
-          <a:xfrm>
-            <a:off x="7196328" y="4663440"/>
-            <a:ext cx="3879799" cy="548640"/>
-          </a:xfrm>
-          <a:prstGeom prst="rect">
-            <a:avLst/>
-          </a:prstGeom>
-          <a:noFill/>
-          <a:ln/>
-        </p:spPr>
-        <p:txBody>
           <a:bodyPr wrap="square" lIns="0" tIns="0" rIns="0" bIns="0" rtlCol="0" anchor="t"/>
           <a:lstStyle/>
           <a:p>
             <a:pPr indent="0" marL="0">
+              <a:lnSpc>
+                <a:spcPct val="160000"/>
+              </a:lnSpc>
+              <a:buNone/>
+            </a:pPr>
+            <a:r>
+              <a:rPr lang="en-US" sz="1300" b="1" dirty="0">
+                <a:solidFill>
+                  <a:srgbClr val="4A5568"/>
+                </a:solidFill>
+                <a:latin typeface="Yu Gothic" pitchFamily="34" charset="0"/>
+                <a:ea typeface="Yu Gothic" pitchFamily="34" charset="-122"/>
+                <a:cs typeface="Yu Gothic" pitchFamily="34" charset="-120"/>
+              </a:rPr>
+              <a:t>ベースライン：</a:t>
+            </a:r>
+            <a:pPr indent="0" marL="0">
+              <a:lnSpc>
+                <a:spcPct val="160000"/>
+              </a:lnSpc>
               <a:buNone/>
             </a:pPr>
             <a:r>
@@ -2246,7 +2270,81 @@
                 <a:ea typeface="Yu Gothic" pitchFamily="34" charset="-122"/>
                 <a:cs typeface="Yu Gothic" pitchFamily="34" charset="-120"/>
               </a:rPr>
-              <a:t>データ：韓国語TAPS（喉マイク／気導マイクの同時収録）</a:t>
+              <a:t>TAPS論文の学習済みSE（以下 TAPS SE）</a:t>
+            </a:r>
+            <a:endParaRPr lang="en-US" sz="1300" dirty="0"/>
+          </a:p>
+          <a:p>
+            <a:pPr indent="0" marL="0">
+              <a:lnSpc>
+                <a:spcPct val="160000"/>
+              </a:lnSpc>
+              <a:buNone/>
+            </a:pPr>
+            <a:r>
+              <a:rPr lang="en-US" sz="1300" b="1" dirty="0">
+                <a:solidFill>
+                  <a:srgbClr val="4A5568"/>
+                </a:solidFill>
+                <a:latin typeface="Yu Gothic" pitchFamily="34" charset="0"/>
+                <a:ea typeface="Yu Gothic" pitchFamily="34" charset="-122"/>
+                <a:cs typeface="Yu Gothic" pitchFamily="34" charset="-120"/>
+              </a:rPr>
+              <a:t>データ：</a:t>
+            </a:r>
+            <a:pPr indent="0" marL="0">
+              <a:lnSpc>
+                <a:spcPct val="160000"/>
+              </a:lnSpc>
+              <a:buNone/>
+            </a:pPr>
+            <a:r>
+              <a:rPr lang="en-US" sz="1300" dirty="0">
+                <a:solidFill>
+                  <a:srgbClr val="4A5568"/>
+                </a:solidFill>
+                <a:latin typeface="Yu Gothic" pitchFamily="34" charset="0"/>
+                <a:ea typeface="Yu Gothic" pitchFamily="34" charset="-122"/>
+                <a:cs typeface="Yu Gothic" pitchFamily="34" charset="-120"/>
+              </a:rPr>
+              <a:t>韓国語TAPS（喉マイク／気導マイクの同時収録）</a:t>
+            </a:r>
+            <a:endParaRPr lang="en-US" sz="1300" dirty="0"/>
+          </a:p>
+          <a:p>
+            <a:pPr indent="0" marL="0">
+              <a:lnSpc>
+                <a:spcPct val="160000"/>
+              </a:lnSpc>
+              <a:buNone/>
+            </a:pPr>
+            <a:r>
+              <a:rPr lang="en-US" sz="1300" b="1" dirty="0">
+                <a:solidFill>
+                  <a:srgbClr val="4A5568"/>
+                </a:solidFill>
+                <a:latin typeface="Yu Gothic" pitchFamily="34" charset="0"/>
+                <a:ea typeface="Yu Gothic" pitchFamily="34" charset="-122"/>
+                <a:cs typeface="Yu Gothic" pitchFamily="34" charset="-120"/>
+              </a:rPr>
+              <a:t>評価：</a:t>
+            </a:r>
+            <a:pPr indent="0" marL="0">
+              <a:lnSpc>
+                <a:spcPct val="160000"/>
+              </a:lnSpc>
+              <a:buNone/>
+            </a:pPr>
+            <a:r>
+              <a:rPr lang="en-US" sz="1300" dirty="0">
+                <a:solidFill>
+                  <a:srgbClr val="4A5568"/>
+                </a:solidFill>
+                <a:latin typeface="Yu Gothic" pitchFamily="34" charset="0"/>
+                <a:ea typeface="Yu Gothic" pitchFamily="34" charset="-122"/>
+                <a:cs typeface="Yu Gothic" pitchFamily="34" charset="-120"/>
+              </a:rPr>
+              <a:t>雑音のない収録音声、テスト話者10名</a:t>
             </a:r>
             <a:endParaRPr lang="en-US" sz="1300" dirty="0"/>
           </a:p>
@@ -3421,7 +3519,46 @@
       </p:sp>
       <p:sp>
         <p:nvSpPr>
-          <p:cNvPr id="3" name="Shape 1"/>
+          <p:cNvPr id="3" name="Text 1"/>
+          <p:cNvSpPr/>
+          <p:nvPr/>
+        </p:nvSpPr>
+        <p:spPr>
+          <a:xfrm>
+            <a:off x="813816" y="1188720"/>
+            <a:ext cx="10564063" cy="320040"/>
+          </a:xfrm>
+          <a:prstGeom prst="rect">
+            <a:avLst/>
+          </a:prstGeom>
+          <a:noFill/>
+          <a:ln/>
+        </p:spPr>
+        <p:txBody>
+          <a:bodyPr wrap="square" lIns="0" tIns="0" rIns="0" bIns="0" rtlCol="0" anchor="t"/>
+          <a:lstStyle/>
+          <a:p>
+            <a:pPr indent="0" marL="0">
+              <a:buNone/>
+            </a:pPr>
+            <a:r>
+              <a:rPr lang="en-US" sz="1300" dirty="0">
+                <a:solidFill>
+                  <a:srgbClr val="4A5568"/>
+                </a:solidFill>
+                <a:latin typeface="Yu Gothic" pitchFamily="34" charset="0"/>
+                <a:ea typeface="Yu Gothic" pitchFamily="34" charset="-122"/>
+                <a:cs typeface="Yu Gothic" pitchFamily="34" charset="-120"/>
+              </a:rPr>
+              <a:t>比較の相手はすべて TAPS SE（ASR損失なしで学習した元のSE）</a:t>
+            </a:r>
+            <a:endParaRPr lang="en-US" sz="1300" dirty="0"/>
+          </a:p>
+        </p:txBody>
+      </p:sp>
+      <p:sp>
+        <p:nvSpPr>
+          <p:cNvPr id="4" name="Shape 2"/>
           <p:cNvSpPr/>
           <p:nvPr/>
         </p:nvSpPr>
@@ -3444,7 +3581,7 @@
       </p:sp>
       <p:sp>
         <p:nvSpPr>
-          <p:cNvPr id="4" name="Text 2"/>
+          <p:cNvPr id="5" name="Text 3"/>
           <p:cNvSpPr/>
           <p:nvPr/>
         </p:nvSpPr>
@@ -3483,7 +3620,7 @@
       </p:sp>
       <p:sp>
         <p:nvSpPr>
-          <p:cNvPr id="5" name="Text 3"/>
+          <p:cNvPr id="6" name="Text 4"/>
           <p:cNvSpPr/>
           <p:nvPr/>
         </p:nvSpPr>
@@ -3559,7 +3696,7 @@
       </p:sp>
       <p:sp>
         <p:nvSpPr>
-          <p:cNvPr id="6" name="Shape 4"/>
+          <p:cNvPr id="7" name="Shape 5"/>
           <p:cNvSpPr/>
           <p:nvPr/>
         </p:nvSpPr>
@@ -3582,7 +3719,7 @@
       </p:sp>
       <p:sp>
         <p:nvSpPr>
-          <p:cNvPr id="7" name="Text 5"/>
+          <p:cNvPr id="8" name="Text 6"/>
           <p:cNvSpPr/>
           <p:nvPr/>
         </p:nvSpPr>
@@ -3621,7 +3758,7 @@
       </p:sp>
       <p:sp>
         <p:nvSpPr>
-          <p:cNvPr id="8" name="Text 6"/>
+          <p:cNvPr id="9" name="Text 7"/>
           <p:cNvSpPr/>
           <p:nvPr/>
         </p:nvSpPr>
@@ -3697,7 +3834,7 @@
       </p:sp>
       <p:sp>
         <p:nvSpPr>
-          <p:cNvPr id="9" name="Shape 7"/>
+          <p:cNvPr id="10" name="Shape 8"/>
           <p:cNvSpPr/>
           <p:nvPr/>
         </p:nvSpPr>
@@ -3720,7 +3857,7 @@
       </p:sp>
       <p:sp>
         <p:nvSpPr>
-          <p:cNvPr id="10" name="Text 8"/>
+          <p:cNvPr id="11" name="Text 9"/>
           <p:cNvSpPr/>
           <p:nvPr/>
         </p:nvSpPr>
@@ -3759,7 +3896,7 @@
       </p:sp>
       <p:sp>
         <p:nvSpPr>
-          <p:cNvPr id="11" name="Text 9"/>
+          <p:cNvPr id="12" name="Text 10"/>
           <p:cNvSpPr/>
           <p:nvPr/>
         </p:nvSpPr>
@@ -3835,7 +3972,7 @@
       </p:sp>
       <p:sp>
         <p:nvSpPr>
-          <p:cNvPr id="12" name="Shape 10"/>
+          <p:cNvPr id="13" name="Shape 11"/>
           <p:cNvSpPr/>
           <p:nvPr/>
         </p:nvSpPr>
@@ -3858,7 +3995,7 @@
       </p:sp>
       <p:sp>
         <p:nvSpPr>
-          <p:cNvPr id="13" name="Text 11"/>
+          <p:cNvPr id="14" name="Text 12"/>
           <p:cNvSpPr/>
           <p:nvPr/>
         </p:nvSpPr>
@@ -3889,7 +4026,7 @@
                 <a:ea typeface="Yu Gothic" pitchFamily="34" charset="-122"/>
                 <a:cs typeface="Yu Gothic" pitchFamily="34" charset="-120"/>
               </a:rPr>
-              <a:t>知覚品質</a:t>
+              <a:t>出力の音</a:t>
             </a:r>
             <a:endParaRPr lang="en-US" sz="1700" dirty="0"/>
           </a:p>
@@ -3897,7 +4034,7 @@
       </p:sp>
       <p:sp>
         <p:nvSpPr>
-          <p:cNvPr id="14" name="Text 12"/>
+          <p:cNvPr id="15" name="Text 13"/>
           <p:cNvSpPr/>
           <p:nvPr/>
         </p:nvSpPr>
@@ -3931,7 +4068,7 @@
                 <a:ea typeface="Yu Gothic" pitchFamily="34" charset="-122"/>
                 <a:cs typeface="Yu Gothic" pitchFamily="34" charset="-120"/>
               </a:rPr>
-              <a:t>STOI・PESQは下がる。気導音声らしい音ではなく、</a:t>
+              <a:t>STOI・PESQは下がり、250 Hz間隔の人工的な成分が現れる。気導音声らしい音ではなく、</a:t>
             </a:r>
             <a:pPr indent="0" marL="0">
               <a:lnSpc>
@@ -3973,7 +4110,7 @@
       </p:sp>
       <p:sp>
         <p:nvSpPr>
-          <p:cNvPr id="15" name="Shape 13"/>
+          <p:cNvPr id="16" name="Shape 14"/>
           <p:cNvSpPr/>
           <p:nvPr/>
         </p:nvSpPr>
@@ -5456,7 +5593,7 @@
                 <a:ea typeface="Yu Gothic" pitchFamily="34" charset="-122"/>
                 <a:cs typeface="Yu Gothic" pitchFamily="34" charset="-120"/>
               </a:rPr>
-              <a:t>という報告がある（Sato 2025、Ravenscroft 2024）。今回のEnc L1（Whisperの表現に近づける損失）は特化は起きなかったが、改善もしなかった</a:t>
+              <a:t>という報告がある（Sato 2025、Ravenscroft 2024）。特定のASRの出力ではなく、「音声の表現」に近づける方向</a:t>
             </a:r>
             <a:endParaRPr lang="en-US" sz="1400" dirty="0"/>
           </a:p>
@@ -6177,7 +6314,7 @@
                           <a:ea typeface="Yu Gothic" pitchFamily="34" charset="-122"/>
                           <a:cs typeface="Yu Gothic" pitchFamily="34" charset="-120"/>
                         </a:rPr>
-                        <a:t>実際の雑音環境で評価</a:t>
+                        <a:t>雑音のある環境で評価（今回は雑音なし）</a:t>
                       </a:r>
                       <a:endParaRPr lang="en-US" sz="1500" dirty="0">
                         <a:latin typeface="Yu Gothic" charset="0"/>
@@ -6383,7 +6520,7 @@
                           <a:ea typeface="Yu Gothic" pitchFamily="34" charset="-122"/>
                           <a:cs typeface="Yu Gothic" pitchFamily="34" charset="-120"/>
                         </a:rPr>
-                        <a:t>入力側の適応とFTの比較（なぜ効くか）</a:t>
+                        <a:t>SEとFTがそれぞれ何を直しているかの分析</a:t>
                       </a:r>
                       <a:endParaRPr lang="en-US" sz="1500" dirty="0">
                         <a:latin typeface="Yu Gothic" charset="0"/>
@@ -6575,6 +6712,72 @@
           </a:graphicData>
         </a:graphic>
       </p:graphicFrame>
+      <p:sp>
+        <p:nvSpPr>
+          <p:cNvPr id="5" name="Shape 2"/>
+          <p:cNvSpPr/>
+          <p:nvPr/>
+        </p:nvSpPr>
+        <p:spPr>
+          <a:xfrm>
+            <a:off x="813816" y="5440680"/>
+            <a:ext cx="10564063" cy="594360"/>
+          </a:xfrm>
+          <a:prstGeom prst="roundRect">
+            <a:avLst>
+              <a:gd name="adj" fmla="val 12308"/>
+            </a:avLst>
+          </a:prstGeom>
+          <a:solidFill>
+            <a:srgbClr val="1F2A37"/>
+          </a:solidFill>
+          <a:ln w="12700">
+            <a:solidFill>
+              <a:srgbClr val="1F2A37"/>
+            </a:solidFill>
+            <a:prstDash val="solid"/>
+          </a:ln>
+        </p:spPr>
+      </p:sp>
+      <p:sp>
+        <p:nvSpPr>
+          <p:cNvPr id="6" name="Text 3"/>
+          <p:cNvSpPr/>
+          <p:nvPr/>
+        </p:nvSpPr>
+        <p:spPr>
+          <a:xfrm>
+            <a:off x="1042416" y="5440680"/>
+            <a:ext cx="10106863" cy="594360"/>
+          </a:xfrm>
+          <a:prstGeom prst="rect">
+            <a:avLst/>
+          </a:prstGeom>
+          <a:noFill/>
+          <a:ln/>
+        </p:spPr>
+        <p:txBody>
+          <a:bodyPr wrap="square" lIns="0" tIns="0" rIns="0" bIns="0" rtlCol="0" anchor="ctr"/>
+          <a:lstStyle/>
+          <a:p>
+            <a:pPr indent="0" marL="0">
+              <a:buNone/>
+            </a:pPr>
+            <a:r>
+              <a:rPr lang="en-US" sz="1600" b="1" dirty="0">
+                <a:solidFill>
+                  <a:srgbClr val="F7F6F2"/>
+                </a:solidFill>
+                <a:latin typeface="Yu Gothic" pitchFamily="34" charset="0"/>
+                <a:ea typeface="Yu Gothic" pitchFamily="34" charset="-122"/>
+                <a:cs typeface="Yu Gothic" pitchFamily="34" charset="-120"/>
+              </a:rPr>
+              <a:t>ご意見をいただきたい点：本命の方向でよいか ／ ほかに検討すべき選択肢はあるか</a:t>
+            </a:r>
+            <a:endParaRPr lang="en-US" sz="1600" dirty="0"/>
+          </a:p>
+        </p:txBody>
+      </p:sp>
     </p:spTree>
   </p:cSld>
   <p:clrMapOvr>

</xml_diff>

<commit_message>
Slide 2: avoid orphan punctuation wrap
Co-Authored-By: Claude Opus 5.5 (1M context) <noreply@anthropic.com>
</commit_message>
<xml_diff>
--- a/results/progress_slides_2026-09.pptx
+++ b/results/progress_slides_2026-09.pptx
@@ -1934,7 +1934,7 @@
                 <a:ea typeface="Yu Gothic" pitchFamily="34" charset="-122"/>
                 <a:cs typeface="Yu Gothic" pitchFamily="34" charset="-120"/>
               </a:rPr>
-              <a:t>。精度はFTが上だが、SEは</a:t>
+              <a:t>。精度はFTが上。SEは</a:t>
             </a:r>
             <a:pPr indent="0" marL="0">
               <a:lnSpc>
@@ -1968,7 +1968,7 @@
                 <a:ea typeface="Yu Gothic" pitchFamily="34" charset="-122"/>
                 <a:cs typeface="Yu Gothic" pitchFamily="34" charset="-120"/>
               </a:rPr>
-              <a:t>のが利点。</a:t>
+              <a:t>のが利点</a:t>
             </a:r>
             <a:endParaRPr lang="en-US" sz="1600" dirty="0"/>
           </a:p>

</xml_diff>

<commit_message>
Slides: drop punctuation topic from screen (moved to Q&A in notes); rebalance slide 4
Co-Authored-By: Claude Opus 5.5 (1M context) <noreply@anthropic.com>
</commit_message>
<xml_diff>
--- a/results/progress_slides_2026-09.pptx
+++ b/results/progress_slides_2026-09.pptx
@@ -513,7 +513,7 @@
 よろしくお願いします。卒論の進捗を報告します。
 タイトルは「ASR損失で学習した喉マイク音声強調の効果と汎化範囲」です。
 今日の話は3つです。1つ目は、今やっている実験で何がわかったか。2つ目は、それを踏まえて、今のやり方を提案手法として押すのは正直行き詰まっている、という現状の評価。3つ目は、その先の方向について相談したいことです。
-先に結論を言うと、卒論に必要な実験はほぼ揃っていて、論文も4ページの形になっています。ただ、途中で評価の方法に問題を見つけたので、数字を全部計算し直しました。その話も正直にします。
+先に結論を言うと、卒論に必要な実験はほぼ揃っていて、論文も4ページの形になっています。
 （目安：30秒）</a:t>
             </a:r>
             <a:endParaRPr lang="en-US" dirty="0"/>
@@ -796,10 +796,12 @@
 わかったことです。細かい数字は省いて、傾向だけお話しします。比べている相手は、すべて元のTAPSのSEです。
 （1行目）まず、学習に使ったWhisper-smallでは、CERは確かに改善しました。テスト用の10話者全員で改善しています。同じWhisper系列のmediumにも改善は持ち越されましたが、小さいbaseでははっきりした差が出ませんでした。
 （2行目）一方で、Whisperとは作りが違うwav2vec2系の音声認識では改善しませんでした。XLS-Rでははっきり悪化し、MMSではほぼ変わりませんでした。
-（3行目）それから、評価の途中で問題を見つけました。TAPSの正解テキストには句読点がないのですが、Whisperは普通、文末に句点を付けます。ASR損失で学習すると、SEはWhisperが句読点を出さなくなるような音を作るようになっていました。評価で句読点をそろえていなかったので、その分が改善として数えられていました。句読点をそろえて計算し直すと改善は小さくなりますが、それでも残ります。
-（4行目）最後に出力の音です。STOIやPESQといった音の品質の指標は、むしろ下がっていました。さらに出力には、250Hz間隔で鋭いピークが並ぶ人工的な成分が現れていました。気導マイクの音にはない成分です。つまり、気導マイクらしい自然な音に近づけているのではなく、Whisperが読みやすい別の音を作っている、ということです。
-（補足：聞かれたら）句読点をそろえたCERで、Whisper-smallはTAPSのSEの0.230から0.196、15%の改善です。改善幅のうち約3分の1が句読点によるものでした。XLS-Rは約26%悪化しています。
-（目安：1分30秒）</a:t>
+（3行目）最後に出力の音です。STOIやPESQといった音の品質の指標は、むしろ下がっていました。さらに出力には、250Hz間隔で鋭いピークが並ぶ人工的な成分が現れていました。気導マイクの音にはない成分です。つまり、気導マイクらしい自然な音に近づけているのではなく、Whisperが読みやすい別の音を作っている、ということです。
+（補足：聞かれたら）Whisper-smallのCERは、TAPSのSEの0.230から0.196で、15%の改善です。XLS-Rは約26%悪化しています。
+（目安：1分15秒）
+【想定質問】
+Q. CERの計算で気をつけたことは？
+A. TAPSの正解テキストには句読点がありません。ASR損失で学習したSEはWhisperが句読点を出さなくなる音を作るので、そのままだと句読点の分が改善に見えてしまいます。そこで正解と認識結果の両方から句読点を除いてからCERを計算しています。上の数字はその値です。</a:t>
             </a:r>
             <a:endParaRPr lang="en-US" dirty="0"/>
           </a:p>
@@ -987,12 +989,12 @@
               <a:rPr lang="en-US" dirty="0"/>
               <a:t>【台本】
 ただ、研究そのものが行き詰まったわけではないと考えています。
-（左のカード）1つ目に、分析の成果としての価値があります。ASR損失で学習するとSEの汎用性が失われること、そしてこういうSEを評価するには、テキストの正規化と、学習に使っていない系列のASRでの評価が必要だということです。さっきお話ししたとおり、「汎用性を失う」こと自体は先行研究と同じ傾向です。新しいと言えるのは、4kHz以上が欠けた喉マイクという条件で確かめたこと、句読点による見かけの改善を定量化したこと、そして出力に現れる250Hz間隔の人工的な成分を分析したことです。卒論や学会発表としては、この分析でまとめられると考えています。
+（左のカード）1つ目に、分析の成果としての価値があります。ASR損失で学習するとSEの汎用性が失われること、そしてこういうSEを評価するには、テキストの正規化と、学習に使っていない系列のASRでの評価が必要だということです。さっきお話ししたとおり、「汎用性を失う」こと自体は先行研究と同じ傾向です。新しいと言えるのは、4kHz以上が欠けた喉マイクという条件で確かめたことと、出力に現れる250Hz間隔の人工的な成分を分析したことです。卒論や学会発表としては、この分析でまとめられると考えています。
 （右のカード）2つ目、こちらの方が大きいのですが、次に何を目指すべきかがはっきりしました。SEの長所である汎用性を保ったまま、ASRに効くSEをどう作るか、です。
 （目安：1分）
 【想定質問】
 Q. 先行研究と同じ結論なら、卒論の新規性は？
-A. 喉マイクへの適用と、句読点による見かけの改善の定量化、それに出力に現れる250Hz間隔の人工的な成分の分析が新しい部分です。</a:t>
+A. 喉マイクへの適用と、出力に現れる250Hz間隔の人工的な成分の分析が新しい部分です。</a:t>
             </a:r>
             <a:endParaRPr lang="en-US" dirty="0"/>
           </a:p>
@@ -1084,7 +1086,7 @@
 次の方向の本命として考えているのは、特定のASRに依存しない、喉マイク用のSEです。
 （動機）実際の現場では、クラウドのAPIや、他のサービスと共用しているASRのように、重みを変えられないASRが多いです。その場合は、ファインチューニングも、今回のようなASR損失での学習もできません。つまり、ASRを選ばないSEしか選択肢がない。ここが、ファインチューニングに対するSEの本当の存在意義だと考えています。
 （手がかり）手がかりは先行研究にあります。WavLMのような自己教師あり学習モデルの表現を損失に使ってSEを学習すると、学習に使っていないASRでも改善した、という報告があります。NTTのSatoらの2025年の論文や、Ravenscroftらの2024年の研究です。特定のASRの出力に合わせるのではなく、音声の表現そのものに近づける方向なので、汎用性を保てる可能性があります。
-（評価の枠組み）評価については、学習に使っていない系列のASRで評価する、句読点をそろえる、といった枠組みを卒論で作ったので、それがそのまま使えます。
+（評価の枠組み）評価については、学習に使っていない系列のASRで、話者ごとに評価する、といった枠組みを卒論で作ったので、それがそのまま使えます。
 （目安：1分15秒）
 【想定質問】
 Q. 自分の実験で、表現に近づける損失は試していないのか？
@@ -3564,7 +3566,7 @@
         </p:nvSpPr>
         <p:spPr>
           <a:xfrm>
-            <a:off x="813816" y="1600200"/>
+            <a:off x="813816" y="1737360"/>
             <a:ext cx="10564063" cy="0"/>
           </a:xfrm>
           <a:prstGeom prst="line">
@@ -3587,8 +3589,8 @@
         </p:nvSpPr>
         <p:spPr>
           <a:xfrm>
-            <a:off x="813816" y="1709928"/>
-            <a:ext cx="2743200" cy="804672"/>
+            <a:off x="813816" y="1847088"/>
+            <a:ext cx="2743200" cy="1152144"/>
           </a:xfrm>
           <a:prstGeom prst="rect">
             <a:avLst/>
@@ -3604,7 +3606,7 @@
               <a:buNone/>
             </a:pPr>
             <a:r>
-              <a:rPr lang="en-US" sz="1700" b="1" dirty="0">
+              <a:rPr lang="en-US" sz="1900" b="1" dirty="0">
                 <a:solidFill>
                   <a:srgbClr val="2F6FB0"/>
                 </a:solidFill>
@@ -3614,7 +3616,7 @@
               </a:rPr>
               <a:t>学習に使ったWhisper</a:t>
             </a:r>
-            <a:endParaRPr lang="en-US" sz="1700" dirty="0"/>
+            <a:endParaRPr lang="en-US" sz="1900" dirty="0"/>
           </a:p>
         </p:txBody>
       </p:sp>
@@ -3626,8 +3628,8 @@
         </p:nvSpPr>
         <p:spPr>
           <a:xfrm>
-            <a:off x="3739896" y="1709928"/>
-            <a:ext cx="7637983" cy="804672"/>
+            <a:off x="3739896" y="1847088"/>
+            <a:ext cx="7637983" cy="1152144"/>
           </a:xfrm>
           <a:prstGeom prst="rect">
             <a:avLst/>
@@ -3641,12 +3643,12 @@
           <a:p>
             <a:pPr indent="0" marL="0">
               <a:lnSpc>
-                <a:spcPct val="130000"/>
+                <a:spcPct val="135000"/>
               </a:lnSpc>
               <a:buNone/>
             </a:pPr>
             <a:r>
-              <a:rPr lang="en-US" sz="1700" dirty="0">
+              <a:rPr lang="en-US" sz="1900" dirty="0">
                 <a:solidFill>
                   <a:srgbClr val="1F2A37"/>
                 </a:solidFill>
@@ -3658,12 +3660,12 @@
             </a:r>
             <a:pPr indent="0" marL="0">
               <a:lnSpc>
-                <a:spcPct val="130000"/>
+                <a:spcPct val="135000"/>
               </a:lnSpc>
               <a:buNone/>
             </a:pPr>
             <a:r>
-              <a:rPr lang="en-US" sz="1700" b="1" dirty="0">
+              <a:rPr lang="en-US" sz="1900" b="1" dirty="0">
                 <a:solidFill>
                   <a:srgbClr val="1F2A37"/>
                 </a:solidFill>
@@ -3675,12 +3677,12 @@
             </a:r>
             <a:pPr indent="0" marL="0">
               <a:lnSpc>
-                <a:spcPct val="130000"/>
+                <a:spcPct val="135000"/>
               </a:lnSpc>
               <a:buNone/>
             </a:pPr>
             <a:r>
-              <a:rPr lang="en-US" sz="1700" dirty="0">
+              <a:rPr lang="en-US" sz="1900" dirty="0">
                 <a:solidFill>
                   <a:srgbClr val="1F2A37"/>
                 </a:solidFill>
@@ -3690,7 +3692,7 @@
               </a:rPr>
               <a:t>。Whisper-mediumにも持ち越されるが、baseでははっきりしない</a:t>
             </a:r>
-            <a:endParaRPr lang="en-US" sz="1700" dirty="0"/>
+            <a:endParaRPr lang="en-US" sz="1900" dirty="0"/>
           </a:p>
         </p:txBody>
       </p:sp>
@@ -3702,7 +3704,7 @@
         </p:nvSpPr>
         <p:spPr>
           <a:xfrm>
-            <a:off x="813816" y="2624328"/>
+            <a:off x="813816" y="3108960"/>
             <a:ext cx="10564063" cy="0"/>
           </a:xfrm>
           <a:prstGeom prst="line">
@@ -3725,8 +3727,8 @@
         </p:nvSpPr>
         <p:spPr>
           <a:xfrm>
-            <a:off x="813816" y="2734056"/>
-            <a:ext cx="2743200" cy="804672"/>
+            <a:off x="813816" y="3218688"/>
+            <a:ext cx="2743200" cy="1152144"/>
           </a:xfrm>
           <a:prstGeom prst="rect">
             <a:avLst/>
@@ -3742,7 +3744,7 @@
               <a:buNone/>
             </a:pPr>
             <a:r>
-              <a:rPr lang="en-US" sz="1700" b="1" dirty="0">
+              <a:rPr lang="en-US" sz="1900" b="1" dirty="0">
                 <a:solidFill>
                   <a:srgbClr val="B45F1E"/>
                 </a:solidFill>
@@ -3752,7 +3754,7 @@
               </a:rPr>
               <a:t>Whisper以外のASR</a:t>
             </a:r>
-            <a:endParaRPr lang="en-US" sz="1700" dirty="0"/>
+            <a:endParaRPr lang="en-US" sz="1900" dirty="0"/>
           </a:p>
         </p:txBody>
       </p:sp>
@@ -3764,8 +3766,8 @@
         </p:nvSpPr>
         <p:spPr>
           <a:xfrm>
-            <a:off x="3739896" y="2734056"/>
-            <a:ext cx="7637983" cy="804672"/>
+            <a:off x="3739896" y="3218688"/>
+            <a:ext cx="7637983" cy="1152144"/>
           </a:xfrm>
           <a:prstGeom prst="rect">
             <a:avLst/>
@@ -3779,12 +3781,12 @@
           <a:p>
             <a:pPr indent="0" marL="0">
               <a:lnSpc>
-                <a:spcPct val="130000"/>
+                <a:spcPct val="135000"/>
               </a:lnSpc>
               <a:buNone/>
             </a:pPr>
             <a:r>
-              <a:rPr lang="en-US" sz="1700" dirty="0">
+              <a:rPr lang="en-US" sz="1900" dirty="0">
                 <a:solidFill>
                   <a:srgbClr val="1F2A37"/>
                 </a:solidFill>
@@ -3796,12 +3798,12 @@
             </a:r>
             <a:pPr indent="0" marL="0">
               <a:lnSpc>
-                <a:spcPct val="130000"/>
+                <a:spcPct val="135000"/>
               </a:lnSpc>
               <a:buNone/>
             </a:pPr>
             <a:r>
-              <a:rPr lang="en-US" sz="1700" b="1" dirty="0">
+              <a:rPr lang="en-US" sz="1900" b="1" dirty="0">
                 <a:solidFill>
                   <a:srgbClr val="1F2A37"/>
                 </a:solidFill>
@@ -3813,12 +3815,12 @@
             </a:r>
             <a:pPr indent="0" marL="0">
               <a:lnSpc>
-                <a:spcPct val="130000"/>
+                <a:spcPct val="135000"/>
               </a:lnSpc>
               <a:buNone/>
             </a:pPr>
             <a:r>
-              <a:rPr lang="en-US" sz="1700" dirty="0">
+              <a:rPr lang="en-US" sz="1900" dirty="0">
                 <a:solidFill>
                   <a:srgbClr val="1F2A37"/>
                 </a:solidFill>
@@ -3828,7 +3830,7 @@
               </a:rPr>
               <a:t>。XLS-Rでははっきり悪化、MMSではほぼ変わらない</a:t>
             </a:r>
-            <a:endParaRPr lang="en-US" sz="1700" dirty="0"/>
+            <a:endParaRPr lang="en-US" sz="1900" dirty="0"/>
           </a:p>
         </p:txBody>
       </p:sp>
@@ -3840,7 +3842,7 @@
         </p:nvSpPr>
         <p:spPr>
           <a:xfrm>
-            <a:off x="813816" y="3648456"/>
+            <a:off x="813816" y="4480560"/>
             <a:ext cx="10564063" cy="0"/>
           </a:xfrm>
           <a:prstGeom prst="line">
@@ -3863,8 +3865,8 @@
         </p:nvSpPr>
         <p:spPr>
           <a:xfrm>
-            <a:off x="813816" y="3758184"/>
-            <a:ext cx="2743200" cy="804672"/>
+            <a:off x="813816" y="4590288"/>
+            <a:ext cx="2743200" cy="1152144"/>
           </a:xfrm>
           <a:prstGeom prst="rect">
             <a:avLst/>
@@ -3880,7 +3882,7 @@
               <a:buNone/>
             </a:pPr>
             <a:r>
-              <a:rPr lang="en-US" sz="1700" b="1" dirty="0">
+              <a:rPr lang="en-US" sz="1900" b="1" dirty="0">
                 <a:solidFill>
                   <a:srgbClr val="1F2A37"/>
                 </a:solidFill>
@@ -3888,9 +3890,9 @@
                 <a:ea typeface="Yu Gothic" pitchFamily="34" charset="-122"/>
                 <a:cs typeface="Yu Gothic" pitchFamily="34" charset="-120"/>
               </a:rPr>
-              <a:t>改善の中身</a:t>
-            </a:r>
-            <a:endParaRPr lang="en-US" sz="1700" dirty="0"/>
+              <a:t>出力の音</a:t>
+            </a:r>
+            <a:endParaRPr lang="en-US" sz="1900" dirty="0"/>
           </a:p>
         </p:txBody>
       </p:sp>
@@ -3902,8 +3904,8 @@
         </p:nvSpPr>
         <p:spPr>
           <a:xfrm>
-            <a:off x="3739896" y="3758184"/>
-            <a:ext cx="7637983" cy="804672"/>
+            <a:off x="3739896" y="4590288"/>
+            <a:ext cx="7637983" cy="1152144"/>
           </a:xfrm>
           <a:prstGeom prst="rect">
             <a:avLst/>
@@ -3917,12 +3919,12 @@
           <a:p>
             <a:pPr indent="0" marL="0">
               <a:lnSpc>
-                <a:spcPct val="130000"/>
+                <a:spcPct val="135000"/>
               </a:lnSpc>
               <a:buNone/>
             </a:pPr>
             <a:r>
-              <a:rPr lang="en-US" sz="1700" dirty="0">
+              <a:rPr lang="en-US" sz="1900" dirty="0">
                 <a:solidFill>
                   <a:srgbClr val="1F2A37"/>
                 </a:solidFill>
@@ -3930,16 +3932,16 @@
                 <a:ea typeface="Yu Gothic" pitchFamily="34" charset="-122"/>
                 <a:cs typeface="Yu Gothic" pitchFamily="34" charset="-120"/>
               </a:rPr>
-              <a:t>一部は、Whisperが</a:t>
+              <a:t>STOI・PESQは下がり、250 Hz間隔の人工的な成分が現れる。気導音声らしい音ではなく、</a:t>
             </a:r>
             <a:pPr indent="0" marL="0">
               <a:lnSpc>
-                <a:spcPct val="130000"/>
+                <a:spcPct val="135000"/>
               </a:lnSpc>
               <a:buNone/>
             </a:pPr>
             <a:r>
-              <a:rPr lang="en-US" sz="1700" b="1" dirty="0">
+              <a:rPr lang="en-US" sz="1900" b="1" dirty="0">
                 <a:solidFill>
                   <a:srgbClr val="1F2A37"/>
                 </a:solidFill>
@@ -3947,16 +3949,16 @@
                 <a:ea typeface="Yu Gothic" pitchFamily="34" charset="-122"/>
                 <a:cs typeface="Yu Gothic" pitchFamily="34" charset="-120"/>
               </a:rPr>
-              <a:t>句読点を出さなくなった</a:t>
+              <a:t>Whisperが読みやすい音</a:t>
             </a:r>
             <a:pPr indent="0" marL="0">
               <a:lnSpc>
-                <a:spcPct val="130000"/>
+                <a:spcPct val="135000"/>
               </a:lnSpc>
               <a:buNone/>
             </a:pPr>
             <a:r>
-              <a:rPr lang="en-US" sz="1700" dirty="0">
+              <a:rPr lang="en-US" sz="1900" dirty="0">
                 <a:solidFill>
                   <a:srgbClr val="1F2A37"/>
                 </a:solidFill>
@@ -3964,9 +3966,9 @@
                 <a:ea typeface="Yu Gothic" pitchFamily="34" charset="-122"/>
                 <a:cs typeface="Yu Gothic" pitchFamily="34" charset="-120"/>
               </a:rPr>
-              <a:t>だけ（正解テキストに句読点がないため）。評価をそろえると改善は小さくなるが、残る</a:t>
-            </a:r>
-            <a:endParaRPr lang="en-US" sz="1700" dirty="0"/>
+              <a:t>を作っている</a:t>
+            </a:r>
+            <a:endParaRPr lang="en-US" sz="1900" dirty="0"/>
           </a:p>
         </p:txBody>
       </p:sp>
@@ -3978,145 +3980,7 @@
         </p:nvSpPr>
         <p:spPr>
           <a:xfrm>
-            <a:off x="813816" y="4672584"/>
-            <a:ext cx="10564063" cy="0"/>
-          </a:xfrm>
-          <a:prstGeom prst="line">
-            <a:avLst/>
-          </a:prstGeom>
-          <a:noFill/>
-          <a:ln w="12700">
-            <a:solidFill>
-              <a:srgbClr val="D8D3C8"/>
-            </a:solidFill>
-            <a:prstDash val="solid"/>
-          </a:ln>
-        </p:spPr>
-      </p:sp>
-      <p:sp>
-        <p:nvSpPr>
-          <p:cNvPr id="14" name="Text 12"/>
-          <p:cNvSpPr/>
-          <p:nvPr/>
-        </p:nvSpPr>
-        <p:spPr>
-          <a:xfrm>
-            <a:off x="813816" y="4782312"/>
-            <a:ext cx="2743200" cy="804672"/>
-          </a:xfrm>
-          <a:prstGeom prst="rect">
-            <a:avLst/>
-          </a:prstGeom>
-          <a:noFill/>
-          <a:ln/>
-        </p:spPr>
-        <p:txBody>
-          <a:bodyPr wrap="square" lIns="0" tIns="0" rIns="0" bIns="0" rtlCol="0" anchor="ctr"/>
-          <a:lstStyle/>
-          <a:p>
-            <a:pPr indent="0" marL="0">
-              <a:buNone/>
-            </a:pPr>
-            <a:r>
-              <a:rPr lang="en-US" sz="1700" b="1" dirty="0">
-                <a:solidFill>
-                  <a:srgbClr val="1F2A37"/>
-                </a:solidFill>
-                <a:latin typeface="Yu Gothic" pitchFamily="34" charset="0"/>
-                <a:ea typeface="Yu Gothic" pitchFamily="34" charset="-122"/>
-                <a:cs typeface="Yu Gothic" pitchFamily="34" charset="-120"/>
-              </a:rPr>
-              <a:t>出力の音</a:t>
-            </a:r>
-            <a:endParaRPr lang="en-US" sz="1700" dirty="0"/>
-          </a:p>
-        </p:txBody>
-      </p:sp>
-      <p:sp>
-        <p:nvSpPr>
-          <p:cNvPr id="15" name="Text 13"/>
-          <p:cNvSpPr/>
-          <p:nvPr/>
-        </p:nvSpPr>
-        <p:spPr>
-          <a:xfrm>
-            <a:off x="3739896" y="4782312"/>
-            <a:ext cx="7637983" cy="804672"/>
-          </a:xfrm>
-          <a:prstGeom prst="rect">
-            <a:avLst/>
-          </a:prstGeom>
-          <a:noFill/>
-          <a:ln/>
-        </p:spPr>
-        <p:txBody>
-          <a:bodyPr wrap="square" lIns="0" tIns="0" rIns="0" bIns="0" rtlCol="0" anchor="ctr"/>
-          <a:lstStyle/>
-          <a:p>
-            <a:pPr indent="0" marL="0">
-              <a:lnSpc>
-                <a:spcPct val="130000"/>
-              </a:lnSpc>
-              <a:buNone/>
-            </a:pPr>
-            <a:r>
-              <a:rPr lang="en-US" sz="1700" dirty="0">
-                <a:solidFill>
-                  <a:srgbClr val="1F2A37"/>
-                </a:solidFill>
-                <a:latin typeface="Yu Gothic" pitchFamily="34" charset="0"/>
-                <a:ea typeface="Yu Gothic" pitchFamily="34" charset="-122"/>
-                <a:cs typeface="Yu Gothic" pitchFamily="34" charset="-120"/>
-              </a:rPr>
-              <a:t>STOI・PESQは下がり、250 Hz間隔の人工的な成分が現れる。気導音声らしい音ではなく、</a:t>
-            </a:r>
-            <a:pPr indent="0" marL="0">
-              <a:lnSpc>
-                <a:spcPct val="130000"/>
-              </a:lnSpc>
-              <a:buNone/>
-            </a:pPr>
-            <a:r>
-              <a:rPr lang="en-US" sz="1700" b="1" dirty="0">
-                <a:solidFill>
-                  <a:srgbClr val="1F2A37"/>
-                </a:solidFill>
-                <a:latin typeface="Yu Gothic" pitchFamily="34" charset="0"/>
-                <a:ea typeface="Yu Gothic" pitchFamily="34" charset="-122"/>
-                <a:cs typeface="Yu Gothic" pitchFamily="34" charset="-120"/>
-              </a:rPr>
-              <a:t>Whisperが読みやすい音</a:t>
-            </a:r>
-            <a:pPr indent="0" marL="0">
-              <a:lnSpc>
-                <a:spcPct val="130000"/>
-              </a:lnSpc>
-              <a:buNone/>
-            </a:pPr>
-            <a:r>
-              <a:rPr lang="en-US" sz="1700" dirty="0">
-                <a:solidFill>
-                  <a:srgbClr val="1F2A37"/>
-                </a:solidFill>
-                <a:latin typeface="Yu Gothic" pitchFamily="34" charset="0"/>
-                <a:ea typeface="Yu Gothic" pitchFamily="34" charset="-122"/>
-                <a:cs typeface="Yu Gothic" pitchFamily="34" charset="-120"/>
-              </a:rPr>
-              <a:t>を作っている</a:t>
-            </a:r>
-            <a:endParaRPr lang="en-US" sz="1700" dirty="0"/>
-          </a:p>
-        </p:txBody>
-      </p:sp>
-      <p:sp>
-        <p:nvSpPr>
-          <p:cNvPr id="16" name="Shape 14"/>
-          <p:cNvSpPr/>
-          <p:nvPr/>
-        </p:nvSpPr>
-        <p:spPr>
-          <a:xfrm>
-            <a:off x="813816" y="5696712"/>
+            <a:off x="813816" y="5852160"/>
             <a:ext cx="10564063" cy="0"/>
           </a:xfrm>
           <a:prstGeom prst="line">
@@ -4876,7 +4740,7 @@
                 <a:ea typeface="Yu Gothic" pitchFamily="34" charset="-122"/>
                 <a:cs typeface="Yu Gothic" pitchFamily="34" charset="-120"/>
               </a:rPr>
-              <a:t>、帯域が欠けた喉マイクでの確認、句読点による見かけの改善の定量化、250 Hz間隔の人工成分の分析</a:t>
+              <a:t>、帯域が欠けた喉マイクでの確認と、出力に現れる250 Hz間隔の人工成分の分析</a:t>
             </a:r>
             <a:endParaRPr lang="en-US" sz="1500" dirty="0"/>
           </a:p>
@@ -5724,7 +5588,7 @@
                 <a:ea typeface="Yu Gothic" pitchFamily="34" charset="-122"/>
                 <a:cs typeface="Yu Gothic" pitchFamily="34" charset="-120"/>
               </a:rPr>
-              <a:t>学習に使っていない系列のASRで評価する、句読点をそろえる。</a:t>
+              <a:t>学習に使っていない系列のASRで、話者ごとに評価する。</a:t>
             </a:r>
             <a:pPr indent="0" marL="0">
               <a:lnSpc>

</xml_diff>

<commit_message>
Slides: save manual edits made in PowerPoint
Co-Authored-By: Claude Opus 5.5 (1M context) <noreply@anthropic.com>
</commit_message>
<xml_diff>
--- a/results/progress_slides_2026-09.pptx
+++ b/results/progress_slides_2026-09.pptx
@@ -4,6 +4,9 @@
   <p:sldMasterIdLst>
     <p:sldMasterId id="2147483648" r:id="rId1"/>
   </p:sldMasterIdLst>
+  <p:notesMasterIdLst>
+    <p:notesMasterId r:id="rId9"/>
+  </p:notesMasterIdLst>
   <p:sldIdLst>
     <p:sldId id="256" r:id="rId2"/>
     <p:sldId id="257" r:id="rId3"/>
@@ -12,11 +15,7 @@
     <p:sldId id="260" r:id="rId6"/>
     <p:sldId id="261" r:id="rId7"/>
     <p:sldId id="262" r:id="rId8"/>
-    <p:sldId id="263" r:id="rId9"/>
   </p:sldIdLst>
-  <p:notesMasterIdLst>
-    <p:notesMasterId r:id="rId10"/>
-  </p:notesMasterIdLst>
   <p:sldSz cx="12192000" cy="6858000"/>
   <p:notesSz cx="6858000" cy="12192000"/>
   <p:defaultTextStyle>
@@ -111,6 +110,11 @@
       </a:defRPr>
     </a:lvl9pPr>
   </p:defaultTextStyle>
+  <p:extLst>
+    <p:ext uri="{EFAFB233-063F-42B5-8137-9DF3F51BA10A}">
+      <p15:sldGuideLst xmlns:p15="http://schemas.microsoft.com/office/powerpoint/2012/main"/>
+    </p:ext>
+  </p:extLst>
 </p:presentation>
 </file>
 
@@ -136,241 +140,17 @@
           <a:chExt cx="0" cy="0"/>
         </a:xfrm>
       </p:grpSpPr>
-      <p:sp>
-        <p:nvSpPr>
-          <p:cNvPr id="2" name="Header Placeholder 1"/>
-          <p:cNvSpPr>
-            <a:spLocks noGrp="1"/>
-          </p:cNvSpPr>
-          <p:nvPr>
-            <p:ph type="hdr" sz="quarter"/>
-          </p:nvPr>
-        </p:nvSpPr>
-        <p:spPr>
-          <a:xfrm>
-            <a:off x="0" y="0"/>
-            <a:ext cx="2971800" cy="458788"/>
-          </a:xfrm>
-          <a:prstGeom prst="rect">
-            <a:avLst/>
-          </a:prstGeom>
-        </p:spPr>
-        <p:txBody>
-          <a:bodyPr vert="horz" lIns="91440" tIns="45720" rIns="91440" bIns="45720" rtlCol="0"/>
-          <a:lstStyle>
-            <a:lvl1pPr algn="l">
-              <a:defRPr sz="1200"/>
-            </a:lvl1pPr>
-          </a:lstStyle>
-          <a:p>
-            <a:endParaRPr lang="en-US"/>
-          </a:p>
-        </p:txBody>
-      </p:sp>
-      <p:sp>
-        <p:nvSpPr>
-          <p:cNvPr id="3" name="Date Placeholder 2"/>
-          <p:cNvSpPr>
-            <a:spLocks noGrp="1"/>
-          </p:cNvSpPr>
-          <p:nvPr>
-            <p:ph type="dt" idx="1"/>
-          </p:nvPr>
-        </p:nvSpPr>
-        <p:spPr>
-          <a:xfrm>
-            <a:off x="3884613" y="0"/>
-            <a:ext cx="2971800" cy="458788"/>
-          </a:xfrm>
-          <a:prstGeom prst="rect">
-            <a:avLst/>
-          </a:prstGeom>
-        </p:spPr>
-        <p:txBody>
-          <a:bodyPr vert="horz" lIns="91440" tIns="45720" rIns="91440" bIns="45720" rtlCol="0"/>
-          <a:lstStyle>
-            <a:lvl1pPr algn="r">
-              <a:defRPr sz="1200"/>
-            </a:lvl1pPr>
-          </a:lstStyle>
-          <a:p>
-            <a:fld id="{5282F153-3F37-0F45-9E97-73ACFA13230C}" type="datetimeFigureOut">
-              <a:rPr lang="en-US"/>
-              <a:t>7/23/19</a:t>
-            </a:fld>
-            <a:endParaRPr lang="en-US"/>
-          </a:p>
-        </p:txBody>
-      </p:sp>
-      <p:sp>
-        <p:nvSpPr>
-          <p:cNvPr id="4" name="Slide Image Placeholder 3"/>
-          <p:cNvSpPr>
-            <a:spLocks noGrp="1" noRot="1" noChangeAspect="1"/>
-          </p:cNvSpPr>
-          <p:nvPr>
-            <p:ph type="sldImg" idx="2"/>
-          </p:nvPr>
-        </p:nvSpPr>
-        <p:spPr>
-          <a:xfrm>
-            <a:off x="685800" y="1143000"/>
-            <a:ext cx="5486400" cy="3086100"/>
-          </a:xfrm>
-          <a:prstGeom prst="rect">
-            <a:avLst/>
-          </a:prstGeom>
-          <a:noFill/>
-          <a:ln w="12700">
-            <a:solidFill>
-              <a:prstClr val="black"/>
-            </a:solidFill>
-          </a:ln>
-        </p:spPr>
-        <p:txBody>
-          <a:bodyPr vert="horz" lIns="91440" tIns="45720" rIns="91440" bIns="45720" rtlCol="0" anchor="ctr"/>
-          <a:lstStyle/>
-          <a:p>
-            <a:endParaRPr lang="en-US"/>
-          </a:p>
-        </p:txBody>
-      </p:sp>
-      <p:sp>
-        <p:nvSpPr>
-          <p:cNvPr id="5" name="Notes Placeholder 4"/>
-          <p:cNvSpPr>
-            <a:spLocks noGrp="1"/>
-          </p:cNvSpPr>
-          <p:nvPr>
-            <p:ph type="body" sz="quarter" idx="3"/>
-          </p:nvPr>
-        </p:nvSpPr>
-        <p:spPr>
-          <a:xfrm>
-            <a:off x="685800" y="4400550"/>
-            <a:ext cx="5486400" cy="3600450"/>
-          </a:xfrm>
-          <a:prstGeom prst="rect">
-            <a:avLst/>
-          </a:prstGeom>
-        </p:spPr>
-        <p:txBody>
-          <a:bodyPr vert="horz" lIns="91440" tIns="45720" rIns="91440" bIns="45720" rtlCol="0"/>
-          <a:lstStyle/>
-          <a:p>
-            <a:pPr lvl="0"/>
-            <a:r>
-              <a:rPr lang="en-US"/>
-              <a:t>Click to edit Master text styles</a:t>
-            </a:r>
-          </a:p>
-          <a:p>
-            <a:pPr lvl="1"/>
-            <a:r>
-              <a:rPr lang="en-US"/>
-              <a:t>Second level</a:t>
-            </a:r>
-          </a:p>
-          <a:p>
-            <a:pPr lvl="2"/>
-            <a:r>
-              <a:rPr lang="en-US"/>
-              <a:t>Third level</a:t>
-            </a:r>
-          </a:p>
-          <a:p>
-            <a:pPr lvl="3"/>
-            <a:r>
-              <a:rPr lang="en-US"/>
-              <a:t>Fourth level</a:t>
-            </a:r>
-          </a:p>
-          <a:p>
-            <a:pPr lvl="4"/>
-            <a:r>
-              <a:rPr lang="en-US"/>
-              <a:t>Fifth level</a:t>
-            </a:r>
-          </a:p>
-        </p:txBody>
-      </p:sp>
-      <p:sp>
-        <p:nvSpPr>
-          <p:cNvPr id="6" name="Footer Placeholder 5"/>
-          <p:cNvSpPr>
-            <a:spLocks noGrp="1"/>
-          </p:cNvSpPr>
-          <p:nvPr>
-            <p:ph type="ftr" sz="quarter" idx="4"/>
-          </p:nvPr>
-        </p:nvSpPr>
-        <p:spPr>
-          <a:xfrm>
-            <a:off x="0" y="8685213"/>
-            <a:ext cx="2971800" cy="458787"/>
-          </a:xfrm>
-          <a:prstGeom prst="rect">
-            <a:avLst/>
-          </a:prstGeom>
-        </p:spPr>
-        <p:txBody>
-          <a:bodyPr vert="horz" lIns="91440" tIns="45720" rIns="91440" bIns="45720" rtlCol="0" anchor="b"/>
-          <a:lstStyle>
-            <a:lvl1pPr algn="l">
-              <a:defRPr sz="1200"/>
-            </a:lvl1pPr>
-          </a:lstStyle>
-          <a:p>
-            <a:endParaRPr lang="en-US"/>
-          </a:p>
-        </p:txBody>
-      </p:sp>
-      <p:sp>
-        <p:nvSpPr>
-          <p:cNvPr id="7" name="Slide Number Placeholder 6"/>
-          <p:cNvSpPr>
-            <a:spLocks noGrp="1"/>
-          </p:cNvSpPr>
-          <p:nvPr>
-            <p:ph type="sldNum" sz="quarter" idx="5"/>
-          </p:nvPr>
-        </p:nvSpPr>
-        <p:spPr>
-          <a:xfrm>
-            <a:off x="3884613" y="8685213"/>
-            <a:ext cx="2971800" cy="458787"/>
-          </a:xfrm>
-          <a:prstGeom prst="rect">
-            <a:avLst/>
-          </a:prstGeom>
-        </p:spPr>
-        <p:txBody>
-          <a:bodyPr vert="horz" lIns="91440" tIns="45720" rIns="91440" bIns="45720" rtlCol="0" anchor="b"/>
-          <a:lstStyle>
-            <a:lvl1pPr algn="r">
-              <a:defRPr sz="1200"/>
-            </a:lvl1pPr>
-          </a:lstStyle>
-          <a:p>
-            <a:fld id="{CE5E9CC1-C706-0F49-92D6-E571CC5EEA8F}" type="slidenum">
-              <a:rPr lang="en-US"/>
-              <a:t>‹#›</a:t>
-            </a:fld>
-            <a:endParaRPr lang="en-US"/>
-          </a:p>
-        </p:txBody>
-      </p:sp>
     </p:spTree>
     <p:extLst>
       <p:ext uri="{BB962C8B-B14F-4D97-AF65-F5344CB8AC3E}">
-        <p14:creationId xmlns:p14="http://schemas.microsoft.com/office/powerpoint/2010/main" val="1024086991"/>
+        <p14:creationId xmlns:p14="http://schemas.microsoft.com/office/powerpoint/2010/main" val="3489668967"/>
       </p:ext>
     </p:extLst>
   </p:cSld>
   <p:clrMap bg1="lt1" tx1="dk1" bg2="lt2" tx2="dk2" accent1="accent1" accent2="accent2" accent3="accent3" accent4="accent4" accent5="accent5" accent6="accent6" hlink="hlink" folHlink="folHlink"/>
   <p:notesStyle>
     <a:lvl1pPr marL="0" algn="l" defTabSz="914400" rtl="0" eaLnBrk="1" latinLnBrk="0" hangingPunct="1">
-      <a:defRPr sz="1200" kern="1200">
+      <a:defRPr kumimoji="1" sz="1200" kern="1200">
         <a:solidFill>
           <a:schemeClr val="tx1"/>
         </a:solidFill>
@@ -380,7 +160,7 @@
       </a:defRPr>
     </a:lvl1pPr>
     <a:lvl2pPr marL="457200" algn="l" defTabSz="914400" rtl="0" eaLnBrk="1" latinLnBrk="0" hangingPunct="1">
-      <a:defRPr sz="1200" kern="1200">
+      <a:defRPr kumimoji="1" sz="1200" kern="1200">
         <a:solidFill>
           <a:schemeClr val="tx1"/>
         </a:solidFill>
@@ -390,7 +170,7 @@
       </a:defRPr>
     </a:lvl2pPr>
     <a:lvl3pPr marL="914400" algn="l" defTabSz="914400" rtl="0" eaLnBrk="1" latinLnBrk="0" hangingPunct="1">
-      <a:defRPr sz="1200" kern="1200">
+      <a:defRPr kumimoji="1" sz="1200" kern="1200">
         <a:solidFill>
           <a:schemeClr val="tx1"/>
         </a:solidFill>
@@ -400,7 +180,7 @@
       </a:defRPr>
     </a:lvl3pPr>
     <a:lvl4pPr marL="1371600" algn="l" defTabSz="914400" rtl="0" eaLnBrk="1" latinLnBrk="0" hangingPunct="1">
-      <a:defRPr sz="1200" kern="1200">
+      <a:defRPr kumimoji="1" sz="1200" kern="1200">
         <a:solidFill>
           <a:schemeClr val="tx1"/>
         </a:solidFill>
@@ -410,7 +190,7 @@
       </a:defRPr>
     </a:lvl4pPr>
     <a:lvl5pPr marL="1828800" algn="l" defTabSz="914400" rtl="0" eaLnBrk="1" latinLnBrk="0" hangingPunct="1">
-      <a:defRPr sz="1200" kern="1200">
+      <a:defRPr kumimoji="1" sz="1200" kern="1200">
         <a:solidFill>
           <a:schemeClr val="tx1"/>
         </a:solidFill>
@@ -420,7 +200,7 @@
       </a:defRPr>
     </a:lvl5pPr>
     <a:lvl6pPr marL="2286000" algn="l" defTabSz="914400" rtl="0" eaLnBrk="1" latinLnBrk="0" hangingPunct="1">
-      <a:defRPr sz="1200" kern="1200">
+      <a:defRPr kumimoji="1" sz="1200" kern="1200">
         <a:solidFill>
           <a:schemeClr val="tx1"/>
         </a:solidFill>
@@ -430,7 +210,7 @@
       </a:defRPr>
     </a:lvl6pPr>
     <a:lvl7pPr marL="2743200" algn="l" defTabSz="914400" rtl="0" eaLnBrk="1" latinLnBrk="0" hangingPunct="1">
-      <a:defRPr sz="1200" kern="1200">
+      <a:defRPr kumimoji="1" sz="1200" kern="1200">
         <a:solidFill>
           <a:schemeClr val="tx1"/>
         </a:solidFill>
@@ -440,7 +220,7 @@
       </a:defRPr>
     </a:lvl7pPr>
     <a:lvl8pPr marL="3200400" algn="l" defTabSz="914400" rtl="0" eaLnBrk="1" latinLnBrk="0" hangingPunct="1">
-      <a:defRPr sz="1200" kern="1200">
+      <a:defRPr kumimoji="1" sz="1200" kern="1200">
         <a:solidFill>
           <a:schemeClr val="tx1"/>
         </a:solidFill>
@@ -450,7 +230,7 @@
       </a:defRPr>
     </a:lvl8pPr>
     <a:lvl9pPr marL="3657600" algn="l" defTabSz="914400" rtl="0" eaLnBrk="1" latinLnBrk="0" hangingPunct="1">
-      <a:defRPr sz="1200" kern="1200">
+      <a:defRPr kumimoji="1" sz="1200" kern="1200">
         <a:solidFill>
           <a:schemeClr val="tx1"/>
         </a:solidFill>
@@ -516,7 +296,6 @@
 先に結論を言うと、卒論に必要な実験はほぼ揃っていて、論文も4ページの形になっています。
 （目安：30秒）</a:t>
             </a:r>
-            <a:endParaRPr lang="en-US" dirty="0"/>
           </a:p>
         </p:txBody>
       </p:sp>
@@ -610,7 +389,6 @@
 （問いを指して）問いは、こうやってASRの損失で学習したSEの改善が、学習に使っていない別のASRにも通用するのか、です。SEの利点が「どのASRにもつなげられること」なので、ここが本質的な問いだと考えています。
 （目安：1分15秒）</a:t>
             </a:r>
-            <a:endParaRPr lang="en-US" dirty="0"/>
           </a:p>
         </p:txBody>
       </p:sp>
@@ -706,7 +484,6 @@
 この仕組みだと、SEはWhisperという特定のモデルに合わせて最適化されます。これが次のスライドの結果につながります。
 （目安：1分15秒）</a:t>
             </a:r>
-            <a:endParaRPr lang="en-US" dirty="0"/>
           </a:p>
         </p:txBody>
       </p:sp>
@@ -803,7 +580,6 @@
 Q. CERの計算で気をつけたことは？
 A. TAPSの正解テキストには句読点がありません。ASR損失で学習したSEはWhisperが句読点を出さなくなる音を作るので、そのままだと句読点の分が改善に見えてしまいます。そこで正解と認識結果の両方から句読点を除いてからCERを計算しています。上の数字はその値です。</a:t>
             </a:r>
-            <a:endParaRPr lang="en-US" dirty="0"/>
           </a:p>
         </p:txBody>
       </p:sp>
@@ -901,7 +677,6 @@
 Q. 学習をやり直せば改善するのでは？
 A. λを大きくするほど、句読点の抑制や、出力に現れる人工的な成分が強くなりました。ASR損失の比重を上げるほどWhisperへの合わせ込みが進む、という構造的な問題だと考えています。</a:t>
             </a:r>
-            <a:endParaRPr lang="en-US" dirty="0"/>
           </a:p>
         </p:txBody>
       </p:sp>
@@ -996,7 +771,6 @@
 Q. 先行研究と同じ結論なら、卒論の新規性は？
 A. 喉マイクへの適用と、出力に現れる250Hz間隔の人工的な成分の分析が新しい部分です。</a:t>
             </a:r>
-            <a:endParaRPr lang="en-US" dirty="0"/>
           </a:p>
         </p:txBody>
       </p:sp>
@@ -1092,7 +866,6 @@
 Q. 自分の実験で、表現に近づける損失は試していないのか？
 A. 比較手法として、気導マイクの音をWhisperに入れたときの表現に近づける損失（Enc L1）を試しました。Whisper以外のASRで悪化はしませんでしたが、どのASRでも改善もせず、元のTAPS SEからほとんど変わりませんでした。なので、Whisperの表現ではなく、自己教師あり学習モデルの表現を使うところから試したいと考えています。</a:t>
             </a:r>
-            <a:endParaRPr lang="en-US" dirty="0"/>
           </a:p>
         </p:txBody>
       </p:sp>
@@ -1114,100 +887,6 @@
             <a:fld id="{F7021451-1387-4CA6-816F-3879F97B5CBC}" type="slidenum">
               <a:rPr lang="en-US"/>
               <a:t>7</a:t>
-            </a:fld>
-            <a:endParaRPr lang="en-US"/>
-          </a:p>
-        </p:txBody>
-      </p:sp>
-    </p:spTree>
-    <p:extLst>
-      <p:ext uri="{BB962C8B-B14F-4D97-AF65-F5344CB8AC3E}">
-        <p14:creationId xmlns:p14="http://schemas.microsoft.com/office/powerpoint/2010/main" val="1024086991"/>
-      </p:ext>
-    </p:extLst>
-  </p:cSld>
-  <p:clrMapOvr>
-    <a:masterClrMapping/>
-  </p:clrMapOvr>
-</p:notes>
-</file>
-
-<file path=ppt/notesSlides/notesSlide8.xml><?xml version="1.0" encoding="utf-8"?>
-<p:notes xmlns:a="http://schemas.openxmlformats.org/drawingml/2006/main" xmlns:r="http://schemas.openxmlformats.org/officeDocument/2006/relationships" xmlns:p="http://schemas.openxmlformats.org/presentationml/2006/main">
-  <p:cSld>
-    <p:spTree>
-      <p:nvGrpSpPr>
-        <p:cNvPr id="1" name=""/>
-        <p:cNvGrpSpPr/>
-        <p:nvPr/>
-      </p:nvGrpSpPr>
-      <p:grpSpPr>
-        <a:xfrm>
-          <a:off x="0" y="0"/>
-          <a:ext cx="0" cy="0"/>
-          <a:chOff x="0" y="0"/>
-          <a:chExt cx="0" cy="0"/>
-        </a:xfrm>
-      </p:grpSpPr>
-      <p:sp>
-        <p:nvSpPr>
-          <p:cNvPr id="2" name="Slide Image Placeholder 1"/>
-          <p:cNvSpPr>
-            <a:spLocks noGrp="1" noRot="1" noChangeAspect="1"/>
-          </p:cNvSpPr>
-          <p:nvPr>
-            <p:ph type="sldImg"/>
-          </p:nvPr>
-        </p:nvSpPr>
-        <p:spPr/>
-      </p:sp>
-      <p:sp>
-        <p:nvSpPr>
-          <p:cNvPr id="3" name="Notes Placeholder 2"/>
-          <p:cNvSpPr>
-            <a:spLocks noGrp="1"/>
-          </p:cNvSpPr>
-          <p:nvPr>
-            <p:ph type="body" idx="1"/>
-          </p:nvPr>
-        </p:nvSpPr>
-        <p:spPr/>
-        <p:txBody>
-          <a:bodyPr/>
-          <a:lstStyle/>
-          <a:p>
-            <a:r>
-              <a:rPr lang="en-US" dirty="0"/>
-              <a:t>【台本】
-本命以外にも、考えられる選択肢を3つ挙げます。
-（1行目）1つ目は、複数のASRの損失を混ぜて学習する方法です。自然な発展ですが、平均的な結果になるだけで、学習に使っていない系列には効かない可能性があります。
-（2行目）2つ目は、雑音のある環境で評価することです。今回の実験は雑音のない収録音声だけでした。喉マイクの本来の強みは騒音に強いことなので、それを活かせます。ただ、データを自分で収録する必要がありますし、競合する研究もあります。
-（3行目）3つ目は、SEとファインチューニングが、それぞれ音声のどこを直しているのかを分析する方向です。分析としては面白いのですが、手法の提案にはなりません。
-以上です。卒論は分析としてまとめ、この先は本命の方向に切り替えたいと考えています。（下の帯を指して）この本命の方向でよいか、また他に考えるべき選択肢があるか、ご意見をいただけるとありがたいです。ありがとうございました。
-（目安：1分）</a:t>
-            </a:r>
-            <a:endParaRPr lang="en-US" dirty="0"/>
-          </a:p>
-        </p:txBody>
-      </p:sp>
-      <p:sp>
-        <p:nvSpPr>
-          <p:cNvPr id="4" name="Slide Number Placeholder 3"/>
-          <p:cNvSpPr>
-            <a:spLocks noGrp="1"/>
-          </p:cNvSpPr>
-          <p:nvPr>
-            <p:ph type="sldNum" sz="quarter" idx="10"/>
-          </p:nvPr>
-        </p:nvSpPr>
-        <p:spPr/>
-        <p:txBody>
-          <a:bodyPr/>
-          <a:lstStyle/>
-          <a:p>
-            <a:fld id="{F7021451-1387-4CA6-816F-3879F97B5CBC}" type="slidenum">
-              <a:rPr lang="en-US"/>
-              <a:t>8</a:t>
             </a:fld>
             <a:endParaRPr lang="en-US"/>
           </a:p>
@@ -1259,6 +938,11 @@
 <file path=ppt/slideMasters/slideMaster1.xml><?xml version="1.0" encoding="utf-8"?>
 <p:sldMaster xmlns:a="http://schemas.openxmlformats.org/drawingml/2006/main" xmlns:r="http://schemas.openxmlformats.org/officeDocument/2006/relationships" xmlns:p="http://schemas.openxmlformats.org/presentationml/2006/main">
   <p:cSld>
+    <p:bg>
+      <p:bgRef idx="1001">
+        <a:schemeClr val="bg1"/>
+      </p:bgRef>
+    </p:bg>
     <p:spTree>
       <p:nvGrpSpPr>
         <p:cNvPr id="1" name=""/>
@@ -1541,6 +1225,7 @@
         <a:solidFill>
           <a:srgbClr val="F7F6F2"/>
         </a:solidFill>
+        <a:effectLst/>
       </p:bgPr>
     </p:bg>
     <p:spTree>
@@ -1581,6 +1266,13 @@
             <a:prstDash val="solid"/>
           </a:ln>
         </p:spPr>
+        <p:txBody>
+          <a:bodyPr/>
+          <a:lstStyle/>
+          <a:p>
+            <a:endParaRPr lang="ja-JP" altLang="en-US"/>
+          </a:p>
+        </p:txBody>
       </p:sp>
       <p:sp>
         <p:nvSpPr>
@@ -1603,11 +1295,11 @@
           <a:bodyPr wrap="square" lIns="0" tIns="0" rIns="0" bIns="0" rtlCol="0" anchor="t"/>
           <a:lstStyle/>
           <a:p>
-            <a:pPr indent="0" marL="0">
-              <a:buNone/>
-            </a:pPr>
-            <a:r>
-              <a:rPr lang="en-US" sz="1500" b="1" spc="200" kern="0" dirty="0">
+            <a:pPr marL="0" indent="0">
+              <a:buNone/>
+            </a:pPr>
+            <a:r>
+              <a:rPr lang="en-US" sz="1500" b="1" kern="0" spc="200" dirty="0">
                 <a:solidFill>
                   <a:srgbClr val="B45F1E"/>
                 </a:solidFill>
@@ -1642,7 +1334,7 @@
           <a:bodyPr wrap="square" lIns="0" tIns="0" rIns="0" bIns="0" rtlCol="0" anchor="t"/>
           <a:lstStyle/>
           <a:p>
-            <a:pPr indent="0" marL="0">
+            <a:pPr marL="0" indent="0">
               <a:lnSpc>
                 <a:spcPct val="110000"/>
               </a:lnSpc>
@@ -1662,7 +1354,7 @@
             <a:endParaRPr lang="en-US" sz="4000" dirty="0"/>
           </a:p>
           <a:p>
-            <a:pPr indent="0" marL="0">
+            <a:pPr marL="0" indent="0">
               <a:lnSpc>
                 <a:spcPct val="110000"/>
               </a:lnSpc>
@@ -1704,7 +1396,7 @@
           <a:bodyPr wrap="square" lIns="0" tIns="0" rIns="0" bIns="0" rtlCol="0" anchor="t"/>
           <a:lstStyle/>
           <a:p>
-            <a:pPr indent="0" marL="0">
+            <a:pPr marL="0" indent="0">
               <a:buNone/>
             </a:pPr>
             <a:r>
@@ -1738,6 +1430,7 @@
         <a:solidFill>
           <a:srgbClr val="F7F6F2"/>
         </a:solidFill>
+        <a:effectLst/>
       </p:bgPr>
     </p:bg>
     <p:spTree>
@@ -1775,7 +1468,7 @@
           <a:bodyPr wrap="square" lIns="0" tIns="0" rIns="0" bIns="0" rtlCol="0" anchor="t"/>
           <a:lstStyle/>
           <a:p>
-            <a:pPr indent="0" marL="0">
+            <a:pPr marL="0" indent="0">
               <a:buNone/>
             </a:pPr>
             <a:r>
@@ -1814,7 +1507,7 @@
           <a:bodyPr wrap="square" lIns="0" tIns="0" rIns="0" bIns="0" rtlCol="0" anchor="t"/>
           <a:lstStyle/>
           <a:p>
-            <a:pPr indent="0" marL="0">
+            <a:pPr marL="0" indent="0">
               <a:buNone/>
             </a:pPr>
             <a:r>
@@ -1853,7 +1546,7 @@
           <a:bodyPr wrap="square" lIns="0" tIns="0" rIns="0" bIns="0" rtlCol="0" anchor="t"/>
           <a:lstStyle/>
           <a:p>
-            <a:pPr indent="0" marL="0">
+            <a:pPr marL="0" indent="0">
               <a:lnSpc>
                 <a:spcPct val="140000"/>
               </a:lnSpc>
@@ -1870,12 +1563,6 @@
               </a:rPr>
               <a:t>喉マイクは騒音に強いが、4 kHz以上がなくASR精度が低い。対策は、ASR自体を学習し直す</a:t>
             </a:r>
-            <a:pPr indent="0" marL="0">
-              <a:lnSpc>
-                <a:spcPct val="140000"/>
-              </a:lnSpc>
-              <a:buNone/>
-            </a:pPr>
             <a:r>
               <a:rPr lang="en-US" sz="1600" b="1" dirty="0">
                 <a:solidFill>
@@ -1887,12 +1574,6 @@
               </a:rPr>
               <a:t>FT</a:t>
             </a:r>
-            <a:pPr indent="0" marL="0">
-              <a:lnSpc>
-                <a:spcPct val="140000"/>
-              </a:lnSpc>
-              <a:buNone/>
-            </a:pPr>
             <a:r>
               <a:rPr lang="en-US" sz="1600" dirty="0">
                 <a:solidFill>
@@ -1904,12 +1585,6 @@
               </a:rPr>
               <a:t>か、前処理で音を直す</a:t>
             </a:r>
-            <a:pPr indent="0" marL="0">
-              <a:lnSpc>
-                <a:spcPct val="140000"/>
-              </a:lnSpc>
-              <a:buNone/>
-            </a:pPr>
             <a:r>
               <a:rPr lang="en-US" sz="1600" b="1" dirty="0">
                 <a:solidFill>
@@ -1921,12 +1596,6 @@
               </a:rPr>
               <a:t>SE</a:t>
             </a:r>
-            <a:pPr indent="0" marL="0">
-              <a:lnSpc>
-                <a:spcPct val="140000"/>
-              </a:lnSpc>
-              <a:buNone/>
-            </a:pPr>
             <a:r>
               <a:rPr lang="en-US" sz="1600" dirty="0">
                 <a:solidFill>
@@ -1938,12 +1607,6 @@
               </a:rPr>
               <a:t>。精度はFTが上。SEは</a:t>
             </a:r>
-            <a:pPr indent="0" marL="0">
-              <a:lnSpc>
-                <a:spcPct val="140000"/>
-              </a:lnSpc>
-              <a:buNone/>
-            </a:pPr>
             <a:r>
               <a:rPr lang="en-US" sz="1600" b="1" dirty="0">
                 <a:solidFill>
@@ -1955,12 +1618,6 @@
               </a:rPr>
               <a:t>どのASRにもつなげられる</a:t>
             </a:r>
-            <a:pPr indent="0" marL="0">
-              <a:lnSpc>
-                <a:spcPct val="140000"/>
-              </a:lnSpc>
-              <a:buNone/>
-            </a:pPr>
             <a:r>
               <a:rPr lang="en-US" sz="1600" dirty="0">
                 <a:solidFill>
@@ -1997,7 +1654,7 @@
           <a:bodyPr wrap="square" lIns="0" tIns="0" rIns="0" bIns="0" rtlCol="0" anchor="t"/>
           <a:lstStyle/>
           <a:p>
-            <a:pPr indent="0" marL="0">
+            <a:pPr marL="0" indent="0">
               <a:buNone/>
             </a:pPr>
             <a:r>
@@ -2036,7 +1693,7 @@
           <a:bodyPr wrap="square" lIns="0" tIns="0" rIns="0" bIns="0" rtlCol="0" anchor="t"/>
           <a:lstStyle/>
           <a:p>
-            <a:pPr indent="0" marL="0">
+            <a:pPr marL="0" indent="0">
               <a:lnSpc>
                 <a:spcPct val="130000"/>
               </a:lnSpc>
@@ -2056,7 +1713,7 @@
             <a:endParaRPr lang="en-US" sz="2000" dirty="0"/>
           </a:p>
           <a:p>
-            <a:pPr indent="0" marL="0">
+            <a:pPr marL="0" indent="0">
               <a:lnSpc>
                 <a:spcPct val="130000"/>
               </a:lnSpc>
@@ -2103,6 +1760,13 @@
             <a:prstDash val="solid"/>
           </a:ln>
         </p:spPr>
+        <p:txBody>
+          <a:bodyPr/>
+          <a:lstStyle/>
+          <a:p>
+            <a:endParaRPr lang="ja-JP" altLang="en-US"/>
+          </a:p>
+        </p:txBody>
       </p:sp>
       <p:sp>
         <p:nvSpPr>
@@ -2125,7 +1789,7 @@
           <a:bodyPr wrap="square" lIns="0" tIns="0" rIns="0" bIns="0" rtlCol="0" anchor="t"/>
           <a:lstStyle/>
           <a:p>
-            <a:pPr indent="0" marL="0">
+            <a:pPr marL="0" indent="0">
               <a:buNone/>
             </a:pPr>
             <a:r>
@@ -2164,7 +1828,7 @@
           <a:bodyPr wrap="square" lIns="0" tIns="0" rIns="0" bIns="0" rtlCol="0" anchor="t"/>
           <a:lstStyle/>
           <a:p>
-            <a:pPr indent="0" marL="0">
+            <a:pPr marL="0" indent="0">
               <a:lnSpc>
                 <a:spcPct val="140000"/>
               </a:lnSpc>
@@ -2181,12 +1845,6 @@
               </a:rPr>
               <a:t>TAPSのSE-Conformerを、</a:t>
             </a:r>
-            <a:pPr indent="0" marL="0">
-              <a:lnSpc>
-                <a:spcPct val="140000"/>
-              </a:lnSpc>
-              <a:buNone/>
-            </a:pPr>
             <a:r>
               <a:rPr lang="en-US" sz="1600" b="1" dirty="0">
                 <a:solidFill>
@@ -2198,12 +1856,6 @@
               </a:rPr>
               <a:t>凍結したWhisper-small</a:t>
             </a:r>
-            <a:pPr indent="0" marL="0">
-              <a:lnSpc>
-                <a:spcPct val="140000"/>
-              </a:lnSpc>
-              <a:buNone/>
-            </a:pPr>
             <a:r>
               <a:rPr lang="en-US" sz="1600" dirty="0">
                 <a:solidFill>
@@ -2240,7 +1892,7 @@
           <a:bodyPr wrap="square" lIns="0" tIns="0" rIns="0" bIns="0" rtlCol="0" anchor="t"/>
           <a:lstStyle/>
           <a:p>
-            <a:pPr indent="0" marL="0">
+            <a:pPr marL="0" indent="0">
               <a:lnSpc>
                 <a:spcPct val="160000"/>
               </a:lnSpc>
@@ -2257,13 +1909,38 @@
               </a:rPr>
               <a:t>ベースライン：</a:t>
             </a:r>
-            <a:pPr indent="0" marL="0">
+            <a:r>
+              <a:rPr lang="en-US" sz="1300" dirty="0">
+                <a:solidFill>
+                  <a:srgbClr val="4A5568"/>
+                </a:solidFill>
+                <a:latin typeface="Yu Gothic" pitchFamily="34" charset="0"/>
+                <a:ea typeface="Yu Gothic" pitchFamily="34" charset="-122"/>
+                <a:cs typeface="Yu Gothic" pitchFamily="34" charset="-120"/>
+              </a:rPr>
+              <a:t>TAPS論文の学習済みSE（以下 TAPS SE）</a:t>
+            </a:r>
+            <a:endParaRPr lang="en-US" sz="1300" dirty="0"/>
+          </a:p>
+          <a:p>
+            <a:pPr marL="0" indent="0">
               <a:lnSpc>
                 <a:spcPct val="160000"/>
               </a:lnSpc>
               <a:buNone/>
             </a:pPr>
             <a:r>
+              <a:rPr lang="en-US" sz="1300" b="1" dirty="0">
+                <a:solidFill>
+                  <a:srgbClr val="4A5568"/>
+                </a:solidFill>
+                <a:latin typeface="Yu Gothic" pitchFamily="34" charset="0"/>
+                <a:ea typeface="Yu Gothic" pitchFamily="34" charset="-122"/>
+                <a:cs typeface="Yu Gothic" pitchFamily="34" charset="-120"/>
+              </a:rPr>
+              <a:t>データ：</a:t>
+            </a:r>
+            <a:r>
               <a:rPr lang="en-US" sz="1300" dirty="0">
                 <a:solidFill>
                   <a:srgbClr val="4A5568"/>
@@ -2272,12 +1949,12 @@
                 <a:ea typeface="Yu Gothic" pitchFamily="34" charset="-122"/>
                 <a:cs typeface="Yu Gothic" pitchFamily="34" charset="-120"/>
               </a:rPr>
-              <a:t>TAPS論文の学習済みSE（以下 TAPS SE）</a:t>
+              <a:t>韓国語TAPS（喉マイク／気導マイクの同時収録）</a:t>
             </a:r>
             <a:endParaRPr lang="en-US" sz="1300" dirty="0"/>
           </a:p>
           <a:p>
-            <a:pPr indent="0" marL="0">
+            <a:pPr marL="0" indent="0">
               <a:lnSpc>
                 <a:spcPct val="160000"/>
               </a:lnSpc>
@@ -2292,51 +1969,8 @@
                 <a:ea typeface="Yu Gothic" pitchFamily="34" charset="-122"/>
                 <a:cs typeface="Yu Gothic" pitchFamily="34" charset="-120"/>
               </a:rPr>
-              <a:t>データ：</a:t>
-            </a:r>
-            <a:pPr indent="0" marL="0">
-              <a:lnSpc>
-                <a:spcPct val="160000"/>
-              </a:lnSpc>
-              <a:buNone/>
-            </a:pPr>
-            <a:r>
-              <a:rPr lang="en-US" sz="1300" dirty="0">
-                <a:solidFill>
-                  <a:srgbClr val="4A5568"/>
-                </a:solidFill>
-                <a:latin typeface="Yu Gothic" pitchFamily="34" charset="0"/>
-                <a:ea typeface="Yu Gothic" pitchFamily="34" charset="-122"/>
-                <a:cs typeface="Yu Gothic" pitchFamily="34" charset="-120"/>
-              </a:rPr>
-              <a:t>韓国語TAPS（喉マイク／気導マイクの同時収録）</a:t>
-            </a:r>
-            <a:endParaRPr lang="en-US" sz="1300" dirty="0"/>
-          </a:p>
-          <a:p>
-            <a:pPr indent="0" marL="0">
-              <a:lnSpc>
-                <a:spcPct val="160000"/>
-              </a:lnSpc>
-              <a:buNone/>
-            </a:pPr>
-            <a:r>
-              <a:rPr lang="en-US" sz="1300" b="1" dirty="0">
-                <a:solidFill>
-                  <a:srgbClr val="4A5568"/>
-                </a:solidFill>
-                <a:latin typeface="Yu Gothic" pitchFamily="34" charset="0"/>
-                <a:ea typeface="Yu Gothic" pitchFamily="34" charset="-122"/>
-                <a:cs typeface="Yu Gothic" pitchFamily="34" charset="-120"/>
-              </a:rPr>
               <a:t>評価：</a:t>
             </a:r>
-            <a:pPr indent="0" marL="0">
-              <a:lnSpc>
-                <a:spcPct val="160000"/>
-              </a:lnSpc>
-              <a:buNone/>
-            </a:pPr>
             <a:r>
               <a:rPr lang="en-US" sz="1300" dirty="0">
                 <a:solidFill>
@@ -2368,6 +2002,7 @@
         <a:solidFill>
           <a:srgbClr val="F7F6F2"/>
         </a:solidFill>
+        <a:effectLst/>
       </p:bgPr>
     </p:bg>
     <p:spTree>
@@ -2405,7 +2040,7 @@
           <a:bodyPr wrap="square" lIns="0" tIns="0" rIns="0" bIns="0" rtlCol="0" anchor="t"/>
           <a:lstStyle/>
           <a:p>
-            <a:pPr indent="0" marL="0">
+            <a:pPr marL="0" indent="0">
               <a:buNone/>
             </a:pPr>
             <a:r>
@@ -2449,6 +2084,13 @@
             <a:prstDash val="solid"/>
           </a:ln>
         </p:spPr>
+        <p:txBody>
+          <a:bodyPr/>
+          <a:lstStyle/>
+          <a:p>
+            <a:endParaRPr lang="ja-JP" altLang="en-US"/>
+          </a:p>
+        </p:txBody>
       </p:sp>
       <p:sp>
         <p:nvSpPr>
@@ -2471,7 +2113,7 @@
           <a:bodyPr wrap="square" lIns="0" tIns="0" rIns="0" bIns="0" rtlCol="0" anchor="ctr"/>
           <a:lstStyle/>
           <a:p>
-            <a:pPr algn="ctr" indent="0" marL="0">
+            <a:pPr marL="0" indent="0" algn="ctr">
               <a:buNone/>
             </a:pPr>
             <a:r>
@@ -2513,6 +2155,13 @@
             <a:prstDash val="solid"/>
           </a:ln>
         </p:spPr>
+        <p:txBody>
+          <a:bodyPr/>
+          <a:lstStyle/>
+          <a:p>
+            <a:endParaRPr lang="ja-JP" altLang="en-US"/>
+          </a:p>
+        </p:txBody>
       </p:sp>
       <p:sp>
         <p:nvSpPr>
@@ -2540,6 +2189,13 @@
             <a:prstDash val="solid"/>
           </a:ln>
         </p:spPr>
+        <p:txBody>
+          <a:bodyPr/>
+          <a:lstStyle/>
+          <a:p>
+            <a:endParaRPr lang="ja-JP" altLang="en-US"/>
+          </a:p>
+        </p:txBody>
       </p:sp>
       <p:sp>
         <p:nvSpPr>
@@ -2562,7 +2218,7 @@
           <a:bodyPr wrap="square" lIns="0" tIns="0" rIns="0" bIns="0" rtlCol="0" anchor="ctr"/>
           <a:lstStyle/>
           <a:p>
-            <a:pPr algn="ctr" indent="0" marL="0">
+            <a:pPr marL="0" indent="0" algn="ctr">
               <a:buNone/>
             </a:pPr>
             <a:r>
@@ -2579,7 +2235,7 @@
             <a:endParaRPr lang="en-US" sz="1300" dirty="0"/>
           </a:p>
           <a:p>
-            <a:pPr algn="ctr" indent="0" marL="0">
+            <a:pPr marL="0" indent="0" algn="ctr">
               <a:buNone/>
             </a:pPr>
             <a:r>
@@ -2621,6 +2277,13 @@
             <a:prstDash val="solid"/>
           </a:ln>
         </p:spPr>
+        <p:txBody>
+          <a:bodyPr/>
+          <a:lstStyle/>
+          <a:p>
+            <a:endParaRPr lang="ja-JP" altLang="en-US"/>
+          </a:p>
+        </p:txBody>
       </p:sp>
       <p:sp>
         <p:nvSpPr>
@@ -2648,6 +2311,13 @@
             <a:prstDash val="solid"/>
           </a:ln>
         </p:spPr>
+        <p:txBody>
+          <a:bodyPr/>
+          <a:lstStyle/>
+          <a:p>
+            <a:endParaRPr lang="ja-JP" altLang="en-US"/>
+          </a:p>
+        </p:txBody>
       </p:sp>
       <p:sp>
         <p:nvSpPr>
@@ -2670,7 +2340,7 @@
           <a:bodyPr wrap="square" lIns="0" tIns="0" rIns="0" bIns="0" rtlCol="0" anchor="ctr"/>
           <a:lstStyle/>
           <a:p>
-            <a:pPr algn="ctr" indent="0" marL="0">
+            <a:pPr marL="0" indent="0" algn="ctr">
               <a:buNone/>
             </a:pPr>
             <a:r>
@@ -2687,7 +2357,7 @@
             <a:endParaRPr lang="en-US" sz="1300" dirty="0"/>
           </a:p>
           <a:p>
-            <a:pPr algn="ctr" indent="0" marL="0">
+            <a:pPr marL="0" indent="0" algn="ctr">
               <a:buNone/>
             </a:pPr>
             <a:r>
@@ -2729,6 +2399,13 @@
             <a:prstDash val="solid"/>
           </a:ln>
         </p:spPr>
+        <p:txBody>
+          <a:bodyPr/>
+          <a:lstStyle/>
+          <a:p>
+            <a:endParaRPr lang="ja-JP" altLang="en-US"/>
+          </a:p>
+        </p:txBody>
       </p:sp>
       <p:sp>
         <p:nvSpPr>
@@ -2756,6 +2433,13 @@
             <a:prstDash val="solid"/>
           </a:ln>
         </p:spPr>
+        <p:txBody>
+          <a:bodyPr/>
+          <a:lstStyle/>
+          <a:p>
+            <a:endParaRPr lang="ja-JP" altLang="en-US"/>
+          </a:p>
+        </p:txBody>
       </p:sp>
       <p:sp>
         <p:nvSpPr>
@@ -2778,7 +2462,7 @@
           <a:bodyPr wrap="square" lIns="0" tIns="0" rIns="0" bIns="0" rtlCol="0" anchor="ctr"/>
           <a:lstStyle/>
           <a:p>
-            <a:pPr algn="ctr" indent="0" marL="0">
+            <a:pPr marL="0" indent="0" algn="ctr">
               <a:buNone/>
             </a:pPr>
             <a:r>
@@ -2795,7 +2479,7 @@
             <a:endParaRPr lang="en-US" sz="1300" dirty="0"/>
           </a:p>
           <a:p>
-            <a:pPr algn="ctr" indent="0" marL="0">
+            <a:pPr marL="0" indent="0" algn="ctr">
               <a:buNone/>
             </a:pPr>
             <a:r>
@@ -2837,6 +2521,13 @@
             <a:prstDash val="solid"/>
           </a:ln>
         </p:spPr>
+        <p:txBody>
+          <a:bodyPr/>
+          <a:lstStyle/>
+          <a:p>
+            <a:endParaRPr lang="ja-JP" altLang="en-US"/>
+          </a:p>
+        </p:txBody>
       </p:sp>
       <p:sp>
         <p:nvSpPr>
@@ -2864,6 +2555,13 @@
             <a:prstDash val="solid"/>
           </a:ln>
         </p:spPr>
+        <p:txBody>
+          <a:bodyPr/>
+          <a:lstStyle/>
+          <a:p>
+            <a:endParaRPr lang="ja-JP" altLang="en-US"/>
+          </a:p>
+        </p:txBody>
       </p:sp>
       <p:sp>
         <p:nvSpPr>
@@ -2886,7 +2584,7 @@
           <a:bodyPr wrap="square" lIns="0" tIns="0" rIns="0" bIns="0" rtlCol="0" anchor="ctr"/>
           <a:lstStyle/>
           <a:p>
-            <a:pPr algn="ctr" indent="0" marL="0">
+            <a:pPr marL="0" indent="0" algn="ctr">
               <a:buNone/>
             </a:pPr>
             <a:r>
@@ -2903,7 +2601,7 @@
             <a:endParaRPr lang="en-US" sz="1300" dirty="0"/>
           </a:p>
           <a:p>
-            <a:pPr algn="ctr" indent="0" marL="0">
+            <a:pPr marL="0" indent="0" algn="ctr">
               <a:buNone/>
             </a:pPr>
             <a:r>
@@ -2945,6 +2643,13 @@
             <a:prstDash val="solid"/>
           </a:ln>
         </p:spPr>
+        <p:txBody>
+          <a:bodyPr/>
+          <a:lstStyle/>
+          <a:p>
+            <a:endParaRPr lang="ja-JP" altLang="en-US"/>
+          </a:p>
+        </p:txBody>
       </p:sp>
       <p:sp>
         <p:nvSpPr>
@@ -2970,6 +2675,13 @@
             <a:prstDash val="solid"/>
           </a:ln>
         </p:spPr>
+        <p:txBody>
+          <a:bodyPr/>
+          <a:lstStyle/>
+          <a:p>
+            <a:endParaRPr lang="ja-JP" altLang="en-US"/>
+          </a:p>
+        </p:txBody>
       </p:sp>
       <p:sp>
         <p:nvSpPr>
@@ -2992,7 +2704,7 @@
           <a:bodyPr wrap="square" lIns="0" tIns="0" rIns="0" bIns="0" rtlCol="0" anchor="t"/>
           <a:lstStyle/>
           <a:p>
-            <a:pPr indent="0" marL="0">
+            <a:pPr marL="0" indent="0">
               <a:buNone/>
             </a:pPr>
             <a:r>
@@ -3031,7 +2743,7 @@
           <a:bodyPr wrap="square" lIns="0" tIns="0" rIns="0" bIns="0" rtlCol="0" anchor="t"/>
           <a:lstStyle/>
           <a:p>
-            <a:pPr indent="0" marL="0">
+            <a:pPr marL="0" indent="0">
               <a:lnSpc>
                 <a:spcPct val="135000"/>
               </a:lnSpc>
@@ -3076,6 +2788,13 @@
             <a:prstDash val="solid"/>
           </a:ln>
         </p:spPr>
+        <p:txBody>
+          <a:bodyPr/>
+          <a:lstStyle/>
+          <a:p>
+            <a:endParaRPr lang="ja-JP" altLang="en-US"/>
+          </a:p>
+        </p:txBody>
       </p:sp>
       <p:sp>
         <p:nvSpPr>
@@ -3101,6 +2820,13 @@
             <a:prstDash val="solid"/>
           </a:ln>
         </p:spPr>
+        <p:txBody>
+          <a:bodyPr/>
+          <a:lstStyle/>
+          <a:p>
+            <a:endParaRPr lang="ja-JP" altLang="en-US"/>
+          </a:p>
+        </p:txBody>
       </p:sp>
       <p:sp>
         <p:nvSpPr>
@@ -3123,7 +2849,7 @@
           <a:bodyPr wrap="square" lIns="0" tIns="0" rIns="0" bIns="0" rtlCol="0" anchor="t"/>
           <a:lstStyle/>
           <a:p>
-            <a:pPr indent="0" marL="0">
+            <a:pPr marL="0" indent="0">
               <a:buNone/>
             </a:pPr>
             <a:r>
@@ -3162,7 +2888,7 @@
           <a:bodyPr wrap="square" lIns="0" tIns="0" rIns="0" bIns="0" rtlCol="0" anchor="t"/>
           <a:lstStyle/>
           <a:p>
-            <a:pPr indent="0" marL="0">
+            <a:pPr marL="0" indent="0">
               <a:lnSpc>
                 <a:spcPct val="135000"/>
               </a:lnSpc>
@@ -3179,12 +2905,6 @@
               </a:rPr>
               <a:t>正解テキストをWhisperのトークン列にし、1つ前までの</a:t>
             </a:r>
-            <a:pPr indent="0" marL="0">
-              <a:lnSpc>
-                <a:spcPct val="135000"/>
-              </a:lnSpc>
-              <a:buNone/>
-            </a:pPr>
             <a:r>
               <a:rPr lang="en-US" sz="1300" b="1" dirty="0">
                 <a:solidFill>
@@ -3196,12 +2916,6 @@
               </a:rPr>
               <a:t>正解</a:t>
             </a:r>
-            <a:pPr indent="0" marL="0">
-              <a:lnSpc>
-                <a:spcPct val="135000"/>
-              </a:lnSpc>
-              <a:buNone/>
-            </a:pPr>
             <a:r>
               <a:rPr lang="en-US" sz="1300" dirty="0">
                 <a:solidFill>
@@ -3213,12 +2927,6 @@
               </a:rPr>
               <a:t>を与えて次のトークンを予測させる（teacher forcing）。正解トークンの確率の −log を全トークンで平均。</a:t>
             </a:r>
-            <a:pPr indent="0" marL="0">
-              <a:lnSpc>
-                <a:spcPct val="135000"/>
-              </a:lnSpc>
-              <a:buNone/>
-            </a:pPr>
             <a:r>
               <a:rPr lang="en-US" sz="1300" b="1" dirty="0">
                 <a:solidFill>
@@ -3230,12 +2938,6 @@
               </a:rPr>
               <a:t>Whisperが正解を書き起こしやすい音</a:t>
             </a:r>
-            <a:pPr indent="0" marL="0">
-              <a:lnSpc>
-                <a:spcPct val="135000"/>
-              </a:lnSpc>
-              <a:buNone/>
-            </a:pPr>
             <a:r>
               <a:rPr lang="en-US" sz="1300" dirty="0">
                 <a:solidFill>
@@ -3275,6 +2977,13 @@
             <a:prstDash val="solid"/>
           </a:ln>
         </p:spPr>
+        <p:txBody>
+          <a:bodyPr/>
+          <a:lstStyle/>
+          <a:p>
+            <a:endParaRPr lang="ja-JP" altLang="en-US"/>
+          </a:p>
+        </p:txBody>
       </p:sp>
       <p:sp>
         <p:nvSpPr>
@@ -3300,6 +3009,13 @@
             <a:prstDash val="solid"/>
           </a:ln>
         </p:spPr>
+        <p:txBody>
+          <a:bodyPr/>
+          <a:lstStyle/>
+          <a:p>
+            <a:endParaRPr lang="ja-JP" altLang="en-US"/>
+          </a:p>
+        </p:txBody>
       </p:sp>
       <p:sp>
         <p:nvSpPr>
@@ -3322,7 +3038,7 @@
           <a:bodyPr wrap="square" lIns="0" tIns="0" rIns="0" bIns="0" rtlCol="0" anchor="t"/>
           <a:lstStyle/>
           <a:p>
-            <a:pPr indent="0" marL="0">
+            <a:pPr marL="0" indent="0">
               <a:buNone/>
             </a:pPr>
             <a:r>
@@ -3361,7 +3077,7 @@
           <a:bodyPr wrap="square" lIns="0" tIns="0" rIns="0" bIns="0" rtlCol="0" anchor="t"/>
           <a:lstStyle/>
           <a:p>
-            <a:pPr indent="0" marL="0">
+            <a:pPr marL="0" indent="0">
               <a:lnSpc>
                 <a:spcPct val="135000"/>
               </a:lnSpc>
@@ -3408,6 +3124,13 @@
             <a:prstDash val="solid"/>
           </a:ln>
         </p:spPr>
+        <p:txBody>
+          <a:bodyPr/>
+          <a:lstStyle/>
+          <a:p>
+            <a:endParaRPr lang="ja-JP" altLang="en-US"/>
+          </a:p>
+        </p:txBody>
       </p:sp>
       <p:sp>
         <p:nvSpPr>
@@ -3430,7 +3153,7 @@
           <a:bodyPr wrap="square" lIns="0" tIns="0" rIns="0" bIns="0" rtlCol="0" anchor="ctr"/>
           <a:lstStyle/>
           <a:p>
-            <a:pPr indent="0" marL="0">
+            <a:pPr marL="0" indent="0">
               <a:buNone/>
             </a:pPr>
             <a:r>
@@ -3464,6 +3187,7 @@
         <a:solidFill>
           <a:srgbClr val="F7F6F2"/>
         </a:solidFill>
+        <a:effectLst/>
       </p:bgPr>
     </p:bg>
     <p:spTree>
@@ -3501,7 +3225,7 @@
           <a:bodyPr wrap="square" lIns="0" tIns="0" rIns="0" bIns="0" rtlCol="0" anchor="t"/>
           <a:lstStyle/>
           <a:p>
-            <a:pPr indent="0" marL="0">
+            <a:pPr marL="0" indent="0">
               <a:buNone/>
             </a:pPr>
             <a:r>
@@ -3540,7 +3264,7 @@
           <a:bodyPr wrap="square" lIns="0" tIns="0" rIns="0" bIns="0" rtlCol="0" anchor="t"/>
           <a:lstStyle/>
           <a:p>
-            <a:pPr indent="0" marL="0">
+            <a:pPr marL="0" indent="0">
               <a:buNone/>
             </a:pPr>
             <a:r>
@@ -3580,6 +3304,13 @@
             <a:prstDash val="solid"/>
           </a:ln>
         </p:spPr>
+        <p:txBody>
+          <a:bodyPr/>
+          <a:lstStyle/>
+          <a:p>
+            <a:endParaRPr lang="ja-JP" altLang="en-US"/>
+          </a:p>
+        </p:txBody>
       </p:sp>
       <p:sp>
         <p:nvSpPr>
@@ -3602,7 +3333,7 @@
           <a:bodyPr wrap="square" lIns="0" tIns="0" rIns="0" bIns="0" rtlCol="0" anchor="ctr"/>
           <a:lstStyle/>
           <a:p>
-            <a:pPr indent="0" marL="0">
+            <a:pPr marL="0" indent="0">
               <a:buNone/>
             </a:pPr>
             <a:r>
@@ -3641,7 +3372,7 @@
           <a:bodyPr wrap="square" lIns="0" tIns="0" rIns="0" bIns="0" rtlCol="0" anchor="ctr"/>
           <a:lstStyle/>
           <a:p>
-            <a:pPr indent="0" marL="0">
+            <a:pPr marL="0" indent="0">
               <a:lnSpc>
                 <a:spcPct val="135000"/>
               </a:lnSpc>
@@ -3658,12 +3389,6 @@
               </a:rPr>
               <a:t>CERは</a:t>
             </a:r>
-            <a:pPr indent="0" marL="0">
-              <a:lnSpc>
-                <a:spcPct val="135000"/>
-              </a:lnSpc>
-              <a:buNone/>
-            </a:pPr>
             <a:r>
               <a:rPr lang="en-US" sz="1900" b="1" dirty="0">
                 <a:solidFill>
@@ -3675,12 +3400,6 @@
               </a:rPr>
               <a:t>改善する</a:t>
             </a:r>
-            <a:pPr indent="0" marL="0">
-              <a:lnSpc>
-                <a:spcPct val="135000"/>
-              </a:lnSpc>
-              <a:buNone/>
-            </a:pPr>
             <a:r>
               <a:rPr lang="en-US" sz="1900" dirty="0">
                 <a:solidFill>
@@ -3718,6 +3437,13 @@
             <a:prstDash val="solid"/>
           </a:ln>
         </p:spPr>
+        <p:txBody>
+          <a:bodyPr/>
+          <a:lstStyle/>
+          <a:p>
+            <a:endParaRPr lang="ja-JP" altLang="en-US"/>
+          </a:p>
+        </p:txBody>
       </p:sp>
       <p:sp>
         <p:nvSpPr>
@@ -3740,7 +3466,7 @@
           <a:bodyPr wrap="square" lIns="0" tIns="0" rIns="0" bIns="0" rtlCol="0" anchor="ctr"/>
           <a:lstStyle/>
           <a:p>
-            <a:pPr indent="0" marL="0">
+            <a:pPr marL="0" indent="0">
               <a:buNone/>
             </a:pPr>
             <a:r>
@@ -3779,7 +3505,7 @@
           <a:bodyPr wrap="square" lIns="0" tIns="0" rIns="0" bIns="0" rtlCol="0" anchor="ctr"/>
           <a:lstStyle/>
           <a:p>
-            <a:pPr indent="0" marL="0">
+            <a:pPr marL="0" indent="0">
               <a:lnSpc>
                 <a:spcPct val="135000"/>
               </a:lnSpc>
@@ -3796,12 +3522,6 @@
               </a:rPr>
               <a:t>wav2vec2系では</a:t>
             </a:r>
-            <a:pPr indent="0" marL="0">
-              <a:lnSpc>
-                <a:spcPct val="135000"/>
-              </a:lnSpc>
-              <a:buNone/>
-            </a:pPr>
             <a:r>
               <a:rPr lang="en-US" sz="1900" b="1" dirty="0">
                 <a:solidFill>
@@ -3813,12 +3533,6 @@
               </a:rPr>
               <a:t>改善しない</a:t>
             </a:r>
-            <a:pPr indent="0" marL="0">
-              <a:lnSpc>
-                <a:spcPct val="135000"/>
-              </a:lnSpc>
-              <a:buNone/>
-            </a:pPr>
             <a:r>
               <a:rPr lang="en-US" sz="1900" dirty="0">
                 <a:solidFill>
@@ -3856,6 +3570,13 @@
             <a:prstDash val="solid"/>
           </a:ln>
         </p:spPr>
+        <p:txBody>
+          <a:bodyPr/>
+          <a:lstStyle/>
+          <a:p>
+            <a:endParaRPr lang="ja-JP" altLang="en-US"/>
+          </a:p>
+        </p:txBody>
       </p:sp>
       <p:sp>
         <p:nvSpPr>
@@ -3878,7 +3599,7 @@
           <a:bodyPr wrap="square" lIns="0" tIns="0" rIns="0" bIns="0" rtlCol="0" anchor="ctr"/>
           <a:lstStyle/>
           <a:p>
-            <a:pPr indent="0" marL="0">
+            <a:pPr marL="0" indent="0">
               <a:buNone/>
             </a:pPr>
             <a:r>
@@ -3917,7 +3638,7 @@
           <a:bodyPr wrap="square" lIns="0" tIns="0" rIns="0" bIns="0" rtlCol="0" anchor="ctr"/>
           <a:lstStyle/>
           <a:p>
-            <a:pPr indent="0" marL="0">
+            <a:pPr marL="0" indent="0">
               <a:lnSpc>
                 <a:spcPct val="135000"/>
               </a:lnSpc>
@@ -3934,12 +3655,6 @@
               </a:rPr>
               <a:t>STOI・PESQは下がり、250 Hz間隔の人工的な成分が現れる。気導音声らしい音ではなく、</a:t>
             </a:r>
-            <a:pPr indent="0" marL="0">
-              <a:lnSpc>
-                <a:spcPct val="135000"/>
-              </a:lnSpc>
-              <a:buNone/>
-            </a:pPr>
             <a:r>
               <a:rPr lang="en-US" sz="1900" b="1" dirty="0">
                 <a:solidFill>
@@ -3951,12 +3666,6 @@
               </a:rPr>
               <a:t>Whisperが読みやすい音</a:t>
             </a:r>
-            <a:pPr indent="0" marL="0">
-              <a:lnSpc>
-                <a:spcPct val="135000"/>
-              </a:lnSpc>
-              <a:buNone/>
-            </a:pPr>
             <a:r>
               <a:rPr lang="en-US" sz="1900" dirty="0">
                 <a:solidFill>
@@ -3994,6 +3703,13 @@
             <a:prstDash val="solid"/>
           </a:ln>
         </p:spPr>
+        <p:txBody>
+          <a:bodyPr/>
+          <a:lstStyle/>
+          <a:p>
+            <a:endParaRPr lang="ja-JP" altLang="en-US"/>
+          </a:p>
+        </p:txBody>
       </p:sp>
     </p:spTree>
   </p:cSld>
@@ -4011,6 +3727,7 @@
         <a:solidFill>
           <a:srgbClr val="1F2A37"/>
         </a:solidFill>
+        <a:effectLst/>
       </p:bgPr>
     </p:bg>
     <p:spTree>
@@ -4048,11 +3765,11 @@
           <a:bodyPr wrap="square" lIns="0" tIns="0" rIns="0" bIns="0" rtlCol="0" anchor="t"/>
           <a:lstStyle/>
           <a:p>
-            <a:pPr indent="0" marL="0">
-              <a:buNone/>
-            </a:pPr>
-            <a:r>
-              <a:rPr lang="en-US" sz="1500" b="1" spc="200" kern="0" dirty="0">
+            <a:pPr marL="0" indent="0">
+              <a:buNone/>
+            </a:pPr>
+            <a:r>
+              <a:rPr lang="en-US" sz="1500" b="1" kern="0" spc="200" dirty="0">
                 <a:solidFill>
                   <a:srgbClr val="E8A365"/>
                 </a:solidFill>
@@ -4087,7 +3804,7 @@
           <a:bodyPr wrap="square" lIns="0" tIns="0" rIns="0" bIns="0" rtlCol="0" anchor="t"/>
           <a:lstStyle/>
           <a:p>
-            <a:pPr indent="0" marL="0">
+            <a:pPr marL="0" indent="0">
               <a:buNone/>
             </a:pPr>
             <a:r>
@@ -4131,6 +3848,13 @@
             <a:prstDash val="solid"/>
           </a:ln>
         </p:spPr>
+        <p:txBody>
+          <a:bodyPr/>
+          <a:lstStyle/>
+          <a:p>
+            <a:endParaRPr lang="ja-JP" altLang="en-US"/>
+          </a:p>
+        </p:txBody>
       </p:sp>
       <p:sp>
         <p:nvSpPr>
@@ -4153,7 +3877,7 @@
           <a:bodyPr wrap="square" lIns="0" tIns="0" rIns="0" bIns="0" rtlCol="0" anchor="t"/>
           <a:lstStyle/>
           <a:p>
-            <a:pPr indent="0" marL="0">
+            <a:pPr marL="0" indent="0">
               <a:buNone/>
             </a:pPr>
             <a:r>
@@ -4192,7 +3916,7 @@
           <a:bodyPr wrap="square" lIns="0" tIns="0" rIns="0" bIns="0" rtlCol="0" anchor="t"/>
           <a:lstStyle/>
           <a:p>
-            <a:pPr indent="0" marL="0">
+            <a:pPr marL="0" indent="0">
               <a:lnSpc>
                 <a:spcPct val="140000"/>
               </a:lnSpc>
@@ -4239,6 +3963,13 @@
             <a:prstDash val="solid"/>
           </a:ln>
         </p:spPr>
+        <p:txBody>
+          <a:bodyPr/>
+          <a:lstStyle/>
+          <a:p>
+            <a:endParaRPr lang="ja-JP" altLang="en-US"/>
+          </a:p>
+        </p:txBody>
       </p:sp>
       <p:sp>
         <p:nvSpPr>
@@ -4261,7 +3992,7 @@
           <a:bodyPr wrap="square" lIns="0" tIns="0" rIns="0" bIns="0" rtlCol="0" anchor="t"/>
           <a:lstStyle/>
           <a:p>
-            <a:pPr indent="0" marL="0">
+            <a:pPr marL="0" indent="0">
               <a:buNone/>
             </a:pPr>
             <a:r>
@@ -4300,7 +4031,7 @@
           <a:bodyPr wrap="square" lIns="0" tIns="0" rIns="0" bIns="0" rtlCol="0" anchor="t"/>
           <a:lstStyle/>
           <a:p>
-            <a:pPr indent="0" marL="0">
+            <a:pPr marL="0" indent="0">
               <a:lnSpc>
                 <a:spcPct val="140000"/>
               </a:lnSpc>
@@ -4347,6 +4078,13 @@
             <a:prstDash val="solid"/>
           </a:ln>
         </p:spPr>
+        <p:txBody>
+          <a:bodyPr/>
+          <a:lstStyle/>
+          <a:p>
+            <a:endParaRPr lang="ja-JP" altLang="en-US"/>
+          </a:p>
+        </p:txBody>
       </p:sp>
       <p:sp>
         <p:nvSpPr>
@@ -4369,7 +4107,7 @@
           <a:bodyPr wrap="square" lIns="0" tIns="0" rIns="0" bIns="0" rtlCol="0" anchor="t"/>
           <a:lstStyle/>
           <a:p>
-            <a:pPr indent="0" marL="0">
+            <a:pPr marL="0" indent="0">
               <a:buNone/>
             </a:pPr>
             <a:r>
@@ -4408,7 +4146,7 @@
           <a:bodyPr wrap="square" lIns="0" tIns="0" rIns="0" bIns="0" rtlCol="0" anchor="t"/>
           <a:lstStyle/>
           <a:p>
-            <a:pPr indent="0" marL="0">
+            <a:pPr marL="0" indent="0">
               <a:lnSpc>
                 <a:spcPct val="140000"/>
               </a:lnSpc>
@@ -4450,7 +4188,7 @@
           <a:bodyPr wrap="square" lIns="0" tIns="0" rIns="0" bIns="0" rtlCol="0" anchor="t"/>
           <a:lstStyle/>
           <a:p>
-            <a:pPr indent="0" marL="0">
+            <a:pPr marL="0" indent="0">
               <a:lnSpc>
                 <a:spcPct val="140000"/>
               </a:lnSpc>
@@ -4487,6 +4225,7 @@
         <a:solidFill>
           <a:srgbClr val="EEF1F4"/>
         </a:solidFill>
+        <a:effectLst/>
       </p:bgPr>
     </p:bg>
     <p:spTree>
@@ -4524,11 +4263,11 @@
           <a:bodyPr wrap="square" lIns="0" tIns="0" rIns="0" bIns="0" rtlCol="0" anchor="t"/>
           <a:lstStyle/>
           <a:p>
-            <a:pPr indent="0" marL="0">
-              <a:buNone/>
-            </a:pPr>
-            <a:r>
-              <a:rPr lang="en-US" sz="1500" b="1" spc="200" kern="0" dirty="0">
+            <a:pPr marL="0" indent="0">
+              <a:buNone/>
+            </a:pPr>
+            <a:r>
+              <a:rPr lang="en-US" sz="1500" b="1" kern="0" spc="200" dirty="0">
                 <a:solidFill>
                   <a:srgbClr val="2F6FB0"/>
                 </a:solidFill>
@@ -4563,7 +4302,7 @@
           <a:bodyPr wrap="square" lIns="0" tIns="0" rIns="0" bIns="0" rtlCol="0" anchor="t"/>
           <a:lstStyle/>
           <a:p>
-            <a:pPr indent="0" marL="0">
+            <a:pPr marL="0" indent="0">
               <a:buNone/>
             </a:pPr>
             <a:r>
@@ -4605,6 +4344,13 @@
             <a:prstDash val="solid"/>
           </a:ln>
         </p:spPr>
+        <p:txBody>
+          <a:bodyPr/>
+          <a:lstStyle/>
+          <a:p>
+            <a:endParaRPr lang="ja-JP" altLang="en-US"/>
+          </a:p>
+        </p:txBody>
       </p:sp>
       <p:sp>
         <p:nvSpPr>
@@ -4630,6 +4376,13 @@
             <a:prstDash val="solid"/>
           </a:ln>
         </p:spPr>
+        <p:txBody>
+          <a:bodyPr/>
+          <a:lstStyle/>
+          <a:p>
+            <a:endParaRPr lang="ja-JP" altLang="en-US"/>
+          </a:p>
+        </p:txBody>
       </p:sp>
       <p:sp>
         <p:nvSpPr>
@@ -4652,7 +4405,7 @@
           <a:bodyPr wrap="square" lIns="0" tIns="0" rIns="0" bIns="0" rtlCol="0" anchor="t"/>
           <a:lstStyle/>
           <a:p>
-            <a:pPr indent="0" marL="0">
+            <a:pPr marL="0" indent="0">
               <a:buNone/>
             </a:pPr>
             <a:r>
@@ -4691,7 +4444,7 @@
           <a:bodyPr wrap="square" lIns="0" tIns="0" rIns="0" bIns="0" rtlCol="0" anchor="t"/>
           <a:lstStyle/>
           <a:p>
-            <a:pPr indent="0" marL="0">
+            <a:pPr marL="0" indent="0">
               <a:lnSpc>
                 <a:spcPct val="140000"/>
               </a:lnSpc>
@@ -4708,12 +4461,6 @@
               </a:rPr>
               <a:t>「汎用性を失う」は先行研究と同じ傾向。</a:t>
             </a:r>
-            <a:pPr indent="0" marL="0">
-              <a:lnSpc>
-                <a:spcPct val="140000"/>
-              </a:lnSpc>
-              <a:buNone/>
-            </a:pPr>
             <a:r>
               <a:rPr lang="en-US" sz="1500" b="1" dirty="0">
                 <a:solidFill>
@@ -4725,12 +4472,6 @@
               </a:rPr>
               <a:t>新しいのは</a:t>
             </a:r>
-            <a:pPr indent="0" marL="0">
-              <a:lnSpc>
-                <a:spcPct val="140000"/>
-              </a:lnSpc>
-              <a:buNone/>
-            </a:pPr>
             <a:r>
               <a:rPr lang="en-US" sz="1500" dirty="0">
                 <a:solidFill>
@@ -4743,45 +4484,6 @@
               <a:t>、帯域が欠けた喉マイクでの確認と、出力に現れる250 Hz間隔の人工成分の分析</a:t>
             </a:r>
             <a:endParaRPr lang="en-US" sz="1500" dirty="0"/>
-          </a:p>
-        </p:txBody>
-      </p:sp>
-      <p:sp>
-        <p:nvSpPr>
-          <p:cNvPr id="8" name="Text 6"/>
-          <p:cNvSpPr/>
-          <p:nvPr/>
-        </p:nvSpPr>
-        <p:spPr>
-          <a:xfrm>
-            <a:off x="1088136" y="4343400"/>
-            <a:ext cx="4632808" cy="457200"/>
-          </a:xfrm>
-          <a:prstGeom prst="rect">
-            <a:avLst/>
-          </a:prstGeom>
-          <a:noFill/>
-          <a:ln/>
-        </p:spPr>
-        <p:txBody>
-          <a:bodyPr wrap="square" lIns="0" tIns="0" rIns="0" bIns="0" rtlCol="0" anchor="t"/>
-          <a:lstStyle/>
-          <a:p>
-            <a:pPr indent="0" marL="0">
-              <a:buNone/>
-            </a:pPr>
-            <a:r>
-              <a:rPr lang="en-US" sz="1400" dirty="0">
-                <a:solidFill>
-                  <a:srgbClr val="4A5568"/>
-                </a:solidFill>
-                <a:latin typeface="Yu Gothic" pitchFamily="34" charset="0"/>
-                <a:ea typeface="Yu Gothic" pitchFamily="34" charset="-122"/>
-                <a:cs typeface="Yu Gothic" pitchFamily="34" charset="-120"/>
-              </a:rPr>
-              <a:t>→ 卒論・学会発表には十分</a:t>
-            </a:r>
-            <a:endParaRPr lang="en-US" sz="1400" dirty="0"/>
           </a:p>
         </p:txBody>
       </p:sp>
@@ -4809,6 +4511,13 @@
             <a:prstDash val="solid"/>
           </a:ln>
         </p:spPr>
+        <p:txBody>
+          <a:bodyPr/>
+          <a:lstStyle/>
+          <a:p>
+            <a:endParaRPr lang="ja-JP" altLang="en-US"/>
+          </a:p>
+        </p:txBody>
       </p:sp>
       <p:sp>
         <p:nvSpPr>
@@ -4834,6 +4543,13 @@
             <a:prstDash val="solid"/>
           </a:ln>
         </p:spPr>
+        <p:txBody>
+          <a:bodyPr/>
+          <a:lstStyle/>
+          <a:p>
+            <a:endParaRPr lang="ja-JP" altLang="en-US"/>
+          </a:p>
+        </p:txBody>
       </p:sp>
       <p:sp>
         <p:nvSpPr>
@@ -4856,7 +4572,7 @@
           <a:bodyPr wrap="square" lIns="0" tIns="0" rIns="0" bIns="0" rtlCol="0" anchor="t"/>
           <a:lstStyle/>
           <a:p>
-            <a:pPr indent="0" marL="0">
+            <a:pPr marL="0" indent="0">
               <a:buNone/>
             </a:pPr>
             <a:r>
@@ -4895,7 +4611,7 @@
           <a:bodyPr wrap="square" lIns="0" tIns="0" rIns="0" bIns="0" rtlCol="0" anchor="t"/>
           <a:lstStyle/>
           <a:p>
-            <a:pPr indent="0" marL="0">
+            <a:pPr marL="0" indent="0">
               <a:lnSpc>
                 <a:spcPct val="140000"/>
               </a:lnSpc>
@@ -4912,12 +4628,6 @@
               </a:rPr>
               <a:t>SEの長所（汎用性）を</a:t>
             </a:r>
-            <a:pPr indent="0" marL="0">
-              <a:lnSpc>
-                <a:spcPct val="140000"/>
-              </a:lnSpc>
-              <a:buNone/>
-            </a:pPr>
             <a:r>
               <a:rPr lang="en-US" sz="1500" b="1" dirty="0">
                 <a:solidFill>
@@ -4929,12 +4639,6 @@
               </a:rPr>
               <a:t>保ったまま</a:t>
             </a:r>
-            <a:pPr indent="0" marL="0">
-              <a:lnSpc>
-                <a:spcPct val="140000"/>
-              </a:lnSpc>
-              <a:buNone/>
-            </a:pPr>
             <a:r>
               <a:rPr lang="en-US" sz="1500" dirty="0">
                 <a:solidFill>
@@ -4947,45 +4651,6 @@
               <a:t>、ASRに効くSEをどう作るか</a:t>
             </a:r>
             <a:endParaRPr lang="en-US" sz="1500" dirty="0"/>
-          </a:p>
-        </p:txBody>
-      </p:sp>
-      <p:sp>
-        <p:nvSpPr>
-          <p:cNvPr id="13" name="Text 11"/>
-          <p:cNvSpPr/>
-          <p:nvPr/>
-        </p:nvSpPr>
-        <p:spPr>
-          <a:xfrm>
-            <a:off x="6470752" y="4343400"/>
-            <a:ext cx="4632808" cy="457200"/>
-          </a:xfrm>
-          <a:prstGeom prst="rect">
-            <a:avLst/>
-          </a:prstGeom>
-          <a:noFill/>
-          <a:ln/>
-        </p:spPr>
-        <p:txBody>
-          <a:bodyPr wrap="square" lIns="0" tIns="0" rIns="0" bIns="0" rtlCol="0" anchor="t"/>
-          <a:lstStyle/>
-          <a:p>
-            <a:pPr indent="0" marL="0">
-              <a:buNone/>
-            </a:pPr>
-            <a:r>
-              <a:rPr lang="en-US" sz="1400" dirty="0">
-                <a:solidFill>
-                  <a:srgbClr val="4A5568"/>
-                </a:solidFill>
-                <a:latin typeface="Yu Gothic" pitchFamily="34" charset="0"/>
-                <a:ea typeface="Yu Gothic" pitchFamily="34" charset="-122"/>
-                <a:cs typeface="Yu Gothic" pitchFamily="34" charset="-120"/>
-              </a:rPr>
-              <a:t>→ これが一番大きな収穫</a:t>
-            </a:r>
-            <a:endParaRPr lang="en-US" sz="1400" dirty="0"/>
           </a:p>
         </p:txBody>
       </p:sp>
@@ -5005,6 +4670,7 @@
         <a:solidFill>
           <a:srgbClr val="F7F6F2"/>
         </a:solidFill>
+        <a:effectLst/>
       </p:bgPr>
     </p:bg>
     <p:spTree>
@@ -5042,11 +4708,11 @@
           <a:bodyPr wrap="square" lIns="0" tIns="0" rIns="0" bIns="0" rtlCol="0" anchor="t"/>
           <a:lstStyle/>
           <a:p>
-            <a:pPr indent="0" marL="0">
-              <a:buNone/>
-            </a:pPr>
-            <a:r>
-              <a:rPr lang="en-US" sz="1500" b="1" spc="200" kern="0" dirty="0">
+            <a:pPr marL="0" indent="0">
+              <a:buNone/>
+            </a:pPr>
+            <a:r>
+              <a:rPr lang="en-US" sz="1500" b="1" kern="0" spc="200" dirty="0">
                 <a:solidFill>
                   <a:srgbClr val="B45F1E"/>
                 </a:solidFill>
@@ -5081,7 +4747,7 @@
           <a:bodyPr wrap="square" lIns="0" tIns="0" rIns="0" bIns="0" rtlCol="0" anchor="t"/>
           <a:lstStyle/>
           <a:p>
-            <a:pPr indent="0" marL="0">
+            <a:pPr marL="0" indent="0">
               <a:buNone/>
             </a:pPr>
             <a:r>
@@ -5123,6 +4789,13 @@
             <a:prstDash val="solid"/>
           </a:ln>
         </p:spPr>
+        <p:txBody>
+          <a:bodyPr/>
+          <a:lstStyle/>
+          <a:p>
+            <a:endParaRPr lang="ja-JP" altLang="en-US"/>
+          </a:p>
+        </p:txBody>
       </p:sp>
       <p:sp>
         <p:nvSpPr>
@@ -5148,6 +4821,13 @@
             <a:prstDash val="solid"/>
           </a:ln>
         </p:spPr>
+        <p:txBody>
+          <a:bodyPr/>
+          <a:lstStyle/>
+          <a:p>
+            <a:endParaRPr lang="ja-JP" altLang="en-US"/>
+          </a:p>
+        </p:txBody>
       </p:sp>
       <p:sp>
         <p:nvSpPr>
@@ -5170,7 +4850,7 @@
           <a:bodyPr wrap="square" lIns="0" tIns="0" rIns="0" bIns="0" rtlCol="0" anchor="ctr"/>
           <a:lstStyle/>
           <a:p>
-            <a:pPr indent="0" marL="0">
+            <a:pPr marL="0" indent="0">
               <a:buNone/>
             </a:pPr>
             <a:r>
@@ -5209,7 +4889,7 @@
           <a:bodyPr wrap="square" lIns="0" tIns="0" rIns="0" bIns="0" rtlCol="0" anchor="ctr"/>
           <a:lstStyle/>
           <a:p>
-            <a:pPr indent="0" marL="0">
+            <a:pPr marL="0" indent="0">
               <a:lnSpc>
                 <a:spcPct val="135000"/>
               </a:lnSpc>
@@ -5226,12 +4906,6 @@
               </a:rPr>
               <a:t>現場には</a:t>
             </a:r>
-            <a:pPr indent="0" marL="0">
-              <a:lnSpc>
-                <a:spcPct val="135000"/>
-              </a:lnSpc>
-              <a:buNone/>
-            </a:pPr>
             <a:r>
               <a:rPr lang="en-US" sz="1400" b="1" dirty="0">
                 <a:solidFill>
@@ -5243,12 +4917,6 @@
               </a:rPr>
               <a:t>重みを変えられないASR</a:t>
             </a:r>
-            <a:pPr indent="0" marL="0">
-              <a:lnSpc>
-                <a:spcPct val="135000"/>
-              </a:lnSpc>
-              <a:buNone/>
-            </a:pPr>
             <a:r>
               <a:rPr lang="en-US" sz="1400" dirty="0">
                 <a:solidFill>
@@ -5260,12 +4928,6 @@
               </a:rPr>
               <a:t>が多い（クラウドAPI、共用のASR）。FTもASR損失の学習もできないので、</a:t>
             </a:r>
-            <a:pPr indent="0" marL="0">
-              <a:lnSpc>
-                <a:spcPct val="135000"/>
-              </a:lnSpc>
-              <a:buNone/>
-            </a:pPr>
             <a:r>
               <a:rPr lang="en-US" sz="1400" b="1" dirty="0">
                 <a:solidFill>
@@ -5277,12 +4939,6 @@
               </a:rPr>
               <a:t>ASRを選ばないSEしか選択肢がない</a:t>
             </a:r>
-            <a:pPr indent="0" marL="0">
-              <a:lnSpc>
-                <a:spcPct val="135000"/>
-              </a:lnSpc>
-              <a:buNone/>
-            </a:pPr>
             <a:r>
               <a:rPr lang="en-US" sz="1400" dirty="0">
                 <a:solidFill>
@@ -5322,6 +4978,13 @@
             <a:prstDash val="solid"/>
           </a:ln>
         </p:spPr>
+        <p:txBody>
+          <a:bodyPr/>
+          <a:lstStyle/>
+          <a:p>
+            <a:endParaRPr lang="ja-JP" altLang="en-US"/>
+          </a:p>
+        </p:txBody>
       </p:sp>
       <p:sp>
         <p:nvSpPr>
@@ -5347,6 +5010,13 @@
             <a:prstDash val="solid"/>
           </a:ln>
         </p:spPr>
+        <p:txBody>
+          <a:bodyPr/>
+          <a:lstStyle/>
+          <a:p>
+            <a:endParaRPr lang="ja-JP" altLang="en-US"/>
+          </a:p>
+        </p:txBody>
       </p:sp>
       <p:sp>
         <p:nvSpPr>
@@ -5369,7 +5039,7 @@
           <a:bodyPr wrap="square" lIns="0" tIns="0" rIns="0" bIns="0" rtlCol="0" anchor="ctr"/>
           <a:lstStyle/>
           <a:p>
-            <a:pPr indent="0" marL="0">
+            <a:pPr marL="0" indent="0">
               <a:buNone/>
             </a:pPr>
             <a:r>
@@ -5408,7 +5078,7 @@
           <a:bodyPr wrap="square" lIns="0" tIns="0" rIns="0" bIns="0" rtlCol="0" anchor="ctr"/>
           <a:lstStyle/>
           <a:p>
-            <a:pPr indent="0" marL="0">
+            <a:pPr marL="0" indent="0">
               <a:lnSpc>
                 <a:spcPct val="135000"/>
               </a:lnSpc>
@@ -5425,12 +5095,6 @@
               </a:rPr>
               <a:t>自己教師あり表現（WavLMなど）を損失に使うと、</a:t>
             </a:r>
-            <a:pPr indent="0" marL="0">
-              <a:lnSpc>
-                <a:spcPct val="135000"/>
-              </a:lnSpc>
-              <a:buNone/>
-            </a:pPr>
             <a:r>
               <a:rPr lang="en-US" sz="1400" b="1" dirty="0">
                 <a:solidFill>
@@ -5442,12 +5106,6 @@
               </a:rPr>
               <a:t>学習に使っていないASRでも改善した</a:t>
             </a:r>
-            <a:pPr indent="0" marL="0">
-              <a:lnSpc>
-                <a:spcPct val="135000"/>
-              </a:lnSpc>
-              <a:buNone/>
-            </a:pPr>
             <a:r>
               <a:rPr lang="en-US" sz="1400" dirty="0">
                 <a:solidFill>
@@ -5487,6 +5145,13 @@
             <a:prstDash val="solid"/>
           </a:ln>
         </p:spPr>
+        <p:txBody>
+          <a:bodyPr/>
+          <a:lstStyle/>
+          <a:p>
+            <a:endParaRPr lang="ja-JP" altLang="en-US"/>
+          </a:p>
+        </p:txBody>
       </p:sp>
       <p:sp>
         <p:nvSpPr>
@@ -5512,6 +5177,13 @@
             <a:prstDash val="solid"/>
           </a:ln>
         </p:spPr>
+        <p:txBody>
+          <a:bodyPr/>
+          <a:lstStyle/>
+          <a:p>
+            <a:endParaRPr lang="ja-JP" altLang="en-US"/>
+          </a:p>
+        </p:txBody>
       </p:sp>
       <p:sp>
         <p:nvSpPr>
@@ -5534,7 +5206,7 @@
           <a:bodyPr wrap="square" lIns="0" tIns="0" rIns="0" bIns="0" rtlCol="0" anchor="ctr"/>
           <a:lstStyle/>
           <a:p>
-            <a:pPr indent="0" marL="0">
+            <a:pPr marL="0" indent="0">
               <a:buNone/>
             </a:pPr>
             <a:r>
@@ -5573,13 +5245,24 @@
           <a:bodyPr wrap="square" lIns="0" tIns="0" rIns="0" bIns="0" rtlCol="0" anchor="ctr"/>
           <a:lstStyle/>
           <a:p>
-            <a:pPr indent="0" marL="0">
+            <a:pPr marL="0" indent="0">
               <a:lnSpc>
                 <a:spcPct val="135000"/>
               </a:lnSpc>
               <a:buNone/>
             </a:pPr>
             <a:r>
+              <a:rPr lang="en-US" sz="1400" dirty="0" err="1">
+                <a:solidFill>
+                  <a:srgbClr val="1F2A37"/>
+                </a:solidFill>
+                <a:latin typeface="Yu Gothic" pitchFamily="34" charset="0"/>
+                <a:ea typeface="Yu Gothic" pitchFamily="34" charset="-122"/>
+                <a:cs typeface="Yu Gothic" pitchFamily="34" charset="-120"/>
+              </a:rPr>
+              <a:t>学習に使っていない系列のASRで、話者ごとに評価する</a:t>
+            </a:r>
+            <a:r>
               <a:rPr lang="en-US" sz="1400" dirty="0">
                 <a:solidFill>
                   <a:srgbClr val="1F2A37"/>
@@ -5588,1057 +5271,9 @@
                 <a:ea typeface="Yu Gothic" pitchFamily="34" charset="-122"/>
                 <a:cs typeface="Yu Gothic" pitchFamily="34" charset="-120"/>
               </a:rPr>
-              <a:t>学習に使っていない系列のASRで、話者ごとに評価する。</a:t>
-            </a:r>
-            <a:pPr indent="0" marL="0">
-              <a:lnSpc>
-                <a:spcPct val="135000"/>
-              </a:lnSpc>
-              <a:buNone/>
-            </a:pPr>
-            <a:r>
-              <a:rPr lang="en-US" sz="1400" b="1" dirty="0">
-                <a:solidFill>
-                  <a:srgbClr val="1F2A37"/>
-                </a:solidFill>
-                <a:latin typeface="Yu Gothic" pitchFamily="34" charset="0"/>
-                <a:ea typeface="Yu Gothic" pitchFamily="34" charset="-122"/>
-                <a:cs typeface="Yu Gothic" pitchFamily="34" charset="-120"/>
-              </a:rPr>
-              <a:t>卒論で作ったものがそのまま使える</a:t>
+              <a:t>。</a:t>
             </a:r>
             <a:endParaRPr lang="en-US" sz="1400" dirty="0"/>
-          </a:p>
-        </p:txBody>
-      </p:sp>
-    </p:spTree>
-  </p:cSld>
-  <p:clrMapOvr>
-    <a:masterClrMapping/>
-  </p:clrMapOvr>
-</p:sld>
-</file>
-
-<file path=ppt/slides/slide8.xml><?xml version="1.0" encoding="utf-8"?>
-<p:sld xmlns:a="http://schemas.openxmlformats.org/drawingml/2006/main" xmlns:r="http://schemas.openxmlformats.org/officeDocument/2006/relationships" xmlns:p="http://schemas.openxmlformats.org/presentationml/2006/main">
-  <p:cSld name="Slide 8">
-    <p:bg>
-      <p:bgPr>
-        <a:solidFill>
-          <a:srgbClr val="F7F6F2"/>
-        </a:solidFill>
-      </p:bgPr>
-    </p:bg>
-    <p:spTree>
-      <p:nvGrpSpPr>
-        <p:cNvPr id="1" name=""/>
-        <p:cNvGrpSpPr/>
-        <p:nvPr/>
-      </p:nvGrpSpPr>
-      <p:grpSpPr>
-        <a:xfrm>
-          <a:off x="0" y="0"/>
-          <a:ext cx="0" cy="0"/>
-          <a:chOff x="0" y="0"/>
-          <a:chExt cx="0" cy="0"/>
-        </a:xfrm>
-      </p:grpSpPr>
-      <p:sp>
-        <p:nvSpPr>
-          <p:cNvPr id="2" name="Text 0"/>
-          <p:cNvSpPr/>
-          <p:nvPr/>
-        </p:nvSpPr>
-        <p:spPr>
-          <a:xfrm>
-            <a:off x="813816" y="640080"/>
-            <a:ext cx="10564063" cy="320040"/>
-          </a:xfrm>
-          <a:prstGeom prst="rect">
-            <a:avLst/>
-          </a:prstGeom>
-          <a:noFill/>
-          <a:ln/>
-        </p:spPr>
-        <p:txBody>
-          <a:bodyPr wrap="square" lIns="0" tIns="0" rIns="0" bIns="0" rtlCol="0" anchor="t"/>
-          <a:lstStyle/>
-          <a:p>
-            <a:pPr indent="0" marL="0">
-              <a:buNone/>
-            </a:pPr>
-            <a:r>
-              <a:rPr lang="en-US" sz="1500" b="1" spc="200" kern="0" dirty="0">
-                <a:solidFill>
-                  <a:srgbClr val="B45F1E"/>
-                </a:solidFill>
-                <a:latin typeface="Yu Gothic" pitchFamily="34" charset="0"/>
-                <a:ea typeface="Yu Gothic" pitchFamily="34" charset="-122"/>
-                <a:cs typeface="Yu Gothic" pitchFamily="34" charset="-120"/>
-              </a:rPr>
-              <a:t>次の方向の候補：その他</a:t>
-            </a:r>
-            <a:endParaRPr lang="en-US" sz="1500" dirty="0"/>
-          </a:p>
-        </p:txBody>
-      </p:sp>
-      <p:sp>
-        <p:nvSpPr>
-          <p:cNvPr id="3" name="Text 1"/>
-          <p:cNvSpPr/>
-          <p:nvPr/>
-        </p:nvSpPr>
-        <p:spPr>
-          <a:xfrm>
-            <a:off x="813816" y="1051560"/>
-            <a:ext cx="10564063" cy="731520"/>
-          </a:xfrm>
-          <a:prstGeom prst="rect">
-            <a:avLst/>
-          </a:prstGeom>
-          <a:noFill/>
-          <a:ln/>
-        </p:spPr>
-        <p:txBody>
-          <a:bodyPr wrap="square" lIns="0" tIns="0" rIns="0" bIns="0" rtlCol="0" anchor="t"/>
-          <a:lstStyle/>
-          <a:p>
-            <a:pPr indent="0" marL="0">
-              <a:buNone/>
-            </a:pPr>
-            <a:r>
-              <a:rPr lang="en-US" sz="3000" b="1" dirty="0">
-                <a:solidFill>
-                  <a:srgbClr val="1F2A37"/>
-                </a:solidFill>
-                <a:latin typeface="Yu Gothic" pitchFamily="34" charset="0"/>
-                <a:ea typeface="Yu Gothic" pitchFamily="34" charset="-122"/>
-                <a:cs typeface="Yu Gothic" pitchFamily="34" charset="-120"/>
-              </a:rPr>
-              <a:t>ほかに考えられる選択肢</a:t>
-            </a:r>
-            <a:endParaRPr lang="en-US" sz="3000" dirty="0"/>
-          </a:p>
-        </p:txBody>
-      </p:sp>
-      <p:graphicFrame>
-        <p:nvGraphicFramePr>
-          <p:cNvPr id="9" name="Table 0"/>
-          <p:cNvGraphicFramePr>
-            <a:graphicFrameLocks noGrp="1"/>
-          </p:cNvGraphicFramePr>
-          <p:nvPr>
-            <p:extLst>
-              <p:ext uri="{D42A27DB-BD31-4B8C-83A1-F6EECF244321}">
-                <p14:modId xmlns:p14="http://schemas.microsoft.com/office/powerpoint/2010/main" val="1579011935"/>
-              </p:ext>
-            </p:extLst>
-          </p:nvPr>
-        </p:nvGraphicFramePr>
-        <p:xfrm>
-          <a:off x="813816" y="2011680"/>
-          <a:ext cx="10564063" cy="914400"/>
-        </p:xfrm>
-        <a:graphic>
-          <a:graphicData uri="http://schemas.openxmlformats.org/drawingml/2006/table">
-            <a:tbl>
-              <a:tblPr/>
-              <a:tblGrid>
-                <a:gridCol w="3591781"/>
-                <a:gridCol w="3486141"/>
-                <a:gridCol w="3486141"/>
-              </a:tblGrid>
-              <a:tr h="502920">
-                <a:tc>
-                  <a:txBody>
-                    <a:bodyPr/>
-                    <a:lstStyle/>
-                    <a:p>
-                      <a:pPr indent="0" marL="0">
-                        <a:buNone/>
-                      </a:pPr>
-                      <a:r>
-                        <a:rPr lang="en-US" sz="1500" b="1" dirty="0">
-                          <a:solidFill>
-                            <a:srgbClr val="F7F6F2"/>
-                          </a:solidFill>
-                          <a:latin typeface="Yu Gothic" pitchFamily="34" charset="0"/>
-                          <a:ea typeface="Yu Gothic" pitchFamily="34" charset="-122"/>
-                          <a:cs typeface="Yu Gothic" pitchFamily="34" charset="-120"/>
-                        </a:rPr>
-                        <a:t>方向</a:t>
-                      </a:r>
-                      <a:endParaRPr lang="en-US" sz="1500" dirty="0">
-                        <a:latin typeface="Yu Gothic" charset="0"/>
-                        <a:ea typeface="Yu Gothic" charset="0"/>
-                        <a:cs typeface="Yu Gothic" charset="0"/>
-                      </a:endParaRPr>
-                    </a:p>
-                  </a:txBody>
-                  <a:tcPr marL="109728" marR="109728" marT="109728" marB="109728" anchor="ctr">
-                    <a:lnL w="9525" cap="flat" cmpd="sng" algn="ctr">
-                      <a:solidFill>
-                        <a:srgbClr val="D8D3C8"/>
-                      </a:solidFill>
-                      <a:prstDash val="solid"/>
-                      <a:round/>
-                      <a:headEnd type="none" w="med" len="med"/>
-                      <a:tailEnd type="none" w="med" len="med"/>
-                    </a:lnL>
-                    <a:lnR w="9525" cap="flat" cmpd="sng" algn="ctr">
-                      <a:solidFill>
-                        <a:srgbClr val="D8D3C8"/>
-                      </a:solidFill>
-                      <a:prstDash val="solid"/>
-                      <a:round/>
-                      <a:headEnd type="none" w="med" len="med"/>
-                      <a:tailEnd type="none" w="med" len="med"/>
-                    </a:lnR>
-                    <a:lnT w="9525" cap="flat" cmpd="sng" algn="ctr">
-                      <a:solidFill>
-                        <a:srgbClr val="D8D3C8"/>
-                      </a:solidFill>
-                      <a:prstDash val="solid"/>
-                      <a:round/>
-                      <a:headEnd type="none" w="med" len="med"/>
-                      <a:tailEnd type="none" w="med" len="med"/>
-                    </a:lnT>
-                    <a:lnB w="9525" cap="flat" cmpd="sng" algn="ctr">
-                      <a:solidFill>
-                        <a:srgbClr val="D8D3C8"/>
-                      </a:solidFill>
-                      <a:prstDash val="solid"/>
-                      <a:round/>
-                      <a:headEnd type="none" w="med" len="med"/>
-                      <a:tailEnd type="none" w="med" len="med"/>
-                    </a:lnB>
-                    <a:solidFill>
-                      <a:srgbClr val="1F2A37"/>
-                    </a:solidFill>
-                  </a:tcPr>
-                </a:tc>
-                <a:tc>
-                  <a:txBody>
-                    <a:bodyPr/>
-                    <a:lstStyle/>
-                    <a:p>
-                      <a:pPr indent="0" marL="0">
-                        <a:buNone/>
-                      </a:pPr>
-                      <a:r>
-                        <a:rPr lang="en-US" sz="1500" b="1" dirty="0">
-                          <a:solidFill>
-                            <a:srgbClr val="F7F6F2"/>
-                          </a:solidFill>
-                          <a:latin typeface="Yu Gothic" pitchFamily="34" charset="0"/>
-                          <a:ea typeface="Yu Gothic" pitchFamily="34" charset="-122"/>
-                          <a:cs typeface="Yu Gothic" pitchFamily="34" charset="-120"/>
-                        </a:rPr>
-                        <a:t>見込み</a:t>
-                      </a:r>
-                      <a:endParaRPr lang="en-US" sz="1500" dirty="0">
-                        <a:latin typeface="Yu Gothic" charset="0"/>
-                        <a:ea typeface="Yu Gothic" charset="0"/>
-                        <a:cs typeface="Yu Gothic" charset="0"/>
-                      </a:endParaRPr>
-                    </a:p>
-                  </a:txBody>
-                  <a:tcPr marL="109728" marR="109728" marT="109728" marB="109728" anchor="ctr">
-                    <a:lnL w="9525" cap="flat" cmpd="sng" algn="ctr">
-                      <a:solidFill>
-                        <a:srgbClr val="D8D3C8"/>
-                      </a:solidFill>
-                      <a:prstDash val="solid"/>
-                      <a:round/>
-                      <a:headEnd type="none" w="med" len="med"/>
-                      <a:tailEnd type="none" w="med" len="med"/>
-                    </a:lnL>
-                    <a:lnR w="9525" cap="flat" cmpd="sng" algn="ctr">
-                      <a:solidFill>
-                        <a:srgbClr val="D8D3C8"/>
-                      </a:solidFill>
-                      <a:prstDash val="solid"/>
-                      <a:round/>
-                      <a:headEnd type="none" w="med" len="med"/>
-                      <a:tailEnd type="none" w="med" len="med"/>
-                    </a:lnR>
-                    <a:lnT w="9525" cap="flat" cmpd="sng" algn="ctr">
-                      <a:solidFill>
-                        <a:srgbClr val="D8D3C8"/>
-                      </a:solidFill>
-                      <a:prstDash val="solid"/>
-                      <a:round/>
-                      <a:headEnd type="none" w="med" len="med"/>
-                      <a:tailEnd type="none" w="med" len="med"/>
-                    </a:lnT>
-                    <a:lnB w="9525" cap="flat" cmpd="sng" algn="ctr">
-                      <a:solidFill>
-                        <a:srgbClr val="D8D3C8"/>
-                      </a:solidFill>
-                      <a:prstDash val="solid"/>
-                      <a:round/>
-                      <a:headEnd type="none" w="med" len="med"/>
-                      <a:tailEnd type="none" w="med" len="med"/>
-                    </a:lnB>
-                    <a:solidFill>
-                      <a:srgbClr val="1F2A37"/>
-                    </a:solidFill>
-                  </a:tcPr>
-                </a:tc>
-                <a:tc>
-                  <a:txBody>
-                    <a:bodyPr/>
-                    <a:lstStyle/>
-                    <a:p>
-                      <a:pPr indent="0" marL="0">
-                        <a:buNone/>
-                      </a:pPr>
-                      <a:r>
-                        <a:rPr lang="en-US" sz="1500" b="1" dirty="0">
-                          <a:solidFill>
-                            <a:srgbClr val="F7F6F2"/>
-                          </a:solidFill>
-                          <a:latin typeface="Yu Gothic" pitchFamily="34" charset="0"/>
-                          <a:ea typeface="Yu Gothic" pitchFamily="34" charset="-122"/>
-                          <a:cs typeface="Yu Gothic" pitchFamily="34" charset="-120"/>
-                        </a:rPr>
-                        <a:t>懸念</a:t>
-                      </a:r>
-                      <a:endParaRPr lang="en-US" sz="1500" dirty="0">
-                        <a:latin typeface="Yu Gothic" charset="0"/>
-                        <a:ea typeface="Yu Gothic" charset="0"/>
-                        <a:cs typeface="Yu Gothic" charset="0"/>
-                      </a:endParaRPr>
-                    </a:p>
-                  </a:txBody>
-                  <a:tcPr marL="109728" marR="109728" marT="109728" marB="109728" anchor="ctr">
-                    <a:lnL w="9525" cap="flat" cmpd="sng" algn="ctr">
-                      <a:solidFill>
-                        <a:srgbClr val="D8D3C8"/>
-                      </a:solidFill>
-                      <a:prstDash val="solid"/>
-                      <a:round/>
-                      <a:headEnd type="none" w="med" len="med"/>
-                      <a:tailEnd type="none" w="med" len="med"/>
-                    </a:lnL>
-                    <a:lnR w="9525" cap="flat" cmpd="sng" algn="ctr">
-                      <a:solidFill>
-                        <a:srgbClr val="D8D3C8"/>
-                      </a:solidFill>
-                      <a:prstDash val="solid"/>
-                      <a:round/>
-                      <a:headEnd type="none" w="med" len="med"/>
-                      <a:tailEnd type="none" w="med" len="med"/>
-                    </a:lnR>
-                    <a:lnT w="9525" cap="flat" cmpd="sng" algn="ctr">
-                      <a:solidFill>
-                        <a:srgbClr val="D8D3C8"/>
-                      </a:solidFill>
-                      <a:prstDash val="solid"/>
-                      <a:round/>
-                      <a:headEnd type="none" w="med" len="med"/>
-                      <a:tailEnd type="none" w="med" len="med"/>
-                    </a:lnT>
-                    <a:lnB w="9525" cap="flat" cmpd="sng" algn="ctr">
-                      <a:solidFill>
-                        <a:srgbClr val="D8D3C8"/>
-                      </a:solidFill>
-                      <a:prstDash val="solid"/>
-                      <a:round/>
-                      <a:headEnd type="none" w="med" len="med"/>
-                      <a:tailEnd type="none" w="med" len="med"/>
-                    </a:lnB>
-                    <a:solidFill>
-                      <a:srgbClr val="1F2A37"/>
-                    </a:solidFill>
-                  </a:tcPr>
-                </a:tc>
-              </a:tr>
-              <a:tr h="868680">
-                <a:tc>
-                  <a:txBody>
-                    <a:bodyPr/>
-                    <a:lstStyle/>
-                    <a:p>
-                      <a:pPr indent="0" marL="0">
-                        <a:buNone/>
-                      </a:pPr>
-                      <a:r>
-                        <a:rPr lang="en-US" sz="1500" dirty="0">
-                          <a:solidFill>
-                            <a:srgbClr val="1F2A37"/>
-                          </a:solidFill>
-                          <a:latin typeface="Yu Gothic" pitchFamily="34" charset="0"/>
-                          <a:ea typeface="Yu Gothic" pitchFamily="34" charset="-122"/>
-                          <a:cs typeface="Yu Gothic" pitchFamily="34" charset="-120"/>
-                        </a:rPr>
-                        <a:t>複数のASRの損失を混ぜて学習</a:t>
-                      </a:r>
-                      <a:endParaRPr lang="en-US" sz="1500" dirty="0">
-                        <a:latin typeface="Yu Gothic" charset="0"/>
-                        <a:ea typeface="Yu Gothic" charset="0"/>
-                        <a:cs typeface="Yu Gothic" charset="0"/>
-                      </a:endParaRPr>
-                    </a:p>
-                  </a:txBody>
-                  <a:tcPr marL="109728" marR="109728" marT="109728" marB="109728" anchor="ctr">
-                    <a:lnL w="9525" cap="flat" cmpd="sng" algn="ctr">
-                      <a:solidFill>
-                        <a:srgbClr val="D8D3C8"/>
-                      </a:solidFill>
-                      <a:prstDash val="solid"/>
-                      <a:round/>
-                      <a:headEnd type="none" w="med" len="med"/>
-                      <a:tailEnd type="none" w="med" len="med"/>
-                    </a:lnL>
-                    <a:lnR w="9525" cap="flat" cmpd="sng" algn="ctr">
-                      <a:solidFill>
-                        <a:srgbClr val="D8D3C8"/>
-                      </a:solidFill>
-                      <a:prstDash val="solid"/>
-                      <a:round/>
-                      <a:headEnd type="none" w="med" len="med"/>
-                      <a:tailEnd type="none" w="med" len="med"/>
-                    </a:lnR>
-                    <a:lnT w="9525" cap="flat" cmpd="sng" algn="ctr">
-                      <a:solidFill>
-                        <a:srgbClr val="D8D3C8"/>
-                      </a:solidFill>
-                      <a:prstDash val="solid"/>
-                      <a:round/>
-                      <a:headEnd type="none" w="med" len="med"/>
-                      <a:tailEnd type="none" w="med" len="med"/>
-                    </a:lnT>
-                    <a:lnB w="9525" cap="flat" cmpd="sng" algn="ctr">
-                      <a:solidFill>
-                        <a:srgbClr val="D8D3C8"/>
-                      </a:solidFill>
-                      <a:prstDash val="solid"/>
-                      <a:round/>
-                      <a:headEnd type="none" w="med" len="med"/>
-                      <a:tailEnd type="none" w="med" len="med"/>
-                    </a:lnB>
-                    <a:solidFill>
-                      <a:srgbClr val="FBFAF7"/>
-                    </a:solidFill>
-                  </a:tcPr>
-                </a:tc>
-                <a:tc>
-                  <a:txBody>
-                    <a:bodyPr/>
-                    <a:lstStyle/>
-                    <a:p>
-                      <a:pPr indent="0" marL="0">
-                        <a:buNone/>
-                      </a:pPr>
-                      <a:r>
-                        <a:rPr lang="en-US" sz="1500" dirty="0">
-                          <a:solidFill>
-                            <a:srgbClr val="1F2A37"/>
-                          </a:solidFill>
-                          <a:latin typeface="Yu Gothic" pitchFamily="34" charset="0"/>
-                          <a:ea typeface="Yu Gothic" pitchFamily="34" charset="-122"/>
-                          <a:cs typeface="Yu Gothic" pitchFamily="34" charset="-120"/>
-                        </a:rPr>
-                        <a:t>自然な発展</a:t>
-                      </a:r>
-                      <a:endParaRPr lang="en-US" sz="1500" dirty="0">
-                        <a:latin typeface="Yu Gothic" charset="0"/>
-                        <a:ea typeface="Yu Gothic" charset="0"/>
-                        <a:cs typeface="Yu Gothic" charset="0"/>
-                      </a:endParaRPr>
-                    </a:p>
-                  </a:txBody>
-                  <a:tcPr marL="109728" marR="109728" marT="109728" marB="109728" anchor="ctr">
-                    <a:lnL w="9525" cap="flat" cmpd="sng" algn="ctr">
-                      <a:solidFill>
-                        <a:srgbClr val="D8D3C8"/>
-                      </a:solidFill>
-                      <a:prstDash val="solid"/>
-                      <a:round/>
-                      <a:headEnd type="none" w="med" len="med"/>
-                      <a:tailEnd type="none" w="med" len="med"/>
-                    </a:lnL>
-                    <a:lnR w="9525" cap="flat" cmpd="sng" algn="ctr">
-                      <a:solidFill>
-                        <a:srgbClr val="D8D3C8"/>
-                      </a:solidFill>
-                      <a:prstDash val="solid"/>
-                      <a:round/>
-                      <a:headEnd type="none" w="med" len="med"/>
-                      <a:tailEnd type="none" w="med" len="med"/>
-                    </a:lnR>
-                    <a:lnT w="9525" cap="flat" cmpd="sng" algn="ctr">
-                      <a:solidFill>
-                        <a:srgbClr val="D8D3C8"/>
-                      </a:solidFill>
-                      <a:prstDash val="solid"/>
-                      <a:round/>
-                      <a:headEnd type="none" w="med" len="med"/>
-                      <a:tailEnd type="none" w="med" len="med"/>
-                    </a:lnT>
-                    <a:lnB w="9525" cap="flat" cmpd="sng" algn="ctr">
-                      <a:solidFill>
-                        <a:srgbClr val="D8D3C8"/>
-                      </a:solidFill>
-                      <a:prstDash val="solid"/>
-                      <a:round/>
-                      <a:headEnd type="none" w="med" len="med"/>
-                      <a:tailEnd type="none" w="med" len="med"/>
-                    </a:lnB>
-                    <a:solidFill>
-                      <a:srgbClr val="FBFAF7"/>
-                    </a:solidFill>
-                  </a:tcPr>
-                </a:tc>
-                <a:tc>
-                  <a:txBody>
-                    <a:bodyPr/>
-                    <a:lstStyle/>
-                    <a:p>
-                      <a:pPr indent="0" marL="0">
-                        <a:buNone/>
-                      </a:pPr>
-                      <a:r>
-                        <a:rPr lang="en-US" sz="1500" dirty="0">
-                          <a:solidFill>
-                            <a:srgbClr val="1F2A37"/>
-                          </a:solidFill>
-                          <a:latin typeface="Yu Gothic" pitchFamily="34" charset="0"/>
-                          <a:ea typeface="Yu Gothic" pitchFamily="34" charset="-122"/>
-                          <a:cs typeface="Yu Gothic" pitchFamily="34" charset="-120"/>
-                        </a:rPr>
-                        <a:t>平均的になるだけかも。学習に使っていない系列には効かない可能性</a:t>
-                      </a:r>
-                      <a:endParaRPr lang="en-US" sz="1500" dirty="0">
-                        <a:latin typeface="Yu Gothic" charset="0"/>
-                        <a:ea typeface="Yu Gothic" charset="0"/>
-                        <a:cs typeface="Yu Gothic" charset="0"/>
-                      </a:endParaRPr>
-                    </a:p>
-                  </a:txBody>
-                  <a:tcPr marL="109728" marR="109728" marT="109728" marB="109728" anchor="ctr">
-                    <a:lnL w="9525" cap="flat" cmpd="sng" algn="ctr">
-                      <a:solidFill>
-                        <a:srgbClr val="D8D3C8"/>
-                      </a:solidFill>
-                      <a:prstDash val="solid"/>
-                      <a:round/>
-                      <a:headEnd type="none" w="med" len="med"/>
-                      <a:tailEnd type="none" w="med" len="med"/>
-                    </a:lnL>
-                    <a:lnR w="9525" cap="flat" cmpd="sng" algn="ctr">
-                      <a:solidFill>
-                        <a:srgbClr val="D8D3C8"/>
-                      </a:solidFill>
-                      <a:prstDash val="solid"/>
-                      <a:round/>
-                      <a:headEnd type="none" w="med" len="med"/>
-                      <a:tailEnd type="none" w="med" len="med"/>
-                    </a:lnR>
-                    <a:lnT w="9525" cap="flat" cmpd="sng" algn="ctr">
-                      <a:solidFill>
-                        <a:srgbClr val="D8D3C8"/>
-                      </a:solidFill>
-                      <a:prstDash val="solid"/>
-                      <a:round/>
-                      <a:headEnd type="none" w="med" len="med"/>
-                      <a:tailEnd type="none" w="med" len="med"/>
-                    </a:lnT>
-                    <a:lnB w="9525" cap="flat" cmpd="sng" algn="ctr">
-                      <a:solidFill>
-                        <a:srgbClr val="D8D3C8"/>
-                      </a:solidFill>
-                      <a:prstDash val="solid"/>
-                      <a:round/>
-                      <a:headEnd type="none" w="med" len="med"/>
-                      <a:tailEnd type="none" w="med" len="med"/>
-                    </a:lnB>
-                    <a:solidFill>
-                      <a:srgbClr val="FBFAF7"/>
-                    </a:solidFill>
-                  </a:tcPr>
-                </a:tc>
-              </a:tr>
-              <a:tr h="868680">
-                <a:tc>
-                  <a:txBody>
-                    <a:bodyPr/>
-                    <a:lstStyle/>
-                    <a:p>
-                      <a:pPr indent="0" marL="0">
-                        <a:buNone/>
-                      </a:pPr>
-                      <a:r>
-                        <a:rPr lang="en-US" sz="1500" dirty="0">
-                          <a:solidFill>
-                            <a:srgbClr val="1F2A37"/>
-                          </a:solidFill>
-                          <a:latin typeface="Yu Gothic" pitchFamily="34" charset="0"/>
-                          <a:ea typeface="Yu Gothic" pitchFamily="34" charset="-122"/>
-                          <a:cs typeface="Yu Gothic" pitchFamily="34" charset="-120"/>
-                        </a:rPr>
-                        <a:t>雑音のある環境で評価（今回は雑音なし）</a:t>
-                      </a:r>
-                      <a:endParaRPr lang="en-US" sz="1500" dirty="0">
-                        <a:latin typeface="Yu Gothic" charset="0"/>
-                        <a:ea typeface="Yu Gothic" charset="0"/>
-                        <a:cs typeface="Yu Gothic" charset="0"/>
-                      </a:endParaRPr>
-                    </a:p>
-                  </a:txBody>
-                  <a:tcPr marL="109728" marR="109728" marT="109728" marB="109728" anchor="ctr">
-                    <a:lnL w="9525" cap="flat" cmpd="sng" algn="ctr">
-                      <a:solidFill>
-                        <a:srgbClr val="D8D3C8"/>
-                      </a:solidFill>
-                      <a:prstDash val="solid"/>
-                      <a:round/>
-                      <a:headEnd type="none" w="med" len="med"/>
-                      <a:tailEnd type="none" w="med" len="med"/>
-                    </a:lnL>
-                    <a:lnR w="9525" cap="flat" cmpd="sng" algn="ctr">
-                      <a:solidFill>
-                        <a:srgbClr val="D8D3C8"/>
-                      </a:solidFill>
-                      <a:prstDash val="solid"/>
-                      <a:round/>
-                      <a:headEnd type="none" w="med" len="med"/>
-                      <a:tailEnd type="none" w="med" len="med"/>
-                    </a:lnR>
-                    <a:lnT w="9525" cap="flat" cmpd="sng" algn="ctr">
-                      <a:solidFill>
-                        <a:srgbClr val="D8D3C8"/>
-                      </a:solidFill>
-                      <a:prstDash val="solid"/>
-                      <a:round/>
-                      <a:headEnd type="none" w="med" len="med"/>
-                      <a:tailEnd type="none" w="med" len="med"/>
-                    </a:lnT>
-                    <a:lnB w="9525" cap="flat" cmpd="sng" algn="ctr">
-                      <a:solidFill>
-                        <a:srgbClr val="D8D3C8"/>
-                      </a:solidFill>
-                      <a:prstDash val="solid"/>
-                      <a:round/>
-                      <a:headEnd type="none" w="med" len="med"/>
-                      <a:tailEnd type="none" w="med" len="med"/>
-                    </a:lnB>
-                    <a:solidFill>
-                      <a:srgbClr val="EEF1F4"/>
-                    </a:solidFill>
-                  </a:tcPr>
-                </a:tc>
-                <a:tc>
-                  <a:txBody>
-                    <a:bodyPr/>
-                    <a:lstStyle/>
-                    <a:p>
-                      <a:pPr indent="0" marL="0">
-                        <a:buNone/>
-                      </a:pPr>
-                      <a:r>
-                        <a:rPr lang="en-US" sz="1500" dirty="0">
-                          <a:solidFill>
-                            <a:srgbClr val="1F2A37"/>
-                          </a:solidFill>
-                          <a:latin typeface="Yu Gothic" pitchFamily="34" charset="0"/>
-                          <a:ea typeface="Yu Gothic" pitchFamily="34" charset="-122"/>
-                          <a:cs typeface="Yu Gothic" pitchFamily="34" charset="-120"/>
-                        </a:rPr>
-                        <a:t>喉マイク本来の強み（騒音に強い）を活かせる</a:t>
-                      </a:r>
-                      <a:endParaRPr lang="en-US" sz="1500" dirty="0">
-                        <a:latin typeface="Yu Gothic" charset="0"/>
-                        <a:ea typeface="Yu Gothic" charset="0"/>
-                        <a:cs typeface="Yu Gothic" charset="0"/>
-                      </a:endParaRPr>
-                    </a:p>
-                  </a:txBody>
-                  <a:tcPr marL="109728" marR="109728" marT="109728" marB="109728" anchor="ctr">
-                    <a:lnL w="9525" cap="flat" cmpd="sng" algn="ctr">
-                      <a:solidFill>
-                        <a:srgbClr val="D8D3C8"/>
-                      </a:solidFill>
-                      <a:prstDash val="solid"/>
-                      <a:round/>
-                      <a:headEnd type="none" w="med" len="med"/>
-                      <a:tailEnd type="none" w="med" len="med"/>
-                    </a:lnL>
-                    <a:lnR w="9525" cap="flat" cmpd="sng" algn="ctr">
-                      <a:solidFill>
-                        <a:srgbClr val="D8D3C8"/>
-                      </a:solidFill>
-                      <a:prstDash val="solid"/>
-                      <a:round/>
-                      <a:headEnd type="none" w="med" len="med"/>
-                      <a:tailEnd type="none" w="med" len="med"/>
-                    </a:lnR>
-                    <a:lnT w="9525" cap="flat" cmpd="sng" algn="ctr">
-                      <a:solidFill>
-                        <a:srgbClr val="D8D3C8"/>
-                      </a:solidFill>
-                      <a:prstDash val="solid"/>
-                      <a:round/>
-                      <a:headEnd type="none" w="med" len="med"/>
-                      <a:tailEnd type="none" w="med" len="med"/>
-                    </a:lnT>
-                    <a:lnB w="9525" cap="flat" cmpd="sng" algn="ctr">
-                      <a:solidFill>
-                        <a:srgbClr val="D8D3C8"/>
-                      </a:solidFill>
-                      <a:prstDash val="solid"/>
-                      <a:round/>
-                      <a:headEnd type="none" w="med" len="med"/>
-                      <a:tailEnd type="none" w="med" len="med"/>
-                    </a:lnB>
-                    <a:solidFill>
-                      <a:srgbClr val="EEF1F4"/>
-                    </a:solidFill>
-                  </a:tcPr>
-                </a:tc>
-                <a:tc>
-                  <a:txBody>
-                    <a:bodyPr/>
-                    <a:lstStyle/>
-                    <a:p>
-                      <a:pPr indent="0" marL="0">
-                        <a:buNone/>
-                      </a:pPr>
-                      <a:r>
-                        <a:rPr lang="en-US" sz="1500" dirty="0">
-                          <a:solidFill>
-                            <a:srgbClr val="1F2A37"/>
-                          </a:solidFill>
-                          <a:latin typeface="Yu Gothic" pitchFamily="34" charset="0"/>
-                          <a:ea typeface="Yu Gothic" pitchFamily="34" charset="-122"/>
-                          <a:cs typeface="Yu Gothic" pitchFamily="34" charset="-120"/>
-                        </a:rPr>
-                        <a:t>データの収録が必要。競合研究がある</a:t>
-                      </a:r>
-                      <a:endParaRPr lang="en-US" sz="1500" dirty="0">
-                        <a:latin typeface="Yu Gothic" charset="0"/>
-                        <a:ea typeface="Yu Gothic" charset="0"/>
-                        <a:cs typeface="Yu Gothic" charset="0"/>
-                      </a:endParaRPr>
-                    </a:p>
-                  </a:txBody>
-                  <a:tcPr marL="109728" marR="109728" marT="109728" marB="109728" anchor="ctr">
-                    <a:lnL w="9525" cap="flat" cmpd="sng" algn="ctr">
-                      <a:solidFill>
-                        <a:srgbClr val="D8D3C8"/>
-                      </a:solidFill>
-                      <a:prstDash val="solid"/>
-                      <a:round/>
-                      <a:headEnd type="none" w="med" len="med"/>
-                      <a:tailEnd type="none" w="med" len="med"/>
-                    </a:lnL>
-                    <a:lnR w="9525" cap="flat" cmpd="sng" algn="ctr">
-                      <a:solidFill>
-                        <a:srgbClr val="D8D3C8"/>
-                      </a:solidFill>
-                      <a:prstDash val="solid"/>
-                      <a:round/>
-                      <a:headEnd type="none" w="med" len="med"/>
-                      <a:tailEnd type="none" w="med" len="med"/>
-                    </a:lnR>
-                    <a:lnT w="9525" cap="flat" cmpd="sng" algn="ctr">
-                      <a:solidFill>
-                        <a:srgbClr val="D8D3C8"/>
-                      </a:solidFill>
-                      <a:prstDash val="solid"/>
-                      <a:round/>
-                      <a:headEnd type="none" w="med" len="med"/>
-                      <a:tailEnd type="none" w="med" len="med"/>
-                    </a:lnT>
-                    <a:lnB w="9525" cap="flat" cmpd="sng" algn="ctr">
-                      <a:solidFill>
-                        <a:srgbClr val="D8D3C8"/>
-                      </a:solidFill>
-                      <a:prstDash val="solid"/>
-                      <a:round/>
-                      <a:headEnd type="none" w="med" len="med"/>
-                      <a:tailEnd type="none" w="med" len="med"/>
-                    </a:lnB>
-                    <a:solidFill>
-                      <a:srgbClr val="EEF1F4"/>
-                    </a:solidFill>
-                  </a:tcPr>
-                </a:tc>
-              </a:tr>
-              <a:tr h="868680">
-                <a:tc>
-                  <a:txBody>
-                    <a:bodyPr/>
-                    <a:lstStyle/>
-                    <a:p>
-                      <a:pPr indent="0" marL="0">
-                        <a:buNone/>
-                      </a:pPr>
-                      <a:r>
-                        <a:rPr lang="en-US" sz="1500" dirty="0">
-                          <a:solidFill>
-                            <a:srgbClr val="1F2A37"/>
-                          </a:solidFill>
-                          <a:latin typeface="Yu Gothic" pitchFamily="34" charset="0"/>
-                          <a:ea typeface="Yu Gothic" pitchFamily="34" charset="-122"/>
-                          <a:cs typeface="Yu Gothic" pitchFamily="34" charset="-120"/>
-                        </a:rPr>
-                        <a:t>SEとFTがそれぞれ何を直しているかの分析</a:t>
-                      </a:r>
-                      <a:endParaRPr lang="en-US" sz="1500" dirty="0">
-                        <a:latin typeface="Yu Gothic" charset="0"/>
-                        <a:ea typeface="Yu Gothic" charset="0"/>
-                        <a:cs typeface="Yu Gothic" charset="0"/>
-                      </a:endParaRPr>
-                    </a:p>
-                  </a:txBody>
-                  <a:tcPr marL="109728" marR="109728" marT="109728" marB="109728" anchor="ctr">
-                    <a:lnL w="9525" cap="flat" cmpd="sng" algn="ctr">
-                      <a:solidFill>
-                        <a:srgbClr val="D8D3C8"/>
-                      </a:solidFill>
-                      <a:prstDash val="solid"/>
-                      <a:round/>
-                      <a:headEnd type="none" w="med" len="med"/>
-                      <a:tailEnd type="none" w="med" len="med"/>
-                    </a:lnL>
-                    <a:lnR w="9525" cap="flat" cmpd="sng" algn="ctr">
-                      <a:solidFill>
-                        <a:srgbClr val="D8D3C8"/>
-                      </a:solidFill>
-                      <a:prstDash val="solid"/>
-                      <a:round/>
-                      <a:headEnd type="none" w="med" len="med"/>
-                      <a:tailEnd type="none" w="med" len="med"/>
-                    </a:lnR>
-                    <a:lnT w="9525" cap="flat" cmpd="sng" algn="ctr">
-                      <a:solidFill>
-                        <a:srgbClr val="D8D3C8"/>
-                      </a:solidFill>
-                      <a:prstDash val="solid"/>
-                      <a:round/>
-                      <a:headEnd type="none" w="med" len="med"/>
-                      <a:tailEnd type="none" w="med" len="med"/>
-                    </a:lnT>
-                    <a:lnB w="9525" cap="flat" cmpd="sng" algn="ctr">
-                      <a:solidFill>
-                        <a:srgbClr val="D8D3C8"/>
-                      </a:solidFill>
-                      <a:prstDash val="solid"/>
-                      <a:round/>
-                      <a:headEnd type="none" w="med" len="med"/>
-                      <a:tailEnd type="none" w="med" len="med"/>
-                    </a:lnB>
-                    <a:solidFill>
-                      <a:srgbClr val="FBFAF7"/>
-                    </a:solidFill>
-                  </a:tcPr>
-                </a:tc>
-                <a:tc>
-                  <a:txBody>
-                    <a:bodyPr/>
-                    <a:lstStyle/>
-                    <a:p>
-                      <a:pPr indent="0" marL="0">
-                        <a:buNone/>
-                      </a:pPr>
-                      <a:r>
-                        <a:rPr lang="en-US" sz="1500" dirty="0">
-                          <a:solidFill>
-                            <a:srgbClr val="1F2A37"/>
-                          </a:solidFill>
-                          <a:latin typeface="Yu Gothic" pitchFamily="34" charset="0"/>
-                          <a:ea typeface="Yu Gothic" pitchFamily="34" charset="-122"/>
-                          <a:cs typeface="Yu Gothic" pitchFamily="34" charset="-120"/>
-                        </a:rPr>
-                        <a:t>分析として面白い</a:t>
-                      </a:r>
-                      <a:endParaRPr lang="en-US" sz="1500" dirty="0">
-                        <a:latin typeface="Yu Gothic" charset="0"/>
-                        <a:ea typeface="Yu Gothic" charset="0"/>
-                        <a:cs typeface="Yu Gothic" charset="0"/>
-                      </a:endParaRPr>
-                    </a:p>
-                  </a:txBody>
-                  <a:tcPr marL="109728" marR="109728" marT="109728" marB="109728" anchor="ctr">
-                    <a:lnL w="9525" cap="flat" cmpd="sng" algn="ctr">
-                      <a:solidFill>
-                        <a:srgbClr val="D8D3C8"/>
-                      </a:solidFill>
-                      <a:prstDash val="solid"/>
-                      <a:round/>
-                      <a:headEnd type="none" w="med" len="med"/>
-                      <a:tailEnd type="none" w="med" len="med"/>
-                    </a:lnL>
-                    <a:lnR w="9525" cap="flat" cmpd="sng" algn="ctr">
-                      <a:solidFill>
-                        <a:srgbClr val="D8D3C8"/>
-                      </a:solidFill>
-                      <a:prstDash val="solid"/>
-                      <a:round/>
-                      <a:headEnd type="none" w="med" len="med"/>
-                      <a:tailEnd type="none" w="med" len="med"/>
-                    </a:lnR>
-                    <a:lnT w="9525" cap="flat" cmpd="sng" algn="ctr">
-                      <a:solidFill>
-                        <a:srgbClr val="D8D3C8"/>
-                      </a:solidFill>
-                      <a:prstDash val="solid"/>
-                      <a:round/>
-                      <a:headEnd type="none" w="med" len="med"/>
-                      <a:tailEnd type="none" w="med" len="med"/>
-                    </a:lnT>
-                    <a:lnB w="9525" cap="flat" cmpd="sng" algn="ctr">
-                      <a:solidFill>
-                        <a:srgbClr val="D8D3C8"/>
-                      </a:solidFill>
-                      <a:prstDash val="solid"/>
-                      <a:round/>
-                      <a:headEnd type="none" w="med" len="med"/>
-                      <a:tailEnd type="none" w="med" len="med"/>
-                    </a:lnB>
-                    <a:solidFill>
-                      <a:srgbClr val="FBFAF7"/>
-                    </a:solidFill>
-                  </a:tcPr>
-                </a:tc>
-                <a:tc>
-                  <a:txBody>
-                    <a:bodyPr/>
-                    <a:lstStyle/>
-                    <a:p>
-                      <a:pPr indent="0" marL="0">
-                        <a:buNone/>
-                      </a:pPr>
-                      <a:r>
-                        <a:rPr lang="en-US" sz="1500" dirty="0">
-                          <a:solidFill>
-                            <a:srgbClr val="1F2A37"/>
-                          </a:solidFill>
-                          <a:latin typeface="Yu Gothic" pitchFamily="34" charset="0"/>
-                          <a:ea typeface="Yu Gothic" pitchFamily="34" charset="-122"/>
-                          <a:cs typeface="Yu Gothic" pitchFamily="34" charset="-120"/>
-                        </a:rPr>
-                        <a:t>手法の提案にはならない</a:t>
-                      </a:r>
-                      <a:endParaRPr lang="en-US" sz="1500" dirty="0">
-                        <a:latin typeface="Yu Gothic" charset="0"/>
-                        <a:ea typeface="Yu Gothic" charset="0"/>
-                        <a:cs typeface="Yu Gothic" charset="0"/>
-                      </a:endParaRPr>
-                    </a:p>
-                  </a:txBody>
-                  <a:tcPr marL="109728" marR="109728" marT="109728" marB="109728" anchor="ctr">
-                    <a:lnL w="9525" cap="flat" cmpd="sng" algn="ctr">
-                      <a:solidFill>
-                        <a:srgbClr val="D8D3C8"/>
-                      </a:solidFill>
-                      <a:prstDash val="solid"/>
-                      <a:round/>
-                      <a:headEnd type="none" w="med" len="med"/>
-                      <a:tailEnd type="none" w="med" len="med"/>
-                    </a:lnL>
-                    <a:lnR w="9525" cap="flat" cmpd="sng" algn="ctr">
-                      <a:solidFill>
-                        <a:srgbClr val="D8D3C8"/>
-                      </a:solidFill>
-                      <a:prstDash val="solid"/>
-                      <a:round/>
-                      <a:headEnd type="none" w="med" len="med"/>
-                      <a:tailEnd type="none" w="med" len="med"/>
-                    </a:lnR>
-                    <a:lnT w="9525" cap="flat" cmpd="sng" algn="ctr">
-                      <a:solidFill>
-                        <a:srgbClr val="D8D3C8"/>
-                      </a:solidFill>
-                      <a:prstDash val="solid"/>
-                      <a:round/>
-                      <a:headEnd type="none" w="med" len="med"/>
-                      <a:tailEnd type="none" w="med" len="med"/>
-                    </a:lnT>
-                    <a:lnB w="9525" cap="flat" cmpd="sng" algn="ctr">
-                      <a:solidFill>
-                        <a:srgbClr val="D8D3C8"/>
-                      </a:solidFill>
-                      <a:prstDash val="solid"/>
-                      <a:round/>
-                      <a:headEnd type="none" w="med" len="med"/>
-                      <a:tailEnd type="none" w="med" len="med"/>
-                    </a:lnB>
-                    <a:solidFill>
-                      <a:srgbClr val="FBFAF7"/>
-                    </a:solidFill>
-                  </a:tcPr>
-                </a:tc>
-              </a:tr>
-            </a:tbl>
-          </a:graphicData>
-        </a:graphic>
-      </p:graphicFrame>
-      <p:sp>
-        <p:nvSpPr>
-          <p:cNvPr id="5" name="Shape 2"/>
-          <p:cNvSpPr/>
-          <p:nvPr/>
-        </p:nvSpPr>
-        <p:spPr>
-          <a:xfrm>
-            <a:off x="813816" y="5440680"/>
-            <a:ext cx="10564063" cy="594360"/>
-          </a:xfrm>
-          <a:prstGeom prst="roundRect">
-            <a:avLst>
-              <a:gd name="adj" fmla="val 12308"/>
-            </a:avLst>
-          </a:prstGeom>
-          <a:solidFill>
-            <a:srgbClr val="1F2A37"/>
-          </a:solidFill>
-          <a:ln w="12700">
-            <a:solidFill>
-              <a:srgbClr val="1F2A37"/>
-            </a:solidFill>
-            <a:prstDash val="solid"/>
-          </a:ln>
-        </p:spPr>
-      </p:sp>
-      <p:sp>
-        <p:nvSpPr>
-          <p:cNvPr id="6" name="Text 3"/>
-          <p:cNvSpPr/>
-          <p:nvPr/>
-        </p:nvSpPr>
-        <p:spPr>
-          <a:xfrm>
-            <a:off x="1042416" y="5440680"/>
-            <a:ext cx="10106863" cy="594360"/>
-          </a:xfrm>
-          <a:prstGeom prst="rect">
-            <a:avLst/>
-          </a:prstGeom>
-          <a:noFill/>
-          <a:ln/>
-        </p:spPr>
-        <p:txBody>
-          <a:bodyPr wrap="square" lIns="0" tIns="0" rIns="0" bIns="0" rtlCol="0" anchor="ctr"/>
-          <a:lstStyle/>
-          <a:p>
-            <a:pPr indent="0" marL="0">
-              <a:buNone/>
-            </a:pPr>
-            <a:r>
-              <a:rPr lang="en-US" sz="1600" b="1" dirty="0">
-                <a:solidFill>
-                  <a:srgbClr val="F7F6F2"/>
-                </a:solidFill>
-                <a:latin typeface="Yu Gothic" pitchFamily="34" charset="0"/>
-                <a:ea typeface="Yu Gothic" pitchFamily="34" charset="-122"/>
-                <a:cs typeface="Yu Gothic" pitchFamily="34" charset="-120"/>
-              </a:rPr>
-              <a:t>ご意見をいただきたい点：本命の方向でよいか ／ ほかに検討すべき選択肢はあるか</a:t>
-            </a:r>
-            <a:endParaRPr lang="en-US" sz="1600" dirty="0"/>
           </a:p>
         </p:txBody>
       </p:sp>
@@ -6943,4 +5578,319 @@
     </a:ext>
   </a:extLst>
 </a:theme>
+</file>
+
+<file path=ppt/theme/theme2.xml><?xml version="1.0" encoding="utf-8"?>
+<a:theme xmlns:a="http://schemas.openxmlformats.org/drawingml/2006/main" name="Office テーマ">
+  <a:themeElements>
+    <a:clrScheme name="Office">
+      <a:dk1>
+        <a:sysClr val="windowText" lastClr="000000"/>
+      </a:dk1>
+      <a:lt1>
+        <a:sysClr val="window" lastClr="FFFFFF"/>
+      </a:lt1>
+      <a:dk2>
+        <a:srgbClr val="0E2841"/>
+      </a:dk2>
+      <a:lt2>
+        <a:srgbClr val="E8E8E8"/>
+      </a:lt2>
+      <a:accent1>
+        <a:srgbClr val="156082"/>
+      </a:accent1>
+      <a:accent2>
+        <a:srgbClr val="E97132"/>
+      </a:accent2>
+      <a:accent3>
+        <a:srgbClr val="196B24"/>
+      </a:accent3>
+      <a:accent4>
+        <a:srgbClr val="0F9ED5"/>
+      </a:accent4>
+      <a:accent5>
+        <a:srgbClr val="A02B93"/>
+      </a:accent5>
+      <a:accent6>
+        <a:srgbClr val="4EA72E"/>
+      </a:accent6>
+      <a:hlink>
+        <a:srgbClr val="467886"/>
+      </a:hlink>
+      <a:folHlink>
+        <a:srgbClr val="96607D"/>
+      </a:folHlink>
+    </a:clrScheme>
+    <a:fontScheme name="Office">
+      <a:majorFont>
+        <a:latin typeface="游ゴシック Light" panose="02110004020202020204"/>
+        <a:ea typeface=""/>
+        <a:cs typeface=""/>
+        <a:font script="Jpan" typeface="游ゴシック Light"/>
+        <a:font script="Hang" typeface="맑은 고딕"/>
+        <a:font script="Hans" typeface="等线 Light"/>
+        <a:font script="Hant" typeface="新細明體"/>
+        <a:font script="Arab" typeface="Times New Roman"/>
+        <a:font script="Hebr" typeface="Times New Roman"/>
+        <a:font script="Thai" typeface="Angsana New"/>
+        <a:font script="Ethi" typeface="Nyala"/>
+        <a:font script="Beng" typeface="Vrinda"/>
+        <a:font script="Gujr" typeface="Shruti"/>
+        <a:font script="Khmr" typeface="MoolBoran"/>
+        <a:font script="Knda" typeface="Tunga"/>
+        <a:font script="Guru" typeface="Raavi"/>
+        <a:font script="Cans" typeface="Euphemia"/>
+        <a:font script="Cher" typeface="Plantagenet Cherokee"/>
+        <a:font script="Yiii" typeface="Microsoft Yi Baiti"/>
+        <a:font script="Tibt" typeface="Microsoft Himalaya"/>
+        <a:font script="Thaa" typeface="MV Boli"/>
+        <a:font script="Deva" typeface="Mangal"/>
+        <a:font script="Telu" typeface="Gautami"/>
+        <a:font script="Taml" typeface="Latha"/>
+        <a:font script="Syrc" typeface="Estrangelo Edessa"/>
+        <a:font script="Orya" typeface="Kalinga"/>
+        <a:font script="Mlym" typeface="Kartika"/>
+        <a:font script="Laoo" typeface="DokChampa"/>
+        <a:font script="Sinh" typeface="Iskoola Pota"/>
+        <a:font script="Mong" typeface="Mongolian Baiti"/>
+        <a:font script="Viet" typeface="Times New Roman"/>
+        <a:font script="Uigh" typeface="Microsoft Uighur"/>
+        <a:font script="Geor" typeface="Sylfaen"/>
+        <a:font script="Armn" typeface="Arial"/>
+        <a:font script="Bugi" typeface="Leelawadee UI"/>
+        <a:font script="Bopo" typeface="Microsoft JhengHei"/>
+        <a:font script="Java" typeface="Javanese Text"/>
+        <a:font script="Lisu" typeface="Segoe UI"/>
+        <a:font script="Mymr" typeface="Myanmar Text"/>
+        <a:font script="Nkoo" typeface="Ebrima"/>
+        <a:font script="Olck" typeface="Nirmala UI"/>
+        <a:font script="Osma" typeface="Ebrima"/>
+        <a:font script="Phag" typeface="Phagspa"/>
+        <a:font script="Syrn" typeface="Estrangelo Edessa"/>
+        <a:font script="Syrj" typeface="Estrangelo Edessa"/>
+        <a:font script="Syre" typeface="Estrangelo Edessa"/>
+        <a:font script="Sora" typeface="Nirmala UI"/>
+        <a:font script="Tale" typeface="Microsoft Tai Le"/>
+        <a:font script="Talu" typeface="Microsoft New Tai Lue"/>
+        <a:font script="Tfng" typeface="Ebrima"/>
+      </a:majorFont>
+      <a:minorFont>
+        <a:latin typeface="游ゴシック" panose="02110004020202020204"/>
+        <a:ea typeface=""/>
+        <a:cs typeface=""/>
+        <a:font script="Jpan" typeface="游ゴシック"/>
+        <a:font script="Hang" typeface="맑은 고딕"/>
+        <a:font script="Hans" typeface="等线"/>
+        <a:font script="Hant" typeface="新細明體"/>
+        <a:font script="Arab" typeface="Arial"/>
+        <a:font script="Hebr" typeface="Arial"/>
+        <a:font script="Thai" typeface="Cordia New"/>
+        <a:font script="Ethi" typeface="Nyala"/>
+        <a:font script="Beng" typeface="Vrinda"/>
+        <a:font script="Gujr" typeface="Shruti"/>
+        <a:font script="Khmr" typeface="DaunPenh"/>
+        <a:font script="Knda" typeface="Tunga"/>
+        <a:font script="Guru" typeface="Raavi"/>
+        <a:font script="Cans" typeface="Euphemia"/>
+        <a:font script="Cher" typeface="Plantagenet Cherokee"/>
+        <a:font script="Yiii" typeface="Microsoft Yi Baiti"/>
+        <a:font script="Tibt" typeface="Microsoft Himalaya"/>
+        <a:font script="Thaa" typeface="MV Boli"/>
+        <a:font script="Deva" typeface="Mangal"/>
+        <a:font script="Telu" typeface="Gautami"/>
+        <a:font script="Taml" typeface="Latha"/>
+        <a:font script="Syrc" typeface="Estrangelo Edessa"/>
+        <a:font script="Orya" typeface="Kalinga"/>
+        <a:font script="Mlym" typeface="Kartika"/>
+        <a:font script="Laoo" typeface="DokChampa"/>
+        <a:font script="Sinh" typeface="Iskoola Pota"/>
+        <a:font script="Mong" typeface="Mongolian Baiti"/>
+        <a:font script="Viet" typeface="Arial"/>
+        <a:font script="Uigh" typeface="Microsoft Uighur"/>
+        <a:font script="Geor" typeface="Sylfaen"/>
+        <a:font script="Armn" typeface="Arial"/>
+        <a:font script="Bugi" typeface="Leelawadee UI"/>
+        <a:font script="Bopo" typeface="Microsoft JhengHei"/>
+        <a:font script="Java" typeface="Javanese Text"/>
+        <a:font script="Lisu" typeface="Segoe UI"/>
+        <a:font script="Mymr" typeface="Myanmar Text"/>
+        <a:font script="Nkoo" typeface="Ebrima"/>
+        <a:font script="Olck" typeface="Nirmala UI"/>
+        <a:font script="Osma" typeface="Ebrima"/>
+        <a:font script="Phag" typeface="Phagspa"/>
+        <a:font script="Syrn" typeface="Estrangelo Edessa"/>
+        <a:font script="Syrj" typeface="Estrangelo Edessa"/>
+        <a:font script="Syre" typeface="Estrangelo Edessa"/>
+        <a:font script="Sora" typeface="Nirmala UI"/>
+        <a:font script="Tale" typeface="Microsoft Tai Le"/>
+        <a:font script="Talu" typeface="Microsoft New Tai Lue"/>
+        <a:font script="Tfng" typeface="Ebrima"/>
+      </a:minorFont>
+    </a:fontScheme>
+    <a:fmtScheme name="Office">
+      <a:fillStyleLst>
+        <a:solidFill>
+          <a:schemeClr val="phClr"/>
+        </a:solidFill>
+        <a:gradFill rotWithShape="1">
+          <a:gsLst>
+            <a:gs pos="0">
+              <a:schemeClr val="phClr">
+                <a:lumMod val="110000"/>
+                <a:satMod val="105000"/>
+                <a:tint val="67000"/>
+              </a:schemeClr>
+            </a:gs>
+            <a:gs pos="50000">
+              <a:schemeClr val="phClr">
+                <a:lumMod val="105000"/>
+                <a:satMod val="103000"/>
+                <a:tint val="73000"/>
+              </a:schemeClr>
+            </a:gs>
+            <a:gs pos="100000">
+              <a:schemeClr val="phClr">
+                <a:lumMod val="105000"/>
+                <a:satMod val="109000"/>
+                <a:tint val="81000"/>
+              </a:schemeClr>
+            </a:gs>
+          </a:gsLst>
+          <a:lin ang="5400000" scaled="0"/>
+        </a:gradFill>
+        <a:gradFill rotWithShape="1">
+          <a:gsLst>
+            <a:gs pos="0">
+              <a:schemeClr val="phClr">
+                <a:satMod val="103000"/>
+                <a:lumMod val="102000"/>
+                <a:tint val="94000"/>
+              </a:schemeClr>
+            </a:gs>
+            <a:gs pos="50000">
+              <a:schemeClr val="phClr">
+                <a:satMod val="110000"/>
+                <a:lumMod val="100000"/>
+                <a:shade val="100000"/>
+              </a:schemeClr>
+            </a:gs>
+            <a:gs pos="100000">
+              <a:schemeClr val="phClr">
+                <a:lumMod val="99000"/>
+                <a:satMod val="120000"/>
+                <a:shade val="78000"/>
+              </a:schemeClr>
+            </a:gs>
+          </a:gsLst>
+          <a:lin ang="5400000" scaled="0"/>
+        </a:gradFill>
+      </a:fillStyleLst>
+      <a:lnStyleLst>
+        <a:ln w="12700" cap="flat" cmpd="sng" algn="ctr">
+          <a:solidFill>
+            <a:schemeClr val="phClr"/>
+          </a:solidFill>
+          <a:prstDash val="solid"/>
+          <a:miter lim="800000"/>
+        </a:ln>
+        <a:ln w="19050" cap="flat" cmpd="sng" algn="ctr">
+          <a:solidFill>
+            <a:schemeClr val="phClr"/>
+          </a:solidFill>
+          <a:prstDash val="solid"/>
+          <a:miter lim="800000"/>
+        </a:ln>
+        <a:ln w="25400" cap="flat" cmpd="sng" algn="ctr">
+          <a:solidFill>
+            <a:schemeClr val="phClr"/>
+          </a:solidFill>
+          <a:prstDash val="solid"/>
+          <a:miter lim="800000"/>
+        </a:ln>
+      </a:lnStyleLst>
+      <a:effectStyleLst>
+        <a:effectStyle>
+          <a:effectLst/>
+        </a:effectStyle>
+        <a:effectStyle>
+          <a:effectLst/>
+        </a:effectStyle>
+        <a:effectStyle>
+          <a:effectLst>
+            <a:outerShdw blurRad="57150" dist="19050" dir="5400000" algn="ctr" rotWithShape="0">
+              <a:srgbClr val="000000">
+                <a:alpha val="63000"/>
+              </a:srgbClr>
+            </a:outerShdw>
+          </a:effectLst>
+        </a:effectStyle>
+      </a:effectStyleLst>
+      <a:bgFillStyleLst>
+        <a:solidFill>
+          <a:schemeClr val="phClr"/>
+        </a:solidFill>
+        <a:solidFill>
+          <a:schemeClr val="phClr">
+            <a:tint val="95000"/>
+            <a:satMod val="170000"/>
+          </a:schemeClr>
+        </a:solidFill>
+        <a:gradFill rotWithShape="1">
+          <a:gsLst>
+            <a:gs pos="0">
+              <a:schemeClr val="phClr">
+                <a:tint val="93000"/>
+                <a:satMod val="150000"/>
+                <a:shade val="98000"/>
+                <a:lumMod val="102000"/>
+              </a:schemeClr>
+            </a:gs>
+            <a:gs pos="50000">
+              <a:schemeClr val="phClr">
+                <a:tint val="98000"/>
+                <a:satMod val="130000"/>
+                <a:shade val="90000"/>
+                <a:lumMod val="103000"/>
+              </a:schemeClr>
+            </a:gs>
+            <a:gs pos="100000">
+              <a:schemeClr val="phClr">
+                <a:shade val="63000"/>
+                <a:satMod val="120000"/>
+              </a:schemeClr>
+            </a:gs>
+          </a:gsLst>
+          <a:lin ang="5400000" scaled="0"/>
+        </a:gradFill>
+      </a:bgFillStyleLst>
+    </a:fmtScheme>
+  </a:themeElements>
+  <a:objectDefaults>
+    <a:lnDef>
+      <a:spPr/>
+      <a:bodyPr/>
+      <a:lstStyle/>
+      <a:style>
+        <a:lnRef idx="2">
+          <a:schemeClr val="accent1"/>
+        </a:lnRef>
+        <a:fillRef idx="0">
+          <a:schemeClr val="accent1"/>
+        </a:fillRef>
+        <a:effectRef idx="1">
+          <a:schemeClr val="accent1"/>
+        </a:effectRef>
+        <a:fontRef idx="minor">
+          <a:schemeClr val="tx1"/>
+        </a:fontRef>
+      </a:style>
+    </a:lnDef>
+  </a:objectDefaults>
+  <a:extraClrSchemeLst/>
+  <a:extLst>
+    <a:ext uri="{05A4C25C-085E-4340-85A3-A5531E510DB2}">
+      <thm15:themeFamily xmlns:thm15="http://schemas.microsoft.com/office/thememl/2012/main" name="Office Theme" id="{2E142A2C-CD16-42D6-873A-C26D2A0506FA}" vid="{1BDDFF52-6CD6-40A5-AB3C-68EB2F1E4D0A}"/>
+    </a:ext>
+  </a:extLst>
+</a:theme>
 </file>
</xml_diff>